<commit_message>
Embed advisor talk notes in presentation
</commit_message>
<xml_diff>
--- a/outputs/presentations/ascr_stage2_progress_advisor_meeting.pptx
+++ b/outputs/presentations/ascr_stage2_progress_advisor_meeting.pptx
@@ -2,27 +2,27 @@
 <file path=ppt/presentation.xml><?xml version="1.0" encoding="utf-8"?>
 <p:presentation xmlns:p="http://schemas.openxmlformats.org/presentationml/2006/main">
   <p:sldMasterIdLst>
-    <p:sldMasterId xmlns:r="http://schemas.openxmlformats.org/officeDocument/2006/relationships" id="2147483648" r:id="R55b5d2d0afcf4123"/>
+    <p:sldMasterId xmlns:r="http://schemas.openxmlformats.org/officeDocument/2006/relationships" id="2147483648" r:id="R348fc12de8ba43e8"/>
   </p:sldMasterIdLst>
   <p:notesMasterIdLst>
-    <p:notesMasterId xmlns:r="http://schemas.openxmlformats.org/officeDocument/2006/relationships" r:id="Rbec7b16eddd94f05"/>
+    <p:notesMasterId xmlns:r="http://schemas.openxmlformats.org/officeDocument/2006/relationships" r:id="Rd9f4aa8c83b841e9"/>
   </p:notesMasterIdLst>
   <p:sldIdLst>
-    <p:sldId xmlns:r="http://schemas.openxmlformats.org/officeDocument/2006/relationships" id="256" r:id="R9b20d9ffeb7a416b"/>
-    <p:sldId xmlns:r="http://schemas.openxmlformats.org/officeDocument/2006/relationships" id="257" r:id="R8b1f9ac29cb546b4"/>
-    <p:sldId xmlns:r="http://schemas.openxmlformats.org/officeDocument/2006/relationships" id="258" r:id="Rd992bbc9582a4dd1"/>
-    <p:sldId xmlns:r="http://schemas.openxmlformats.org/officeDocument/2006/relationships" id="259" r:id="R5b9b2e9b3c9c422b"/>
-    <p:sldId xmlns:r="http://schemas.openxmlformats.org/officeDocument/2006/relationships" id="260" r:id="Rffd17af2c46341db"/>
-    <p:sldId xmlns:r="http://schemas.openxmlformats.org/officeDocument/2006/relationships" id="261" r:id="Rd512e5daba8944fb"/>
-    <p:sldId xmlns:r="http://schemas.openxmlformats.org/officeDocument/2006/relationships" id="262" r:id="Re263dfd7fccc470b"/>
-    <p:sldId xmlns:r="http://schemas.openxmlformats.org/officeDocument/2006/relationships" id="263" r:id="Rd8ecfcb30ee74a26"/>
-    <p:sldId xmlns:r="http://schemas.openxmlformats.org/officeDocument/2006/relationships" id="264" r:id="R1507d3e60b054f8b"/>
-    <p:sldId xmlns:r="http://schemas.openxmlformats.org/officeDocument/2006/relationships" id="265" r:id="R420910d37f114477"/>
-    <p:sldId xmlns:r="http://schemas.openxmlformats.org/officeDocument/2006/relationships" id="266" r:id="Ra95a778ffe864aa1"/>
-    <p:sldId xmlns:r="http://schemas.openxmlformats.org/officeDocument/2006/relationships" id="267" r:id="Rdeb4824fd5a24087"/>
-    <p:sldId xmlns:r="http://schemas.openxmlformats.org/officeDocument/2006/relationships" id="268" r:id="R32f4ed7cd8b0474f"/>
-    <p:sldId xmlns:r="http://schemas.openxmlformats.org/officeDocument/2006/relationships" id="269" r:id="R171063fa09eb4fa5"/>
-    <p:sldId xmlns:r="http://schemas.openxmlformats.org/officeDocument/2006/relationships" id="270" r:id="R82e059f76a404379"/>
+    <p:sldId xmlns:r="http://schemas.openxmlformats.org/officeDocument/2006/relationships" id="256" r:id="Rcf8728f4183b414a"/>
+    <p:sldId xmlns:r="http://schemas.openxmlformats.org/officeDocument/2006/relationships" id="257" r:id="R5e5484de32bf4f69"/>
+    <p:sldId xmlns:r="http://schemas.openxmlformats.org/officeDocument/2006/relationships" id="258" r:id="R5bc830209b814e05"/>
+    <p:sldId xmlns:r="http://schemas.openxmlformats.org/officeDocument/2006/relationships" id="259" r:id="Ree52a664d6ff45ad"/>
+    <p:sldId xmlns:r="http://schemas.openxmlformats.org/officeDocument/2006/relationships" id="260" r:id="Rc9e48ab71b424dec"/>
+    <p:sldId xmlns:r="http://schemas.openxmlformats.org/officeDocument/2006/relationships" id="261" r:id="Re5aa0dc4f1ec40c6"/>
+    <p:sldId xmlns:r="http://schemas.openxmlformats.org/officeDocument/2006/relationships" id="262" r:id="R31b183f15f454f79"/>
+    <p:sldId xmlns:r="http://schemas.openxmlformats.org/officeDocument/2006/relationships" id="263" r:id="Rafe253ad29304392"/>
+    <p:sldId xmlns:r="http://schemas.openxmlformats.org/officeDocument/2006/relationships" id="264" r:id="R816df0e3de874343"/>
+    <p:sldId xmlns:r="http://schemas.openxmlformats.org/officeDocument/2006/relationships" id="265" r:id="R8a5b625c27c54eb5"/>
+    <p:sldId xmlns:r="http://schemas.openxmlformats.org/officeDocument/2006/relationships" id="266" r:id="Rd163656fdb6b4432"/>
+    <p:sldId xmlns:r="http://schemas.openxmlformats.org/officeDocument/2006/relationships" id="267" r:id="R5cb2327f1d764e9e"/>
+    <p:sldId xmlns:r="http://schemas.openxmlformats.org/officeDocument/2006/relationships" id="268" r:id="Rfdbacc3662a74bcf"/>
+    <p:sldId xmlns:r="http://schemas.openxmlformats.org/officeDocument/2006/relationships" id="269" r:id="R3841ba0c42fe448e"/>
+    <p:sldId xmlns:r="http://schemas.openxmlformats.org/officeDocument/2006/relationships" id="270" r:id="R066c97578ca6497d"/>
   </p:sldIdLst>
   <p:sldSz cx="12192000" cy="6858000"/>
   <p:notesSz cx="6858000" cy="9144000"/>
@@ -549,7 +549,21 @@
         <p:txBody>
           <a:bodyPr xmlns:a="http://schemas.openxmlformats.org/drawingml/2006/main"/>
           <a:lstStyle xmlns:a="http://schemas.openxmlformats.org/drawingml/2006/main"/>
-          <a:p xmlns:a="http://schemas.openxmlformats.org/drawingml/2006/main"/>
+          <a:p xmlns:a="http://schemas.openxmlformats.org/drawingml/2006/main">
+            <a:r>
+              <a:t>Slide 1. Title</a:t>
+            </a:r>
+          </a:p>
+          <a:p xmlns:a="http://schemas.openxmlformats.org/drawingml/2006/main">
+            <a:r>
+              <a:t/>
+            </a:r>
+          </a:p>
+          <a:p xmlns:a="http://schemas.openxmlformats.org/drawingml/2006/main">
+            <a:r>
+              <a:t>老师，这次主要汇报 ASCR 从 Stage 1 往 Stage 2 走的进展。核心不是再做一个 heuristic selector，而是把 external semantic evaluator 蒸馏成本地 student semantic localizer。</a:t>
+            </a:r>
+          </a:p>
         </p:txBody>
       </p:sp>
       <p:sp>
@@ -615,7 +629,21 @@
         <p:txBody>
           <a:bodyPr xmlns:a="http://schemas.openxmlformats.org/drawingml/2006/main"/>
           <a:lstStyle xmlns:a="http://schemas.openxmlformats.org/drawingml/2006/main"/>
-          <a:p xmlns:a="http://schemas.openxmlformats.org/drawingml/2006/main"/>
+          <a:p xmlns:a="http://schemas.openxmlformats.org/drawingml/2006/main">
+            <a:r>
+              <a:t>Slide 10. Student v0</a:t>
+            </a:r>
+          </a:p>
+          <a:p xmlns:a="http://schemas.openxmlformats.org/drawingml/2006/main">
+            <a:r>
+              <a:t/>
+            </a:r>
+          </a:p>
+          <a:p xmlns:a="http://schemas.openxmlformats.org/drawingml/2006/main">
+            <a:r>
+              <a:t>v0 是第一个真正的 student localizer baseline。它不是 cell-prior；它至少读 prompt 和 grid image。但它仍然是 shallow features，不是 neural model。它的意义是验证整个 Stage-2 pipeline 能跑通。</a:t>
+            </a:r>
+          </a:p>
         </p:txBody>
       </p:sp>
       <p:sp>
@@ -681,7 +709,21 @@
         <p:txBody>
           <a:bodyPr xmlns:a="http://schemas.openxmlformats.org/drawingml/2006/main"/>
           <a:lstStyle xmlns:a="http://schemas.openxmlformats.org/drawingml/2006/main"/>
-          <a:p xmlns:a="http://schemas.openxmlformats.org/drawingml/2006/main"/>
+          <a:p xmlns:a="http://schemas.openxmlformats.org/drawingml/2006/main">
+            <a:r>
+              <a:t>Slide 11. v0 quantitative results</a:t>
+            </a:r>
+          </a:p>
+          <a:p xmlns:a="http://schemas.openxmlformats.org/drawingml/2006/main">
+            <a:r>
+              <a:t/>
+            </a:r>
+          </a:p>
+          <a:p xmlns:a="http://schemas.openxmlformats.org/drawingml/2006/main">
+            <a:r>
+              <a:t>结果很诚实：pipeline works, but student is weak。Hit-any 只有 0.2，mean F1 只有 0.13。这说明现在不是 rerun v0，而是要 improve student data and model。</a:t>
+            </a:r>
+          </a:p>
         </p:txBody>
       </p:sp>
       <p:sp>
@@ -747,7 +789,21 @@
         <p:txBody>
           <a:bodyPr xmlns:a="http://schemas.openxmlformats.org/drawingml/2006/main"/>
           <a:lstStyle xmlns:a="http://schemas.openxmlformats.org/drawingml/2006/main"/>
-          <a:p xmlns:a="http://schemas.openxmlformats.org/drawingml/2006/main"/>
+          <a:p xmlns:a="http://schemas.openxmlformats.org/drawingml/2006/main">
+            <a:r>
+              <a:t>Slide 12. Image benchmark results</a:t>
+            </a:r>
+          </a:p>
+          <a:p xmlns:a="http://schemas.openxmlformats.org/drawingml/2006/main">
+            <a:r>
+              <a:t/>
+            </a:r>
+          </a:p>
+          <a:p xmlns:a="http://schemas.openxmlformats.org/drawingml/2006/main">
+            <a:r>
+              <a:t>In-domain 有非常小的 positive delta，Geneval 全 tie。这个结果不是失败，它说明 measurement loop 是健康的，没有明显 regression，但要看到实质提升，需要更强的 student localizer。</a:t>
+            </a:r>
+          </a:p>
         </p:txBody>
       </p:sp>
       <p:sp>
@@ -813,7 +869,21 @@
         <p:txBody>
           <a:bodyPr xmlns:a="http://schemas.openxmlformats.org/drawingml/2006/main"/>
           <a:lstStyle xmlns:a="http://schemas.openxmlformats.org/drawingml/2006/main"/>
-          <a:p xmlns:a="http://schemas.openxmlformats.org/drawingml/2006/main"/>
+          <a:p xmlns:a="http://schemas.openxmlformats.org/drawingml/2006/main">
+            <a:r>
+              <a:t>Slide 13. Engineering lessons</a:t>
+            </a:r>
+          </a:p>
+          <a:p xmlns:a="http://schemas.openxmlformats.org/drawingml/2006/main">
+            <a:r>
+              <a:t/>
+            </a:r>
+          </a:p>
+          <a:p xmlns:a="http://schemas.openxmlformats.org/drawingml/2006/main">
+            <a:r>
+              <a:t>这一步也暴露了几个关键工程问题。第一，LIMIT=16 差点截断 in-domain holdout。第二，fallback 会让 after image 变成 before image，所以必须记录 raw final candidate。第三，API judge rerun 要 overwrite and dedupe，否则会混旧结果。第四，compute node 不能继承 OFOX key。</a:t>
+            </a:r>
+          </a:p>
         </p:txBody>
       </p:sp>
       <p:sp>
@@ -879,7 +949,21 @@
         <p:txBody>
           <a:bodyPr xmlns:a="http://schemas.openxmlformats.org/drawingml/2006/main"/>
           <a:lstStyle xmlns:a="http://schemas.openxmlformats.org/drawingml/2006/main"/>
-          <a:p xmlns:a="http://schemas.openxmlformats.org/drawingml/2006/main"/>
+          <a:p xmlns:a="http://schemas.openxmlformats.org/drawingml/2006/main">
+            <a:r>
+              <a:t>Slide 14. v1 plan</a:t>
+            </a:r>
+          </a:p>
+          <a:p xmlns:a="http://schemas.openxmlformats.org/drawingml/2006/main">
+            <a:r>
+              <a:t/>
+            </a:r>
+          </a:p>
+          <a:p xmlns:a="http://schemas.openxmlformats.org/drawingml/2006/main">
+            <a:r>
+              <a:t>v1 的核心是增加 supervision。我们会让 Qwen3.7 teacher 对 v0 benchmark 产生的 before/after grid images 再做 localization，然后合并 hard64、in-domain、Geneval labels，训练 grid-localizer-v1。v1 还是 lightweight，但比 v0 有更多 image statistics 和 domain features。</a:t>
+            </a:r>
+          </a:p>
         </p:txBody>
       </p:sp>
       <p:sp>
@@ -945,7 +1029,21 @@
         <p:txBody>
           <a:bodyPr xmlns:a="http://schemas.openxmlformats.org/drawingml/2006/main"/>
           <a:lstStyle xmlns:a="http://schemas.openxmlformats.org/drawingml/2006/main"/>
-          <a:p xmlns:a="http://schemas.openxmlformats.org/drawingml/2006/main"/>
+          <a:p xmlns:a="http://schemas.openxmlformats.org/drawingml/2006/main">
+            <a:r>
+              <a:t>Slide 15. Next milestone</a:t>
+            </a:r>
+          </a:p>
+          <a:p xmlns:a="http://schemas.openxmlformats.org/drawingml/2006/main">
+            <a:r>
+              <a:t/>
+            </a:r>
+          </a:p>
+          <a:p xmlns:a="http://schemas.openxmlformats.org/drawingml/2006/main">
+            <a:r>
+              <a:t>下一步我会用同样 benchmark 比较 v1 和 v0：winner counts、mean score delta、fallback count、changed image count。如果 v1 仍然弱，那就说明 shallow localizer 不够，下一步应该进入 neural localizer 或更强 multimodal student。</a:t>
+            </a:r>
+          </a:p>
         </p:txBody>
       </p:sp>
       <p:sp>
@@ -1011,7 +1109,21 @@
         <p:txBody>
           <a:bodyPr xmlns:a="http://schemas.openxmlformats.org/drawingml/2006/main"/>
           <a:lstStyle xmlns:a="http://schemas.openxmlformats.org/drawingml/2006/main"/>
-          <a:p xmlns:a="http://schemas.openxmlformats.org/drawingml/2006/main"/>
+          <a:p xmlns:a="http://schemas.openxmlformats.org/drawingml/2006/main">
+            <a:r>
+              <a:t>Slide 2. Executive summary</a:t>
+            </a:r>
+          </a:p>
+          <a:p xmlns:a="http://schemas.openxmlformats.org/drawingml/2006/main">
+            <a:r>
+              <a:t/>
+            </a:r>
+          </a:p>
+          <a:p xmlns:a="http://schemas.openxmlformats.org/drawingml/2006/main">
+            <a:r>
+              <a:t>一句话总结：Stage 1 的 ASCR loop 已经跑通，Qwen3.7 teacher 数据也有了。现在第一个 end-to-end student localizer baseline 已经在 server 上跑过，但结果还弱，所以不是重复跑 v0，而是进入 v1 data expansion 和 stronger lightweight student。</a:t>
+            </a:r>
+          </a:p>
         </p:txBody>
       </p:sp>
       <p:sp>
@@ -1077,7 +1189,21 @@
         <p:txBody>
           <a:bodyPr xmlns:a="http://schemas.openxmlformats.org/drawingml/2006/main"/>
           <a:lstStyle xmlns:a="http://schemas.openxmlformats.org/drawingml/2006/main"/>
-          <a:p xmlns:a="http://schemas.openxmlformats.org/drawingml/2006/main"/>
+          <a:p xmlns:a="http://schemas.openxmlformats.org/drawingml/2006/main">
+            <a:r>
+              <a:t>Slide 3. Research problem</a:t>
+            </a:r>
+          </a:p>
+          <a:p xmlns:a="http://schemas.openxmlformats.org/drawingml/2006/main">
+            <a:r>
+              <a:t/>
+            </a:r>
+          </a:p>
+          <a:p xmlns:a="http://schemas.openxmlformats.org/drawingml/2006/main">
+            <a:r>
+              <a:t>原始 masked/discrete generation 主要依赖 confidence。问题是，有些区域 confidence 已经 stable，但 semantic 上仍然错，比如颜色、数量、左右关系。这就是 ASCR 要解决的 confidence-semantic inconsistency。</a:t>
+            </a:r>
+          </a:p>
         </p:txBody>
       </p:sp>
       <p:sp>
@@ -1143,7 +1269,21 @@
         <p:txBody>
           <a:bodyPr xmlns:a="http://schemas.openxmlformats.org/drawingml/2006/main"/>
           <a:lstStyle xmlns:a="http://schemas.openxmlformats.org/drawingml/2006/main"/>
-          <a:p xmlns:a="http://schemas.openxmlformats.org/drawingml/2006/main"/>
+          <a:p xmlns:a="http://schemas.openxmlformats.org/drawingml/2006/main">
+            <a:r>
+              <a:t>Slide 4. ASCR core loop</a:t>
+            </a:r>
+          </a:p>
+          <a:p xmlns:a="http://schemas.openxmlformats.org/drawingml/2006/main">
+            <a:r>
+              <a:t/>
+            </a:r>
+          </a:p>
+          <a:p xmlns:a="http://schemas.openxmlformats.org/drawingml/2006/main">
+            <a:r>
+              <a:t>ASCR 的核心是 alternating。Confidence block 继续 native denoising；Semantic block 问另一个问题：当前图像哪里和 prompt 不一致，然后只 reopen those selected token regions。</a:t>
+            </a:r>
+          </a:p>
         </p:txBody>
       </p:sp>
       <p:sp>
@@ -1209,7 +1349,21 @@
         <p:txBody>
           <a:bodyPr xmlns:a="http://schemas.openxmlformats.org/drawingml/2006/main"/>
           <a:lstStyle xmlns:a="http://schemas.openxmlformats.org/drawingml/2006/main"/>
-          <a:p xmlns:a="http://schemas.openxmlformats.org/drawingml/2006/main"/>
+          <a:p xmlns:a="http://schemas.openxmlformats.org/drawingml/2006/main">
+            <a:r>
+              <a:t>Slide 5. Stage roadmap</a:t>
+            </a:r>
+          </a:p>
+          <a:p xmlns:a="http://schemas.openxmlformats.org/drawingml/2006/main">
+            <a:r>
+              <a:t/>
+            </a:r>
+          </a:p>
+          <a:p xmlns:a="http://schemas.openxmlformats.org/drawingml/2006/main">
+            <a:r>
+              <a:t>Stage 1 是 zero-training，用 external evaluator。Stage 2 是把 evaluator/localizer 学出来。Stage 3 才是更系统地迁移到不同 masked/discrete generator。</a:t>
+            </a:r>
+          </a:p>
         </p:txBody>
       </p:sp>
       <p:sp>
@@ -1275,7 +1429,21 @@
         <p:txBody>
           <a:bodyPr xmlns:a="http://schemas.openxmlformats.org/drawingml/2006/main"/>
           <a:lstStyle xmlns:a="http://schemas.openxmlformats.org/drawingml/2006/main"/>
-          <a:p xmlns:a="http://schemas.openxmlformats.org/drawingml/2006/main"/>
+          <a:p xmlns:a="http://schemas.openxmlformats.org/drawingml/2006/main">
+            <a:r>
+              <a:t>Slide 6. Stage-1 results</a:t>
+            </a:r>
+          </a:p>
+          <a:p xmlns:a="http://schemas.openxmlformats.org/drawingml/2006/main">
+            <a:r>
+              <a:t/>
+            </a:r>
+          </a:p>
+          <a:p xmlns:a="http://schemas.openxmlformats.org/drawingml/2006/main">
+            <a:r>
+              <a:t>Stage 1 已经证明 ASCR 不只是工程结构。Lumina 上提升比较小但没有 regression，因为 base model 本身强；Show-o 上提升更明显，说明 semantic reopening 在弱一些的 generator 上空间更大。</a:t>
+            </a:r>
+          </a:p>
         </p:txBody>
       </p:sp>
       <p:sp>
@@ -1341,7 +1509,21 @@
         <p:txBody>
           <a:bodyPr xmlns:a="http://schemas.openxmlformats.org/drawingml/2006/main"/>
           <a:lstStyle xmlns:a="http://schemas.openxmlformats.org/drawingml/2006/main"/>
-          <a:p xmlns:a="http://schemas.openxmlformats.org/drawingml/2006/main"/>
+          <a:p xmlns:a="http://schemas.openxmlformats.org/drawingml/2006/main">
+            <a:r>
+              <a:t>Slide 7. What is distilled</a:t>
+            </a:r>
+          </a:p>
+          <a:p xmlns:a="http://schemas.openxmlformats.org/drawingml/2006/main">
+            <a:r>
+              <a:t/>
+            </a:r>
+          </a:p>
+          <a:p xmlns:a="http://schemas.openxmlformats.org/drawingml/2006/main">
+            <a:r>
+              <a:t>这里我特别区分两个概念。semantic localizer/evaluator 是看 prompt 和 image，判断有没有 semantic error、错在哪些 grid cells。selector 只是把 grid cells 映射成 token reopen mask。所以真正要 distill 的是 localizer/evaluator，不是 selector。</a:t>
+            </a:r>
+          </a:p>
         </p:txBody>
       </p:sp>
       <p:sp>
@@ -1407,7 +1589,21 @@
         <p:txBody>
           <a:bodyPr xmlns:a="http://schemas.openxmlformats.org/drawingml/2006/main"/>
           <a:lstStyle xmlns:a="http://schemas.openxmlformats.org/drawingml/2006/main"/>
-          <a:p xmlns:a="http://schemas.openxmlformats.org/drawingml/2006/main"/>
+          <a:p xmlns:a="http://schemas.openxmlformats.org/drawingml/2006/main">
+            <a:r>
+              <a:t>Slide 8. Before/after design</a:t>
+            </a:r>
+          </a:p>
+          <a:p xmlns:a="http://schemas.openxmlformats.org/drawingml/2006/main">
+            <a:r>
+              <a:t/>
+            </a:r>
+          </a:p>
+          <a:p xmlns:a="http://schemas.openxmlformats.org/drawingml/2006/main">
+            <a:r>
+              <a:t>before distill 是 prompt 到 generator 得到 initial image。after distill 是同一个 generator 加上 student localizer，再经过 existing GridSemanticReopeningSelector 和 ASCR loop，最终得到 revised image。这里不是固定 reopen 一次，而是 loop 自己决定，最多到 max_iterations。</a:t>
+            </a:r>
+          </a:p>
         </p:txBody>
       </p:sp>
       <p:sp>
@@ -1473,7 +1669,21 @@
         <p:txBody>
           <a:bodyPr xmlns:a="http://schemas.openxmlformats.org/drawingml/2006/main"/>
           <a:lstStyle xmlns:a="http://schemas.openxmlformats.org/drawingml/2006/main"/>
-          <a:p xmlns:a="http://schemas.openxmlformats.org/drawingml/2006/main"/>
+          <a:p xmlns:a="http://schemas.openxmlformats.org/drawingml/2006/main">
+            <a:r>
+              <a:t>Slide 9. Teacher data</a:t>
+            </a:r>
+          </a:p>
+          <a:p xmlns:a="http://schemas.openxmlformats.org/drawingml/2006/main">
+            <a:r>
+              <a:t/>
+            </a:r>
+          </a:p>
+          <a:p xmlns:a="http://schemas.openxmlformats.org/drawingml/2006/main">
+            <a:r>
+              <a:t>我用 Qwen3.7-plus through OFOX 做 teacher。它给两类 supervision：一个是 quality comparison，一个是 localization labels。现在 hard64 compact dataset 已经 clean 到没有 unresolved errors。</a:t>
+            </a:r>
+          </a:p>
         </p:txBody>
       </p:sp>
       <p:sp>
@@ -1539,7 +1749,7 @@
   </p:cSld>
   <p:clrMap bg1="lt1" tx1="dk1" bg2="lt2" tx2="dk2" accent1="accent1" accent2="accent2" accent3="accent3" accent4="accent4" accent5="accent5" accent6="accent6" hlink="hlink" folHlink="folHlink"/>
   <p:sldLayoutIdLst>
-    <p:sldLayoutId xmlns:r="http://schemas.openxmlformats.org/officeDocument/2006/relationships" id="2147483649" r:id="R726a989b46a744d3"/>
+    <p:sldLayoutId xmlns:r="http://schemas.openxmlformats.org/officeDocument/2006/relationships" id="2147483649" r:id="Rf79e81b7ec3e45e3"/>
   </p:sldLayoutIdLst>
   <p:txStyles>
     <p:titleStyle>
@@ -2090,7 +2300,7 @@
           <p:cNvPr id="1" name="">
             <a:extLst xmlns:a="http://schemas.openxmlformats.org/drawingml/2006/main">
               <a:ext uri="{FF2B5EF4-FFF2-40B4-BE49-F238E27FC236}">
-                <a16:creationId xmlns:a16="http://schemas.microsoft.com/office/drawing/2014/main" id="{59F7A711-E13D-45D9-BB22-0F460EAFEDF6}"/>
+                <a16:creationId xmlns:a16="http://schemas.microsoft.com/office/drawing/2014/main" id="{490F67DA-BD46-432E-B125-BB6400C312BD}"/>
               </a:ext>
             </a:extLst>
           </p:cNvPr>
@@ -2123,7 +2333,7 @@
           <p:cNvPr id="2" name="">
             <a:extLst xmlns:a="http://schemas.openxmlformats.org/drawingml/2006/main">
               <a:ext uri="{FF2B5EF4-FFF2-40B4-BE49-F238E27FC236}">
-                <a16:creationId xmlns:a16="http://schemas.microsoft.com/office/drawing/2014/main" id="{396A6D25-F686-4628-8477-15999A64B532}"/>
+                <a16:creationId xmlns:a16="http://schemas.microsoft.com/office/drawing/2014/main" id="{B88B7811-C0F6-4EEE-BE65-C2BE9C969DF7}"/>
               </a:ext>
             </a:extLst>
           </p:cNvPr>
@@ -2154,7 +2364,7 @@
           <p:cNvPr id="3" name="">
             <a:extLst xmlns:a="http://schemas.openxmlformats.org/drawingml/2006/main">
               <a:ext uri="{FF2B5EF4-FFF2-40B4-BE49-F238E27FC236}">
-                <a16:creationId xmlns:a16="http://schemas.microsoft.com/office/drawing/2014/main" id="{D6742DA8-9972-4205-A172-48FF0F550B4A}"/>
+                <a16:creationId xmlns:a16="http://schemas.microsoft.com/office/drawing/2014/main" id="{6198379E-F182-43AF-990D-E0CAD2AD308B}"/>
               </a:ext>
             </a:extLst>
           </p:cNvPr>
@@ -2185,7 +2395,7 @@
           <p:cNvPr id="4" name="">
             <a:extLst xmlns:a="http://schemas.openxmlformats.org/drawingml/2006/main">
               <a:ext uri="{FF2B5EF4-FFF2-40B4-BE49-F238E27FC236}">
-                <a16:creationId xmlns:a16="http://schemas.microsoft.com/office/drawing/2014/main" id="{CF7EC690-06BA-4917-9618-3ECCF17403B3}"/>
+                <a16:creationId xmlns:a16="http://schemas.microsoft.com/office/drawing/2014/main" id="{D5949DFA-D909-432B-A291-C7F5D7CA3FBA}"/>
               </a:ext>
             </a:extLst>
           </p:cNvPr>
@@ -2241,7 +2451,7 @@
           <p:cNvPr id="5" name="">
             <a:extLst xmlns:a="http://schemas.openxmlformats.org/drawingml/2006/main">
               <a:ext uri="{FF2B5EF4-FFF2-40B4-BE49-F238E27FC236}">
-                <a16:creationId xmlns:a16="http://schemas.microsoft.com/office/drawing/2014/main" id="{9805E31E-5408-4BAE-85D7-DBF908BE4A2A}"/>
+                <a16:creationId xmlns:a16="http://schemas.microsoft.com/office/drawing/2014/main" id="{7440A52C-045D-4B14-A74D-D282FD1CF624}"/>
               </a:ext>
             </a:extLst>
           </p:cNvPr>
@@ -2297,7 +2507,7 @@
           <p:cNvPr id="6" name="">
             <a:extLst xmlns:a="http://schemas.openxmlformats.org/drawingml/2006/main">
               <a:ext uri="{FF2B5EF4-FFF2-40B4-BE49-F238E27FC236}">
-                <a16:creationId xmlns:a16="http://schemas.microsoft.com/office/drawing/2014/main" id="{07D0C911-0293-4B88-A4A9-871F49430CE7}"/>
+                <a16:creationId xmlns:a16="http://schemas.microsoft.com/office/drawing/2014/main" id="{72043441-E585-47E2-BF3F-CB85BC142F63}"/>
               </a:ext>
             </a:extLst>
           </p:cNvPr>
@@ -2353,7 +2563,7 @@
           <p:cNvPr id="7" name="">
             <a:extLst xmlns:a="http://schemas.openxmlformats.org/drawingml/2006/main">
               <a:ext uri="{FF2B5EF4-FFF2-40B4-BE49-F238E27FC236}">
-                <a16:creationId xmlns:a16="http://schemas.microsoft.com/office/drawing/2014/main" id="{172AFBE0-0D36-4DC9-AEA4-819B8CC50BF2}"/>
+                <a16:creationId xmlns:a16="http://schemas.microsoft.com/office/drawing/2014/main" id="{1C1D577D-39CF-4DE1-9312-E1FA9487BF43}"/>
               </a:ext>
             </a:extLst>
           </p:cNvPr>
@@ -2388,7 +2598,7 @@
           <p:cNvPr id="8" name="">
             <a:extLst xmlns:a="http://schemas.openxmlformats.org/drawingml/2006/main">
               <a:ext uri="{FF2B5EF4-FFF2-40B4-BE49-F238E27FC236}">
-                <a16:creationId xmlns:a16="http://schemas.microsoft.com/office/drawing/2014/main" id="{1832A17C-9E1B-46C8-A1A8-18163F4C624A}"/>
+                <a16:creationId xmlns:a16="http://schemas.microsoft.com/office/drawing/2014/main" id="{EEB879E2-8CAA-4464-80AE-E8031E5A4D42}"/>
               </a:ext>
             </a:extLst>
           </p:cNvPr>
@@ -2444,7 +2654,7 @@
           <p:cNvPr id="9" name="">
             <a:extLst xmlns:a="http://schemas.openxmlformats.org/drawingml/2006/main">
               <a:ext uri="{FF2B5EF4-FFF2-40B4-BE49-F238E27FC236}">
-                <a16:creationId xmlns:a16="http://schemas.microsoft.com/office/drawing/2014/main" id="{8780AA71-670A-425F-9833-57CF1BA22265}"/>
+                <a16:creationId xmlns:a16="http://schemas.microsoft.com/office/drawing/2014/main" id="{4825F924-EB85-4288-9C5D-38ED2BF86A99}"/>
               </a:ext>
             </a:extLst>
           </p:cNvPr>
@@ -2500,7 +2710,7 @@
           <p:cNvPr id="10" name="">
             <a:extLst xmlns:a="http://schemas.openxmlformats.org/drawingml/2006/main">
               <a:ext uri="{FF2B5EF4-FFF2-40B4-BE49-F238E27FC236}">
-                <a16:creationId xmlns:a16="http://schemas.microsoft.com/office/drawing/2014/main" id="{F00420EB-CE55-4D81-81BB-CB022CA3DFD5}"/>
+                <a16:creationId xmlns:a16="http://schemas.microsoft.com/office/drawing/2014/main" id="{F11CEEB8-126E-42AD-AD0F-15DE19466262}"/>
               </a:ext>
             </a:extLst>
           </p:cNvPr>
@@ -2533,7 +2743,7 @@
           <p:cNvPr id="11" name="">
             <a:extLst xmlns:a="http://schemas.openxmlformats.org/drawingml/2006/main">
               <a:ext uri="{FF2B5EF4-FFF2-40B4-BE49-F238E27FC236}">
-                <a16:creationId xmlns:a16="http://schemas.microsoft.com/office/drawing/2014/main" id="{AD8A1B46-178F-41CC-8089-054ACC181ED5}"/>
+                <a16:creationId xmlns:a16="http://schemas.microsoft.com/office/drawing/2014/main" id="{D8541626-3442-4647-9737-DC917F4DB405}"/>
               </a:ext>
             </a:extLst>
           </p:cNvPr>
@@ -2568,7 +2778,7 @@
           <p:cNvPr id="12" name="">
             <a:extLst xmlns:a="http://schemas.openxmlformats.org/drawingml/2006/main">
               <a:ext uri="{FF2B5EF4-FFF2-40B4-BE49-F238E27FC236}">
-                <a16:creationId xmlns:a16="http://schemas.microsoft.com/office/drawing/2014/main" id="{CBB05E6A-1966-4F4D-AC8B-594AECCFB246}"/>
+                <a16:creationId xmlns:a16="http://schemas.microsoft.com/office/drawing/2014/main" id="{59549AF6-0805-40B1-A4CC-9FD009B7F306}"/>
               </a:ext>
             </a:extLst>
           </p:cNvPr>
@@ -2624,7 +2834,7 @@
           <p:cNvPr id="13" name="">
             <a:extLst xmlns:a="http://schemas.openxmlformats.org/drawingml/2006/main">
               <a:ext uri="{FF2B5EF4-FFF2-40B4-BE49-F238E27FC236}">
-                <a16:creationId xmlns:a16="http://schemas.microsoft.com/office/drawing/2014/main" id="{EC1EC00E-AFD9-4FED-BD22-8FA3BCBE3AE1}"/>
+                <a16:creationId xmlns:a16="http://schemas.microsoft.com/office/drawing/2014/main" id="{790A7C2B-54DE-42B9-9FEE-165640F4CE7D}"/>
               </a:ext>
             </a:extLst>
           </p:cNvPr>
@@ -2680,7 +2890,7 @@
           <p:cNvPr id="14" name="">
             <a:extLst xmlns:a="http://schemas.openxmlformats.org/drawingml/2006/main">
               <a:ext uri="{FF2B5EF4-FFF2-40B4-BE49-F238E27FC236}">
-                <a16:creationId xmlns:a16="http://schemas.microsoft.com/office/drawing/2014/main" id="{54C92C54-EB9E-462E-A95F-1C85EF991BBC}"/>
+                <a16:creationId xmlns:a16="http://schemas.microsoft.com/office/drawing/2014/main" id="{DADBEE16-5848-4AA0-91F8-8E4F71B8A7EB}"/>
               </a:ext>
             </a:extLst>
           </p:cNvPr>
@@ -2713,7 +2923,7 @@
           <p:cNvPr id="15" name="">
             <a:extLst xmlns:a="http://schemas.openxmlformats.org/drawingml/2006/main">
               <a:ext uri="{FF2B5EF4-FFF2-40B4-BE49-F238E27FC236}">
-                <a16:creationId xmlns:a16="http://schemas.microsoft.com/office/drawing/2014/main" id="{B1B68BA5-FBB3-4227-A190-BF5137406178}"/>
+                <a16:creationId xmlns:a16="http://schemas.microsoft.com/office/drawing/2014/main" id="{B13B6CED-3A44-4E6A-9DC8-9E106FD8B01F}"/>
               </a:ext>
             </a:extLst>
           </p:cNvPr>
@@ -2748,7 +2958,7 @@
           <p:cNvPr id="16" name="">
             <a:extLst xmlns:a="http://schemas.openxmlformats.org/drawingml/2006/main">
               <a:ext uri="{FF2B5EF4-FFF2-40B4-BE49-F238E27FC236}">
-                <a16:creationId xmlns:a16="http://schemas.microsoft.com/office/drawing/2014/main" id="{DB73D36E-6953-4DE0-937E-6899E2517510}"/>
+                <a16:creationId xmlns:a16="http://schemas.microsoft.com/office/drawing/2014/main" id="{7F521A88-5DD8-4CB8-94B9-73A703BF2F98}"/>
               </a:ext>
             </a:extLst>
           </p:cNvPr>
@@ -2804,7 +3014,7 @@
           <p:cNvPr id="17" name="">
             <a:extLst xmlns:a="http://schemas.openxmlformats.org/drawingml/2006/main">
               <a:ext uri="{FF2B5EF4-FFF2-40B4-BE49-F238E27FC236}">
-                <a16:creationId xmlns:a16="http://schemas.microsoft.com/office/drawing/2014/main" id="{82263D02-2077-4993-9348-1EFD9D575E48}"/>
+                <a16:creationId xmlns:a16="http://schemas.microsoft.com/office/drawing/2014/main" id="{2727458A-9994-4186-9C0C-813F01196DC4}"/>
               </a:ext>
             </a:extLst>
           </p:cNvPr>
@@ -2860,7 +3070,7 @@
           <p:cNvPr id="18" name="">
             <a:extLst xmlns:a="http://schemas.openxmlformats.org/drawingml/2006/main">
               <a:ext uri="{FF2B5EF4-FFF2-40B4-BE49-F238E27FC236}">
-                <a16:creationId xmlns:a16="http://schemas.microsoft.com/office/drawing/2014/main" id="{99E52ADC-CCB3-4FEF-896C-AC5D794DF116}"/>
+                <a16:creationId xmlns:a16="http://schemas.microsoft.com/office/drawing/2014/main" id="{12E7955B-EB9E-4C95-AB60-036D51F4BEE7}"/>
               </a:ext>
             </a:extLst>
           </p:cNvPr>
@@ -2916,7 +3126,7 @@
           <p:cNvPr id="19" name="">
             <a:extLst xmlns:a="http://schemas.openxmlformats.org/drawingml/2006/main">
               <a:ext uri="{FF2B5EF4-FFF2-40B4-BE49-F238E27FC236}">
-                <a16:creationId xmlns:a16="http://schemas.microsoft.com/office/drawing/2014/main" id="{EB266778-E3B7-4657-A35C-3020A96B1FCD}"/>
+                <a16:creationId xmlns:a16="http://schemas.microsoft.com/office/drawing/2014/main" id="{F4847205-1D72-4F1B-9B75-0BF11DE86788}"/>
               </a:ext>
             </a:extLst>
           </p:cNvPr>
@@ -2972,7 +3182,7 @@
           <p:cNvPr id="20" name="">
             <a:extLst xmlns:a="http://schemas.openxmlformats.org/drawingml/2006/main">
               <a:ext uri="{FF2B5EF4-FFF2-40B4-BE49-F238E27FC236}">
-                <a16:creationId xmlns:a16="http://schemas.microsoft.com/office/drawing/2014/main" id="{9E674025-5E59-4034-A842-558E2110C9DE}"/>
+                <a16:creationId xmlns:a16="http://schemas.microsoft.com/office/drawing/2014/main" id="{685EBD0E-D1AC-4B67-B5CA-20901B829458}"/>
               </a:ext>
             </a:extLst>
           </p:cNvPr>
@@ -3026,7 +3236,7 @@
     </p:spTree>
     <p:extLst>
       <p:ext uri="{BB962C8B-B14F-4D97-AF65-F5344CB8AC3E}">
-        <p14:creationId xmlns:p14="http://schemas.microsoft.com/office/powerpoint/2010/main" val="1890572338"/>
+        <p14:creationId xmlns:p14="http://schemas.microsoft.com/office/powerpoint/2010/main" val="471702466"/>
       </p:ext>
     </p:extLst>
   </p:cSld>
@@ -3057,7 +3267,7 @@
           <p:cNvPr id="1" name="">
             <a:extLst xmlns:a="http://schemas.openxmlformats.org/drawingml/2006/main">
               <a:ext uri="{FF2B5EF4-FFF2-40B4-BE49-F238E27FC236}">
-                <a16:creationId xmlns:a16="http://schemas.microsoft.com/office/drawing/2014/main" id="{16DCB185-2DA9-4B07-8312-01374000DE92}"/>
+                <a16:creationId xmlns:a16="http://schemas.microsoft.com/office/drawing/2014/main" id="{B806B5EB-D4B9-4577-A948-0B3EA1C5EF96}"/>
               </a:ext>
             </a:extLst>
           </p:cNvPr>
@@ -3090,7 +3300,7 @@
           <p:cNvPr id="2" name="">
             <a:extLst xmlns:a="http://schemas.openxmlformats.org/drawingml/2006/main">
               <a:ext uri="{FF2B5EF4-FFF2-40B4-BE49-F238E27FC236}">
-                <a16:creationId xmlns:a16="http://schemas.microsoft.com/office/drawing/2014/main" id="{ED282247-B7D0-4FAA-8121-1F730CE0AA44}"/>
+                <a16:creationId xmlns:a16="http://schemas.microsoft.com/office/drawing/2014/main" id="{7EABA707-798F-4B80-B385-BB9A83EC5F84}"/>
               </a:ext>
             </a:extLst>
           </p:cNvPr>
@@ -3146,7 +3356,7 @@
           <p:cNvPr id="3" name="">
             <a:extLst xmlns:a="http://schemas.openxmlformats.org/drawingml/2006/main">
               <a:ext uri="{FF2B5EF4-FFF2-40B4-BE49-F238E27FC236}">
-                <a16:creationId xmlns:a16="http://schemas.microsoft.com/office/drawing/2014/main" id="{2F920270-9816-49DA-95D7-29055FC11B46}"/>
+                <a16:creationId xmlns:a16="http://schemas.microsoft.com/office/drawing/2014/main" id="{D0761461-4832-4C6C-B556-5520C6E443FF}"/>
               </a:ext>
             </a:extLst>
           </p:cNvPr>
@@ -3202,7 +3412,7 @@
           <p:cNvPr id="4" name="">
             <a:extLst xmlns:a="http://schemas.openxmlformats.org/drawingml/2006/main">
               <a:ext uri="{FF2B5EF4-FFF2-40B4-BE49-F238E27FC236}">
-                <a16:creationId xmlns:a16="http://schemas.microsoft.com/office/drawing/2014/main" id="{4BA51E14-CC70-4898-8F7A-883FDF95C33F}"/>
+                <a16:creationId xmlns:a16="http://schemas.microsoft.com/office/drawing/2014/main" id="{3D641DC8-6946-4C4E-8DCB-A9F80D9DD25E}"/>
               </a:ext>
             </a:extLst>
           </p:cNvPr>
@@ -3258,7 +3468,7 @@
           <p:cNvPr id="5" name="">
             <a:extLst xmlns:a="http://schemas.openxmlformats.org/drawingml/2006/main">
               <a:ext uri="{FF2B5EF4-FFF2-40B4-BE49-F238E27FC236}">
-                <a16:creationId xmlns:a16="http://schemas.microsoft.com/office/drawing/2014/main" id="{115CABEC-1E26-431F-B57C-38D3315CA478}"/>
+                <a16:creationId xmlns:a16="http://schemas.microsoft.com/office/drawing/2014/main" id="{31CFD993-507B-4B12-8525-5618292763AF}"/>
               </a:ext>
             </a:extLst>
           </p:cNvPr>
@@ -3293,7 +3503,7 @@
           <p:cNvPr id="6" name="">
             <a:extLst xmlns:a="http://schemas.openxmlformats.org/drawingml/2006/main">
               <a:ext uri="{FF2B5EF4-FFF2-40B4-BE49-F238E27FC236}">
-                <a16:creationId xmlns:a16="http://schemas.microsoft.com/office/drawing/2014/main" id="{013C18CD-8DCC-4CC2-85BE-9781979DE9FE}"/>
+                <a16:creationId xmlns:a16="http://schemas.microsoft.com/office/drawing/2014/main" id="{DF0E7B0A-D3C8-4A8F-A3F8-AA2F1D4AF584}"/>
               </a:ext>
             </a:extLst>
           </p:cNvPr>
@@ -3349,7 +3559,7 @@
           <p:cNvPr id="7" name="">
             <a:extLst xmlns:a="http://schemas.openxmlformats.org/drawingml/2006/main">
               <a:ext uri="{FF2B5EF4-FFF2-40B4-BE49-F238E27FC236}">
-                <a16:creationId xmlns:a16="http://schemas.microsoft.com/office/drawing/2014/main" id="{8642A2B5-0144-4032-8829-6877386DE59E}"/>
+                <a16:creationId xmlns:a16="http://schemas.microsoft.com/office/drawing/2014/main" id="{3BB23F22-1E30-457D-ADED-5B746DD2FDD2}"/>
               </a:ext>
             </a:extLst>
           </p:cNvPr>
@@ -3405,7 +3615,7 @@
           <p:cNvPr id="8" name="">
             <a:extLst xmlns:a="http://schemas.openxmlformats.org/drawingml/2006/main">
               <a:ext uri="{FF2B5EF4-FFF2-40B4-BE49-F238E27FC236}">
-                <a16:creationId xmlns:a16="http://schemas.microsoft.com/office/drawing/2014/main" id="{10C3B165-AAA4-4AB9-81F8-C8005F605D15}"/>
+                <a16:creationId xmlns:a16="http://schemas.microsoft.com/office/drawing/2014/main" id="{1177D6D0-F4BC-4C19-8174-2EA03E357207}"/>
               </a:ext>
             </a:extLst>
           </p:cNvPr>
@@ -3438,7 +3648,7 @@
           <p:cNvPr id="9" name="">
             <a:extLst xmlns:a="http://schemas.openxmlformats.org/drawingml/2006/main">
               <a:ext uri="{FF2B5EF4-FFF2-40B4-BE49-F238E27FC236}">
-                <a16:creationId xmlns:a16="http://schemas.microsoft.com/office/drawing/2014/main" id="{5AF74282-6DB9-461E-97EE-1ECC4C2F2D1F}"/>
+                <a16:creationId xmlns:a16="http://schemas.microsoft.com/office/drawing/2014/main" id="{D18C2867-868C-4C6C-B2CD-5C24F2E8040B}"/>
               </a:ext>
             </a:extLst>
           </p:cNvPr>
@@ -3473,7 +3683,7 @@
           <p:cNvPr id="10" name="">
             <a:extLst xmlns:a="http://schemas.openxmlformats.org/drawingml/2006/main">
               <a:ext uri="{FF2B5EF4-FFF2-40B4-BE49-F238E27FC236}">
-                <a16:creationId xmlns:a16="http://schemas.microsoft.com/office/drawing/2014/main" id="{188DCB7C-4E28-47F8-8ED4-5943D31BF4B8}"/>
+                <a16:creationId xmlns:a16="http://schemas.microsoft.com/office/drawing/2014/main" id="{D9A94295-8BC8-4216-920F-B74CC5911AA0}"/>
               </a:ext>
             </a:extLst>
           </p:cNvPr>
@@ -3529,7 +3739,7 @@
           <p:cNvPr id="11" name="">
             <a:extLst xmlns:a="http://schemas.openxmlformats.org/drawingml/2006/main">
               <a:ext uri="{FF2B5EF4-FFF2-40B4-BE49-F238E27FC236}">
-                <a16:creationId xmlns:a16="http://schemas.microsoft.com/office/drawing/2014/main" id="{6EB23086-4A56-4802-8E39-D54AB0FF9ED1}"/>
+                <a16:creationId xmlns:a16="http://schemas.microsoft.com/office/drawing/2014/main" id="{425E0832-6BC4-42F8-B77D-7C2DE43B49AB}"/>
               </a:ext>
             </a:extLst>
           </p:cNvPr>
@@ -3585,7 +3795,7 @@
           <p:cNvPr id="12" name="">
             <a:extLst xmlns:a="http://schemas.openxmlformats.org/drawingml/2006/main">
               <a:ext uri="{FF2B5EF4-FFF2-40B4-BE49-F238E27FC236}">
-                <a16:creationId xmlns:a16="http://schemas.microsoft.com/office/drawing/2014/main" id="{F519F5CA-1CA1-4C18-85C7-1DE702501E38}"/>
+                <a16:creationId xmlns:a16="http://schemas.microsoft.com/office/drawing/2014/main" id="{8EE46685-0131-4C09-B44E-F46733328378}"/>
               </a:ext>
             </a:extLst>
           </p:cNvPr>
@@ -3618,7 +3828,7 @@
           <p:cNvPr id="13" name="">
             <a:extLst xmlns:a="http://schemas.openxmlformats.org/drawingml/2006/main">
               <a:ext uri="{FF2B5EF4-FFF2-40B4-BE49-F238E27FC236}">
-                <a16:creationId xmlns:a16="http://schemas.microsoft.com/office/drawing/2014/main" id="{BD7FDED9-99CD-4D2C-8CAC-52763E79127D}"/>
+                <a16:creationId xmlns:a16="http://schemas.microsoft.com/office/drawing/2014/main" id="{D4936679-EABA-4366-ABFB-BA41A2D4E2B3}"/>
               </a:ext>
             </a:extLst>
           </p:cNvPr>
@@ -3653,7 +3863,7 @@
           <p:cNvPr id="14" name="">
             <a:extLst xmlns:a="http://schemas.openxmlformats.org/drawingml/2006/main">
               <a:ext uri="{FF2B5EF4-FFF2-40B4-BE49-F238E27FC236}">
-                <a16:creationId xmlns:a16="http://schemas.microsoft.com/office/drawing/2014/main" id="{D8148FDA-9B9C-4D3D-9AE0-1F61DECE1FF1}"/>
+                <a16:creationId xmlns:a16="http://schemas.microsoft.com/office/drawing/2014/main" id="{B9679B6B-F060-4F57-BDCD-160CBC677353}"/>
               </a:ext>
             </a:extLst>
           </p:cNvPr>
@@ -3709,7 +3919,7 @@
           <p:cNvPr id="15" name="">
             <a:extLst xmlns:a="http://schemas.openxmlformats.org/drawingml/2006/main">
               <a:ext uri="{FF2B5EF4-FFF2-40B4-BE49-F238E27FC236}">
-                <a16:creationId xmlns:a16="http://schemas.microsoft.com/office/drawing/2014/main" id="{FA922D90-133E-42B3-8B11-72FDCA53ADBB}"/>
+                <a16:creationId xmlns:a16="http://schemas.microsoft.com/office/drawing/2014/main" id="{9DC7C11A-D9EC-4F26-BCA8-13BB637D95C9}"/>
               </a:ext>
             </a:extLst>
           </p:cNvPr>
@@ -3765,7 +3975,7 @@
           <p:cNvPr id="16" name="">
             <a:extLst xmlns:a="http://schemas.openxmlformats.org/drawingml/2006/main">
               <a:ext uri="{FF2B5EF4-FFF2-40B4-BE49-F238E27FC236}">
-                <a16:creationId xmlns:a16="http://schemas.microsoft.com/office/drawing/2014/main" id="{CA7ABCAB-82CD-45CD-BE4F-E5E8B438B9EF}"/>
+                <a16:creationId xmlns:a16="http://schemas.microsoft.com/office/drawing/2014/main" id="{8763AAD2-B37A-44F9-BA71-DDF61B9853D4}"/>
               </a:ext>
             </a:extLst>
           </p:cNvPr>
@@ -3798,7 +4008,7 @@
           <p:cNvPr id="17" name="">
             <a:extLst xmlns:a="http://schemas.openxmlformats.org/drawingml/2006/main">
               <a:ext uri="{FF2B5EF4-FFF2-40B4-BE49-F238E27FC236}">
-                <a16:creationId xmlns:a16="http://schemas.microsoft.com/office/drawing/2014/main" id="{E957AD48-53F1-4901-8938-52553614A3E5}"/>
+                <a16:creationId xmlns:a16="http://schemas.microsoft.com/office/drawing/2014/main" id="{C6A3B4BD-3E39-4FF4-90BE-49D78D7DFC3B}"/>
               </a:ext>
             </a:extLst>
           </p:cNvPr>
@@ -3833,7 +4043,7 @@
           <p:cNvPr id="18" name="">
             <a:extLst xmlns:a="http://schemas.openxmlformats.org/drawingml/2006/main">
               <a:ext uri="{FF2B5EF4-FFF2-40B4-BE49-F238E27FC236}">
-                <a16:creationId xmlns:a16="http://schemas.microsoft.com/office/drawing/2014/main" id="{15233BAD-49A2-49BE-8451-87FF7864DECE}"/>
+                <a16:creationId xmlns:a16="http://schemas.microsoft.com/office/drawing/2014/main" id="{41EAE75E-CA1B-45FA-8253-8B7A6C941C7F}"/>
               </a:ext>
             </a:extLst>
           </p:cNvPr>
@@ -3889,7 +4099,7 @@
           <p:cNvPr id="19" name="">
             <a:extLst xmlns:a="http://schemas.openxmlformats.org/drawingml/2006/main">
               <a:ext uri="{FF2B5EF4-FFF2-40B4-BE49-F238E27FC236}">
-                <a16:creationId xmlns:a16="http://schemas.microsoft.com/office/drawing/2014/main" id="{BE356E8D-18BC-4751-BEF9-F9185F05EB37}"/>
+                <a16:creationId xmlns:a16="http://schemas.microsoft.com/office/drawing/2014/main" id="{D9A0ACAD-8315-4ED5-953D-43CB036D9E86}"/>
               </a:ext>
             </a:extLst>
           </p:cNvPr>
@@ -3945,7 +4155,7 @@
           <p:cNvPr id="20" name="">
             <a:extLst xmlns:a="http://schemas.openxmlformats.org/drawingml/2006/main">
               <a:ext uri="{FF2B5EF4-FFF2-40B4-BE49-F238E27FC236}">
-                <a16:creationId xmlns:a16="http://schemas.microsoft.com/office/drawing/2014/main" id="{ACF98DFC-E5C7-4CE0-B694-D615F769C2CB}"/>
+                <a16:creationId xmlns:a16="http://schemas.microsoft.com/office/drawing/2014/main" id="{BA65E72F-1F9B-4446-A6B9-C7B57B9BDAC2}"/>
               </a:ext>
             </a:extLst>
           </p:cNvPr>
@@ -3978,7 +4188,7 @@
           <p:cNvPr id="21" name="">
             <a:extLst xmlns:a="http://schemas.openxmlformats.org/drawingml/2006/main">
               <a:ext uri="{FF2B5EF4-FFF2-40B4-BE49-F238E27FC236}">
-                <a16:creationId xmlns:a16="http://schemas.microsoft.com/office/drawing/2014/main" id="{25D6C86C-F99B-4A5C-ADD1-C7B91923CF49}"/>
+                <a16:creationId xmlns:a16="http://schemas.microsoft.com/office/drawing/2014/main" id="{342C2748-1378-4F73-BFE6-8394204F21B0}"/>
               </a:ext>
             </a:extLst>
           </p:cNvPr>
@@ -4034,7 +4244,7 @@
           <p:cNvPr id="22" name="">
             <a:extLst xmlns:a="http://schemas.openxmlformats.org/drawingml/2006/main">
               <a:ext uri="{FF2B5EF4-FFF2-40B4-BE49-F238E27FC236}">
-                <a16:creationId xmlns:a16="http://schemas.microsoft.com/office/drawing/2014/main" id="{500061D1-414C-44DD-B65E-60138934C9FC}"/>
+                <a16:creationId xmlns:a16="http://schemas.microsoft.com/office/drawing/2014/main" id="{B2EC288F-8162-4379-A1A5-8C1E7FEFE97B}"/>
               </a:ext>
             </a:extLst>
           </p:cNvPr>
@@ -4067,7 +4277,7 @@
           <p:cNvPr id="23" name="">
             <a:extLst xmlns:a="http://schemas.openxmlformats.org/drawingml/2006/main">
               <a:ext uri="{FF2B5EF4-FFF2-40B4-BE49-F238E27FC236}">
-                <a16:creationId xmlns:a16="http://schemas.microsoft.com/office/drawing/2014/main" id="{E79C505D-DF40-422A-B144-C314BE71D061}"/>
+                <a16:creationId xmlns:a16="http://schemas.microsoft.com/office/drawing/2014/main" id="{38004B3E-3C4E-4A5F-B67B-D454186E4699}"/>
               </a:ext>
             </a:extLst>
           </p:cNvPr>
@@ -4123,7 +4333,7 @@
           <p:cNvPr id="24" name="">
             <a:extLst xmlns:a="http://schemas.openxmlformats.org/drawingml/2006/main">
               <a:ext uri="{FF2B5EF4-FFF2-40B4-BE49-F238E27FC236}">
-                <a16:creationId xmlns:a16="http://schemas.microsoft.com/office/drawing/2014/main" id="{17277F14-3433-42F0-9157-41EF4B0DD234}"/>
+                <a16:creationId xmlns:a16="http://schemas.microsoft.com/office/drawing/2014/main" id="{E2CC86A7-063D-4DD0-8881-46D68D5D7A58}"/>
               </a:ext>
             </a:extLst>
           </p:cNvPr>
@@ -4156,7 +4366,7 @@
           <p:cNvPr id="25" name="">
             <a:extLst xmlns:a="http://schemas.openxmlformats.org/drawingml/2006/main">
               <a:ext uri="{FF2B5EF4-FFF2-40B4-BE49-F238E27FC236}">
-                <a16:creationId xmlns:a16="http://schemas.microsoft.com/office/drawing/2014/main" id="{F556393F-8649-45E6-9013-5FDA7C2F8F00}"/>
+                <a16:creationId xmlns:a16="http://schemas.microsoft.com/office/drawing/2014/main" id="{F0F62F72-1E0E-43F8-A2B6-8762CF4A04F0}"/>
               </a:ext>
             </a:extLst>
           </p:cNvPr>
@@ -4212,7 +4422,7 @@
           <p:cNvPr id="26" name="">
             <a:extLst xmlns:a="http://schemas.openxmlformats.org/drawingml/2006/main">
               <a:ext uri="{FF2B5EF4-FFF2-40B4-BE49-F238E27FC236}">
-                <a16:creationId xmlns:a16="http://schemas.microsoft.com/office/drawing/2014/main" id="{E5596474-6A27-4CBF-B87F-E41A30C5D3C9}"/>
+                <a16:creationId xmlns:a16="http://schemas.microsoft.com/office/drawing/2014/main" id="{D155D3C2-4203-4AD3-8D90-E10A97FA63EC}"/>
               </a:ext>
             </a:extLst>
           </p:cNvPr>
@@ -4268,7 +4478,7 @@
           <p:cNvPr id="27" name="">
             <a:extLst xmlns:a="http://schemas.openxmlformats.org/drawingml/2006/main">
               <a:ext uri="{FF2B5EF4-FFF2-40B4-BE49-F238E27FC236}">
-                <a16:creationId xmlns:a16="http://schemas.microsoft.com/office/drawing/2014/main" id="{CA3FC5D6-E980-49FC-8BB3-87A7C490DEDB}"/>
+                <a16:creationId xmlns:a16="http://schemas.microsoft.com/office/drawing/2014/main" id="{0787E74B-7CB8-408C-BE85-3786FD07779E}"/>
               </a:ext>
             </a:extLst>
           </p:cNvPr>
@@ -4322,7 +4532,7 @@
     </p:spTree>
     <p:extLst>
       <p:ext uri="{BB962C8B-B14F-4D97-AF65-F5344CB8AC3E}">
-        <p14:creationId xmlns:p14="http://schemas.microsoft.com/office/powerpoint/2010/main" val="280072266"/>
+        <p14:creationId xmlns:p14="http://schemas.microsoft.com/office/powerpoint/2010/main" val="2056933722"/>
       </p:ext>
     </p:extLst>
   </p:cSld>
@@ -4353,7 +4563,7 @@
           <p:cNvPr id="1" name="">
             <a:extLst xmlns:a="http://schemas.openxmlformats.org/drawingml/2006/main">
               <a:ext uri="{FF2B5EF4-FFF2-40B4-BE49-F238E27FC236}">
-                <a16:creationId xmlns:a16="http://schemas.microsoft.com/office/drawing/2014/main" id="{0DD2CF1F-2E0C-430C-B3DE-5D5515AF671D}"/>
+                <a16:creationId xmlns:a16="http://schemas.microsoft.com/office/drawing/2014/main" id="{C51CD3F3-C4C2-4105-9FB3-BE09D6041D60}"/>
               </a:ext>
             </a:extLst>
           </p:cNvPr>
@@ -4386,7 +4596,7 @@
           <p:cNvPr id="2" name="">
             <a:extLst xmlns:a="http://schemas.openxmlformats.org/drawingml/2006/main">
               <a:ext uri="{FF2B5EF4-FFF2-40B4-BE49-F238E27FC236}">
-                <a16:creationId xmlns:a16="http://schemas.microsoft.com/office/drawing/2014/main" id="{94AD1EC1-46F6-49C3-BBE2-18BCDBAC77D3}"/>
+                <a16:creationId xmlns:a16="http://schemas.microsoft.com/office/drawing/2014/main" id="{6A3EB36A-96FA-4BE3-9A2D-7074AE575538}"/>
               </a:ext>
             </a:extLst>
           </p:cNvPr>
@@ -4442,7 +4652,7 @@
           <p:cNvPr id="3" name="">
             <a:extLst xmlns:a="http://schemas.openxmlformats.org/drawingml/2006/main">
               <a:ext uri="{FF2B5EF4-FFF2-40B4-BE49-F238E27FC236}">
-                <a16:creationId xmlns:a16="http://schemas.microsoft.com/office/drawing/2014/main" id="{A9AD6221-BB13-4254-A2B1-DA378DDB6686}"/>
+                <a16:creationId xmlns:a16="http://schemas.microsoft.com/office/drawing/2014/main" id="{0519CFA0-2068-400A-90E4-5E201BAC5945}"/>
               </a:ext>
             </a:extLst>
           </p:cNvPr>
@@ -4498,7 +4708,7 @@
           <p:cNvPr id="4" name="">
             <a:extLst xmlns:a="http://schemas.openxmlformats.org/drawingml/2006/main">
               <a:ext uri="{FF2B5EF4-FFF2-40B4-BE49-F238E27FC236}">
-                <a16:creationId xmlns:a16="http://schemas.microsoft.com/office/drawing/2014/main" id="{0388DA45-00A2-4E02-A962-EAD818C6D11A}"/>
+                <a16:creationId xmlns:a16="http://schemas.microsoft.com/office/drawing/2014/main" id="{9686EC8F-D712-42F4-BA3B-543B2D1E837A}"/>
               </a:ext>
             </a:extLst>
           </p:cNvPr>
@@ -4554,7 +4764,7 @@
           <p:cNvPr id="5" name="">
             <a:extLst xmlns:a="http://schemas.openxmlformats.org/drawingml/2006/main">
               <a:ext uri="{FF2B5EF4-FFF2-40B4-BE49-F238E27FC236}">
-                <a16:creationId xmlns:a16="http://schemas.microsoft.com/office/drawing/2014/main" id="{5C86C76A-01EF-443D-A7FB-EFDE1342641A}"/>
+                <a16:creationId xmlns:a16="http://schemas.microsoft.com/office/drawing/2014/main" id="{F312C6A8-5CB8-4922-9EF6-B37F7AC49550}"/>
               </a:ext>
             </a:extLst>
           </p:cNvPr>
@@ -4589,7 +4799,7 @@
           <p:cNvPr id="6" name="">
             <a:extLst xmlns:a="http://schemas.openxmlformats.org/drawingml/2006/main">
               <a:ext uri="{FF2B5EF4-FFF2-40B4-BE49-F238E27FC236}">
-                <a16:creationId xmlns:a16="http://schemas.microsoft.com/office/drawing/2014/main" id="{79497C30-DC72-43BF-82E1-CFB3B5E3667F}"/>
+                <a16:creationId xmlns:a16="http://schemas.microsoft.com/office/drawing/2014/main" id="{214AEC31-29BA-4425-8042-667FF05CEE35}"/>
               </a:ext>
             </a:extLst>
           </p:cNvPr>
@@ -4622,7 +4832,7 @@
           <p:cNvPr id="7" name="">
             <a:extLst xmlns:a="http://schemas.openxmlformats.org/drawingml/2006/main">
               <a:ext uri="{FF2B5EF4-FFF2-40B4-BE49-F238E27FC236}">
-                <a16:creationId xmlns:a16="http://schemas.microsoft.com/office/drawing/2014/main" id="{2CA26A88-1FCF-47B1-B2E2-FA39DA3F285D}"/>
+                <a16:creationId xmlns:a16="http://schemas.microsoft.com/office/drawing/2014/main" id="{084D3313-FE64-4C19-9E22-2F62F4A491A9}"/>
               </a:ext>
             </a:extLst>
           </p:cNvPr>
@@ -4678,7 +4888,7 @@
           <p:cNvPr id="8" name="">
             <a:extLst xmlns:a="http://schemas.openxmlformats.org/drawingml/2006/main">
               <a:ext uri="{FF2B5EF4-FFF2-40B4-BE49-F238E27FC236}">
-                <a16:creationId xmlns:a16="http://schemas.microsoft.com/office/drawing/2014/main" id="{C4356C9B-23A4-486B-AC25-05390FB3AD2D}"/>
+                <a16:creationId xmlns:a16="http://schemas.microsoft.com/office/drawing/2014/main" id="{468B278F-7373-45D3-9D28-5C8634EA5D83}"/>
               </a:ext>
             </a:extLst>
           </p:cNvPr>
@@ -4734,7 +4944,7 @@
           <p:cNvPr id="9" name="">
             <a:extLst xmlns:a="http://schemas.openxmlformats.org/drawingml/2006/main">
               <a:ext uri="{FF2B5EF4-FFF2-40B4-BE49-F238E27FC236}">
-                <a16:creationId xmlns:a16="http://schemas.microsoft.com/office/drawing/2014/main" id="{7C391136-E259-4BA3-96C9-C27DFF050D9D}"/>
+                <a16:creationId xmlns:a16="http://schemas.microsoft.com/office/drawing/2014/main" id="{0DEA3FA3-513C-4833-BF62-56B3A5652E1F}"/>
               </a:ext>
             </a:extLst>
           </p:cNvPr>
@@ -4790,7 +5000,7 @@
           <p:cNvPr id="10" name="">
             <a:extLst xmlns:a="http://schemas.openxmlformats.org/drawingml/2006/main">
               <a:ext uri="{FF2B5EF4-FFF2-40B4-BE49-F238E27FC236}">
-                <a16:creationId xmlns:a16="http://schemas.microsoft.com/office/drawing/2014/main" id="{DC8F1C9C-69C7-4C10-824A-84AAC3046AF3}"/>
+                <a16:creationId xmlns:a16="http://schemas.microsoft.com/office/drawing/2014/main" id="{1F66C027-2B9B-42F6-8437-3FA32870224D}"/>
               </a:ext>
             </a:extLst>
           </p:cNvPr>
@@ -4825,7 +5035,7 @@
           <p:cNvPr id="11" name="">
             <a:extLst xmlns:a="http://schemas.openxmlformats.org/drawingml/2006/main">
               <a:ext uri="{FF2B5EF4-FFF2-40B4-BE49-F238E27FC236}">
-                <a16:creationId xmlns:a16="http://schemas.microsoft.com/office/drawing/2014/main" id="{D62B1D1B-7EE8-4B19-A131-732A632B10DA}"/>
+                <a16:creationId xmlns:a16="http://schemas.microsoft.com/office/drawing/2014/main" id="{B75CDBA4-F824-4F75-BABA-EDD8EDEB9F99}"/>
               </a:ext>
             </a:extLst>
           </p:cNvPr>
@@ -4858,7 +5068,7 @@
           <p:cNvPr id="12" name="">
             <a:extLst xmlns:a="http://schemas.openxmlformats.org/drawingml/2006/main">
               <a:ext uri="{FF2B5EF4-FFF2-40B4-BE49-F238E27FC236}">
-                <a16:creationId xmlns:a16="http://schemas.microsoft.com/office/drawing/2014/main" id="{3BE2D89D-842D-4F1E-9C34-D290DB79C46D}"/>
+                <a16:creationId xmlns:a16="http://schemas.microsoft.com/office/drawing/2014/main" id="{2D6DA52D-88DD-433D-A3D8-6EBF9E281960}"/>
               </a:ext>
             </a:extLst>
           </p:cNvPr>
@@ -4914,7 +5124,7 @@
           <p:cNvPr id="13" name="">
             <a:extLst xmlns:a="http://schemas.openxmlformats.org/drawingml/2006/main">
               <a:ext uri="{FF2B5EF4-FFF2-40B4-BE49-F238E27FC236}">
-                <a16:creationId xmlns:a16="http://schemas.microsoft.com/office/drawing/2014/main" id="{C8910361-757A-47BB-B56B-E2F599AA4443}"/>
+                <a16:creationId xmlns:a16="http://schemas.microsoft.com/office/drawing/2014/main" id="{87776628-D81A-451F-9069-4EF7D83F29A6}"/>
               </a:ext>
             </a:extLst>
           </p:cNvPr>
@@ -4970,7 +5180,7 @@
           <p:cNvPr id="14" name="">
             <a:extLst xmlns:a="http://schemas.openxmlformats.org/drawingml/2006/main">
               <a:ext uri="{FF2B5EF4-FFF2-40B4-BE49-F238E27FC236}">
-                <a16:creationId xmlns:a16="http://schemas.microsoft.com/office/drawing/2014/main" id="{016B3803-2940-46E3-87C0-204D77421F0A}"/>
+                <a16:creationId xmlns:a16="http://schemas.microsoft.com/office/drawing/2014/main" id="{FE73B8D8-70C3-4002-85F2-6A18E7974F6E}"/>
               </a:ext>
             </a:extLst>
           </p:cNvPr>
@@ -5026,7 +5236,7 @@
           <p:cNvPr id="15" name="">
             <a:extLst xmlns:a="http://schemas.openxmlformats.org/drawingml/2006/main">
               <a:ext uri="{FF2B5EF4-FFF2-40B4-BE49-F238E27FC236}">
-                <a16:creationId xmlns:a16="http://schemas.microsoft.com/office/drawing/2014/main" id="{50C03CC1-36D4-4C6C-9D99-5FF7AF0940CC}"/>
+                <a16:creationId xmlns:a16="http://schemas.microsoft.com/office/drawing/2014/main" id="{0209D414-D090-4913-B280-35C80EC4CEE1}"/>
               </a:ext>
             </a:extLst>
           </p:cNvPr>
@@ -5061,7 +5271,7 @@
           <p:cNvPr id="16" name="">
             <a:extLst xmlns:a="http://schemas.openxmlformats.org/drawingml/2006/main">
               <a:ext uri="{FF2B5EF4-FFF2-40B4-BE49-F238E27FC236}">
-                <a16:creationId xmlns:a16="http://schemas.microsoft.com/office/drawing/2014/main" id="{B790153C-A621-422A-AFD4-9CB868F0EDDA}"/>
+                <a16:creationId xmlns:a16="http://schemas.microsoft.com/office/drawing/2014/main" id="{6283FB70-609A-4762-BE45-FD47EF13F21E}"/>
               </a:ext>
             </a:extLst>
           </p:cNvPr>
@@ -5094,7 +5304,7 @@
           <p:cNvPr id="17" name="">
             <a:extLst xmlns:a="http://schemas.openxmlformats.org/drawingml/2006/main">
               <a:ext uri="{FF2B5EF4-FFF2-40B4-BE49-F238E27FC236}">
-                <a16:creationId xmlns:a16="http://schemas.microsoft.com/office/drawing/2014/main" id="{76E0C417-F405-406B-AE27-C0AFE3DACBD9}"/>
+                <a16:creationId xmlns:a16="http://schemas.microsoft.com/office/drawing/2014/main" id="{1D0CEA82-450D-499E-923F-4F8DF9AC2BCB}"/>
               </a:ext>
             </a:extLst>
           </p:cNvPr>
@@ -5150,7 +5360,7 @@
           <p:cNvPr id="18" name="">
             <a:extLst xmlns:a="http://schemas.openxmlformats.org/drawingml/2006/main">
               <a:ext uri="{FF2B5EF4-FFF2-40B4-BE49-F238E27FC236}">
-                <a16:creationId xmlns:a16="http://schemas.microsoft.com/office/drawing/2014/main" id="{7301FC85-E5DB-4A7E-814A-2AE378EAE0C3}"/>
+                <a16:creationId xmlns:a16="http://schemas.microsoft.com/office/drawing/2014/main" id="{E0F9F107-53D6-4774-BB5D-E916D77E77F3}"/>
               </a:ext>
             </a:extLst>
           </p:cNvPr>
@@ -5206,7 +5416,7 @@
           <p:cNvPr id="19" name="">
             <a:extLst xmlns:a="http://schemas.openxmlformats.org/drawingml/2006/main">
               <a:ext uri="{FF2B5EF4-FFF2-40B4-BE49-F238E27FC236}">
-                <a16:creationId xmlns:a16="http://schemas.microsoft.com/office/drawing/2014/main" id="{17886F6C-93BC-4976-B5B2-7B88B76C9E29}"/>
+                <a16:creationId xmlns:a16="http://schemas.microsoft.com/office/drawing/2014/main" id="{0ED5BA3A-EF46-4B10-AA1E-B32EB90F4633}"/>
               </a:ext>
             </a:extLst>
           </p:cNvPr>
@@ -5262,7 +5472,7 @@
           <p:cNvPr id="20" name="">
             <a:extLst xmlns:a="http://schemas.openxmlformats.org/drawingml/2006/main">
               <a:ext uri="{FF2B5EF4-FFF2-40B4-BE49-F238E27FC236}">
-                <a16:creationId xmlns:a16="http://schemas.microsoft.com/office/drawing/2014/main" id="{D604C0D7-1BD5-4E23-BE04-4D7CF153F0B2}"/>
+                <a16:creationId xmlns:a16="http://schemas.microsoft.com/office/drawing/2014/main" id="{5F1E807C-55F1-4113-8F4B-AAA37C98FEDC}"/>
               </a:ext>
             </a:extLst>
           </p:cNvPr>
@@ -5297,7 +5507,7 @@
           <p:cNvPr id="21" name="">
             <a:extLst xmlns:a="http://schemas.openxmlformats.org/drawingml/2006/main">
               <a:ext uri="{FF2B5EF4-FFF2-40B4-BE49-F238E27FC236}">
-                <a16:creationId xmlns:a16="http://schemas.microsoft.com/office/drawing/2014/main" id="{ADC8FF7F-A26E-4371-A435-52E9F0BE19DE}"/>
+                <a16:creationId xmlns:a16="http://schemas.microsoft.com/office/drawing/2014/main" id="{7F133D61-06F2-4BDA-9F51-AFAEEEC5867F}"/>
               </a:ext>
             </a:extLst>
           </p:cNvPr>
@@ -5330,7 +5540,7 @@
           <p:cNvPr id="22" name="">
             <a:extLst xmlns:a="http://schemas.openxmlformats.org/drawingml/2006/main">
               <a:ext uri="{FF2B5EF4-FFF2-40B4-BE49-F238E27FC236}">
-                <a16:creationId xmlns:a16="http://schemas.microsoft.com/office/drawing/2014/main" id="{417E0C69-C763-44E4-95E9-537E4FD2D7C6}"/>
+                <a16:creationId xmlns:a16="http://schemas.microsoft.com/office/drawing/2014/main" id="{BF80F6D4-603C-43E1-802A-86ECB21852BF}"/>
               </a:ext>
             </a:extLst>
           </p:cNvPr>
@@ -5386,7 +5596,7 @@
           <p:cNvPr id="23" name="">
             <a:extLst xmlns:a="http://schemas.openxmlformats.org/drawingml/2006/main">
               <a:ext uri="{FF2B5EF4-FFF2-40B4-BE49-F238E27FC236}">
-                <a16:creationId xmlns:a16="http://schemas.microsoft.com/office/drawing/2014/main" id="{509D31B1-DAA5-411F-894D-C041614D3764}"/>
+                <a16:creationId xmlns:a16="http://schemas.microsoft.com/office/drawing/2014/main" id="{D7A4A641-D4ED-4786-BEB6-3D286192AD8E}"/>
               </a:ext>
             </a:extLst>
           </p:cNvPr>
@@ -5442,7 +5652,7 @@
           <p:cNvPr id="24" name="">
             <a:extLst xmlns:a="http://schemas.openxmlformats.org/drawingml/2006/main">
               <a:ext uri="{FF2B5EF4-FFF2-40B4-BE49-F238E27FC236}">
-                <a16:creationId xmlns:a16="http://schemas.microsoft.com/office/drawing/2014/main" id="{52BAF8BF-7808-4BD9-A12C-D3168B6083D5}"/>
+                <a16:creationId xmlns:a16="http://schemas.microsoft.com/office/drawing/2014/main" id="{AFF1049E-9DC6-45F0-92A8-81C38116ABF4}"/>
               </a:ext>
             </a:extLst>
           </p:cNvPr>
@@ -5498,7 +5708,7 @@
           <p:cNvPr id="25" name="">
             <a:extLst xmlns:a="http://schemas.openxmlformats.org/drawingml/2006/main">
               <a:ext uri="{FF2B5EF4-FFF2-40B4-BE49-F238E27FC236}">
-                <a16:creationId xmlns:a16="http://schemas.microsoft.com/office/drawing/2014/main" id="{05367B5A-DD08-4BD4-ABAC-05DA906722AB}"/>
+                <a16:creationId xmlns:a16="http://schemas.microsoft.com/office/drawing/2014/main" id="{C86EBFA7-EDD1-4C10-8A3C-AA1E77AF57BC}"/>
               </a:ext>
             </a:extLst>
           </p:cNvPr>
@@ -5533,7 +5743,7 @@
           <p:cNvPr id="26" name="">
             <a:extLst xmlns:a="http://schemas.openxmlformats.org/drawingml/2006/main">
               <a:ext uri="{FF2B5EF4-FFF2-40B4-BE49-F238E27FC236}">
-                <a16:creationId xmlns:a16="http://schemas.microsoft.com/office/drawing/2014/main" id="{775D9A30-15F7-46DF-A665-8932FBE117E6}"/>
+                <a16:creationId xmlns:a16="http://schemas.microsoft.com/office/drawing/2014/main" id="{EB98E287-9F99-469D-873B-46DF763BCC94}"/>
               </a:ext>
             </a:extLst>
           </p:cNvPr>
@@ -5589,7 +5799,7 @@
           <p:cNvPr id="27" name="">
             <a:extLst xmlns:a="http://schemas.openxmlformats.org/drawingml/2006/main">
               <a:ext uri="{FF2B5EF4-FFF2-40B4-BE49-F238E27FC236}">
-                <a16:creationId xmlns:a16="http://schemas.microsoft.com/office/drawing/2014/main" id="{D1197A5F-9E5D-4A3A-8D06-BB727FF2EFF3}"/>
+                <a16:creationId xmlns:a16="http://schemas.microsoft.com/office/drawing/2014/main" id="{1B8F1E28-5B1B-4BC4-A09B-9871ACEAE12D}"/>
               </a:ext>
             </a:extLst>
           </p:cNvPr>
@@ -5645,7 +5855,7 @@
           <p:cNvPr id="28" name="">
             <a:extLst xmlns:a="http://schemas.openxmlformats.org/drawingml/2006/main">
               <a:ext uri="{FF2B5EF4-FFF2-40B4-BE49-F238E27FC236}">
-                <a16:creationId xmlns:a16="http://schemas.microsoft.com/office/drawing/2014/main" id="{027B35DA-734E-4FCB-9199-83637E69EBEA}"/>
+                <a16:creationId xmlns:a16="http://schemas.microsoft.com/office/drawing/2014/main" id="{F3DBDBA8-F1B3-4421-800E-62873DCAAFE4}"/>
               </a:ext>
             </a:extLst>
           </p:cNvPr>
@@ -5701,7 +5911,7 @@
           <p:cNvPr id="29" name="">
             <a:extLst xmlns:a="http://schemas.openxmlformats.org/drawingml/2006/main">
               <a:ext uri="{FF2B5EF4-FFF2-40B4-BE49-F238E27FC236}">
-                <a16:creationId xmlns:a16="http://schemas.microsoft.com/office/drawing/2014/main" id="{E108D849-C856-4F50-8884-DEAB4D20DD42}"/>
+                <a16:creationId xmlns:a16="http://schemas.microsoft.com/office/drawing/2014/main" id="{A8E3A4DB-D10A-44D4-9D7E-DA247492F28A}"/>
               </a:ext>
             </a:extLst>
           </p:cNvPr>
@@ -5755,7 +5965,7 @@
     </p:spTree>
     <p:extLst>
       <p:ext uri="{BB962C8B-B14F-4D97-AF65-F5344CB8AC3E}">
-        <p14:creationId xmlns:p14="http://schemas.microsoft.com/office/powerpoint/2010/main" val="1580899806"/>
+        <p14:creationId xmlns:p14="http://schemas.microsoft.com/office/powerpoint/2010/main" val="876258501"/>
       </p:ext>
     </p:extLst>
   </p:cSld>
@@ -5786,7 +5996,7 @@
           <p:cNvPr id="1" name="">
             <a:extLst xmlns:a="http://schemas.openxmlformats.org/drawingml/2006/main">
               <a:ext uri="{FF2B5EF4-FFF2-40B4-BE49-F238E27FC236}">
-                <a16:creationId xmlns:a16="http://schemas.microsoft.com/office/drawing/2014/main" id="{B5EEBF85-6E8E-48D4-AEBA-DB3F5EA99466}"/>
+                <a16:creationId xmlns:a16="http://schemas.microsoft.com/office/drawing/2014/main" id="{389F46A8-BA2E-4290-A12F-C46CCDCEA8E2}"/>
               </a:ext>
             </a:extLst>
           </p:cNvPr>
@@ -5819,7 +6029,7 @@
           <p:cNvPr id="2" name="">
             <a:extLst xmlns:a="http://schemas.openxmlformats.org/drawingml/2006/main">
               <a:ext uri="{FF2B5EF4-FFF2-40B4-BE49-F238E27FC236}">
-                <a16:creationId xmlns:a16="http://schemas.microsoft.com/office/drawing/2014/main" id="{7A5160B4-2D11-4D94-B21A-74F48276C945}"/>
+                <a16:creationId xmlns:a16="http://schemas.microsoft.com/office/drawing/2014/main" id="{F75B7DA5-E753-46EF-855B-B591826CBB8D}"/>
               </a:ext>
             </a:extLst>
           </p:cNvPr>
@@ -5875,7 +6085,7 @@
           <p:cNvPr id="3" name="">
             <a:extLst xmlns:a="http://schemas.openxmlformats.org/drawingml/2006/main">
               <a:ext uri="{FF2B5EF4-FFF2-40B4-BE49-F238E27FC236}">
-                <a16:creationId xmlns:a16="http://schemas.microsoft.com/office/drawing/2014/main" id="{1E339C67-0EE0-4DC5-A2D0-FF217B0C87C4}"/>
+                <a16:creationId xmlns:a16="http://schemas.microsoft.com/office/drawing/2014/main" id="{6A0E5B5C-7564-443B-B2E8-FD78189BB6C4}"/>
               </a:ext>
             </a:extLst>
           </p:cNvPr>
@@ -5931,7 +6141,7 @@
           <p:cNvPr id="4" name="">
             <a:extLst xmlns:a="http://schemas.openxmlformats.org/drawingml/2006/main">
               <a:ext uri="{FF2B5EF4-FFF2-40B4-BE49-F238E27FC236}">
-                <a16:creationId xmlns:a16="http://schemas.microsoft.com/office/drawing/2014/main" id="{EC085138-5EF1-45F4-9ECE-91F8E95B6116}"/>
+                <a16:creationId xmlns:a16="http://schemas.microsoft.com/office/drawing/2014/main" id="{BC180345-0D3E-48C5-B890-2A5BCE236658}"/>
               </a:ext>
             </a:extLst>
           </p:cNvPr>
@@ -5987,7 +6197,7 @@
           <p:cNvPr id="5" name="">
             <a:extLst xmlns:a="http://schemas.openxmlformats.org/drawingml/2006/main">
               <a:ext uri="{FF2B5EF4-FFF2-40B4-BE49-F238E27FC236}">
-                <a16:creationId xmlns:a16="http://schemas.microsoft.com/office/drawing/2014/main" id="{848165A6-F647-41E6-BADC-A76E851BC93E}"/>
+                <a16:creationId xmlns:a16="http://schemas.microsoft.com/office/drawing/2014/main" id="{E9D01C68-3B74-42D5-92BB-EE11A562EF54}"/>
               </a:ext>
             </a:extLst>
           </p:cNvPr>
@@ -6022,7 +6232,7 @@
           <p:cNvPr id="6" name="">
             <a:extLst xmlns:a="http://schemas.openxmlformats.org/drawingml/2006/main">
               <a:ext uri="{FF2B5EF4-FFF2-40B4-BE49-F238E27FC236}">
-                <a16:creationId xmlns:a16="http://schemas.microsoft.com/office/drawing/2014/main" id="{47B281CB-2C54-412C-B82B-A9158254D436}"/>
+                <a16:creationId xmlns:a16="http://schemas.microsoft.com/office/drawing/2014/main" id="{7BA54C89-3815-4B81-906D-D80E6DC0BD88}"/>
               </a:ext>
             </a:extLst>
           </p:cNvPr>
@@ -6078,7 +6288,7 @@
           <p:cNvPr id="7" name="">
             <a:extLst xmlns:a="http://schemas.openxmlformats.org/drawingml/2006/main">
               <a:ext uri="{FF2B5EF4-FFF2-40B4-BE49-F238E27FC236}">
-                <a16:creationId xmlns:a16="http://schemas.microsoft.com/office/drawing/2014/main" id="{360CDF5E-9263-43B6-9055-42775F678452}"/>
+                <a16:creationId xmlns:a16="http://schemas.microsoft.com/office/drawing/2014/main" id="{ADACAEB3-6777-415F-BDB3-4EC86E034967}"/>
               </a:ext>
             </a:extLst>
           </p:cNvPr>
@@ -6113,7 +6323,7 @@
           <p:cNvPr id="8" name="">
             <a:extLst xmlns:a="http://schemas.openxmlformats.org/drawingml/2006/main">
               <a:ext uri="{FF2B5EF4-FFF2-40B4-BE49-F238E27FC236}">
-                <a16:creationId xmlns:a16="http://schemas.microsoft.com/office/drawing/2014/main" id="{880FA8CD-CB15-4075-814C-50CC6C025993}"/>
+                <a16:creationId xmlns:a16="http://schemas.microsoft.com/office/drawing/2014/main" id="{D44AC59D-4FF4-4BDA-8BB9-AA24994A503F}"/>
               </a:ext>
             </a:extLst>
           </p:cNvPr>
@@ -6146,7 +6356,7 @@
           <p:cNvPr id="9" name="">
             <a:extLst xmlns:a="http://schemas.openxmlformats.org/drawingml/2006/main">
               <a:ext uri="{FF2B5EF4-FFF2-40B4-BE49-F238E27FC236}">
-                <a16:creationId xmlns:a16="http://schemas.microsoft.com/office/drawing/2014/main" id="{7BC024BC-778A-4B10-95DD-9FCCFE0B96BE}"/>
+                <a16:creationId xmlns:a16="http://schemas.microsoft.com/office/drawing/2014/main" id="{08F3E728-5131-4415-8EB3-266C09049E41}"/>
               </a:ext>
             </a:extLst>
           </p:cNvPr>
@@ -6202,7 +6412,7 @@
           <p:cNvPr id="10" name="">
             <a:extLst xmlns:a="http://schemas.openxmlformats.org/drawingml/2006/main">
               <a:ext uri="{FF2B5EF4-FFF2-40B4-BE49-F238E27FC236}">
-                <a16:creationId xmlns:a16="http://schemas.microsoft.com/office/drawing/2014/main" id="{CEBD257B-2EEB-4CE4-9C59-AD5487CAA4F8}"/>
+                <a16:creationId xmlns:a16="http://schemas.microsoft.com/office/drawing/2014/main" id="{80839E44-452A-449B-8C81-5E19F5D369F5}"/>
               </a:ext>
             </a:extLst>
           </p:cNvPr>
@@ -6258,7 +6468,7 @@
           <p:cNvPr id="11" name="">
             <a:extLst xmlns:a="http://schemas.openxmlformats.org/drawingml/2006/main">
               <a:ext uri="{FF2B5EF4-FFF2-40B4-BE49-F238E27FC236}">
-                <a16:creationId xmlns:a16="http://schemas.microsoft.com/office/drawing/2014/main" id="{F6CDA969-4A77-4432-961A-D97377E42A1E}"/>
+                <a16:creationId xmlns:a16="http://schemas.microsoft.com/office/drawing/2014/main" id="{D26C358B-9BAA-4557-B227-31B2FC111DB1}"/>
               </a:ext>
             </a:extLst>
           </p:cNvPr>
@@ -6314,7 +6524,7 @@
           <p:cNvPr id="12" name="">
             <a:extLst xmlns:a="http://schemas.openxmlformats.org/drawingml/2006/main">
               <a:ext uri="{FF2B5EF4-FFF2-40B4-BE49-F238E27FC236}">
-                <a16:creationId xmlns:a16="http://schemas.microsoft.com/office/drawing/2014/main" id="{EF352512-AE76-4305-B524-F4F5226813A0}"/>
+                <a16:creationId xmlns:a16="http://schemas.microsoft.com/office/drawing/2014/main" id="{DCC0FCC5-25B9-44F0-8FD7-C5CF6E4D2F42}"/>
               </a:ext>
             </a:extLst>
           </p:cNvPr>
@@ -6349,7 +6559,7 @@
           <p:cNvPr id="13" name="">
             <a:extLst xmlns:a="http://schemas.openxmlformats.org/drawingml/2006/main">
               <a:ext uri="{FF2B5EF4-FFF2-40B4-BE49-F238E27FC236}">
-                <a16:creationId xmlns:a16="http://schemas.microsoft.com/office/drawing/2014/main" id="{A40F1CCA-B85D-4790-A856-8DB01C2EF513}"/>
+                <a16:creationId xmlns:a16="http://schemas.microsoft.com/office/drawing/2014/main" id="{6AEF43AA-7938-4BAC-8814-FF2468F4B9F9}"/>
               </a:ext>
             </a:extLst>
           </p:cNvPr>
@@ -6382,7 +6592,7 @@
           <p:cNvPr id="14" name="">
             <a:extLst xmlns:a="http://schemas.openxmlformats.org/drawingml/2006/main">
               <a:ext uri="{FF2B5EF4-FFF2-40B4-BE49-F238E27FC236}">
-                <a16:creationId xmlns:a16="http://schemas.microsoft.com/office/drawing/2014/main" id="{25348040-27EE-4840-B147-00889967918D}"/>
+                <a16:creationId xmlns:a16="http://schemas.microsoft.com/office/drawing/2014/main" id="{B6335076-F887-4E9D-B423-21C50E3077F2}"/>
               </a:ext>
             </a:extLst>
           </p:cNvPr>
@@ -6438,7 +6648,7 @@
           <p:cNvPr id="15" name="">
             <a:extLst xmlns:a="http://schemas.openxmlformats.org/drawingml/2006/main">
               <a:ext uri="{FF2B5EF4-FFF2-40B4-BE49-F238E27FC236}">
-                <a16:creationId xmlns:a16="http://schemas.microsoft.com/office/drawing/2014/main" id="{4069EB81-AF89-436C-A888-2186D5B96995}"/>
+                <a16:creationId xmlns:a16="http://schemas.microsoft.com/office/drawing/2014/main" id="{18496BFB-7CD5-43CE-881F-829D2CD6F6DC}"/>
               </a:ext>
             </a:extLst>
           </p:cNvPr>
@@ -6494,7 +6704,7 @@
           <p:cNvPr id="16" name="">
             <a:extLst xmlns:a="http://schemas.openxmlformats.org/drawingml/2006/main">
               <a:ext uri="{FF2B5EF4-FFF2-40B4-BE49-F238E27FC236}">
-                <a16:creationId xmlns:a16="http://schemas.microsoft.com/office/drawing/2014/main" id="{3A7845F3-5FAE-4325-8CF4-EFCD2F740A04}"/>
+                <a16:creationId xmlns:a16="http://schemas.microsoft.com/office/drawing/2014/main" id="{583BE03A-C30C-44C0-9D7C-1D0A1E620C40}"/>
               </a:ext>
             </a:extLst>
           </p:cNvPr>
@@ -6550,7 +6760,7 @@
           <p:cNvPr id="17" name="">
             <a:extLst xmlns:a="http://schemas.openxmlformats.org/drawingml/2006/main">
               <a:ext uri="{FF2B5EF4-FFF2-40B4-BE49-F238E27FC236}">
-                <a16:creationId xmlns:a16="http://schemas.microsoft.com/office/drawing/2014/main" id="{79B77152-1965-4566-82E2-E013E3938CD5}"/>
+                <a16:creationId xmlns:a16="http://schemas.microsoft.com/office/drawing/2014/main" id="{738CA6E2-DC85-4A98-8058-D7E6FA56F053}"/>
               </a:ext>
             </a:extLst>
           </p:cNvPr>
@@ -6585,7 +6795,7 @@
           <p:cNvPr id="18" name="">
             <a:extLst xmlns:a="http://schemas.openxmlformats.org/drawingml/2006/main">
               <a:ext uri="{FF2B5EF4-FFF2-40B4-BE49-F238E27FC236}">
-                <a16:creationId xmlns:a16="http://schemas.microsoft.com/office/drawing/2014/main" id="{FB5A5AE4-7C47-40A4-9BF6-0468DD6360DE}"/>
+                <a16:creationId xmlns:a16="http://schemas.microsoft.com/office/drawing/2014/main" id="{4D08B28E-9CFC-4C1E-A25F-3E4332C8C0D2}"/>
               </a:ext>
             </a:extLst>
           </p:cNvPr>
@@ -6618,7 +6828,7 @@
           <p:cNvPr id="19" name="">
             <a:extLst xmlns:a="http://schemas.openxmlformats.org/drawingml/2006/main">
               <a:ext uri="{FF2B5EF4-FFF2-40B4-BE49-F238E27FC236}">
-                <a16:creationId xmlns:a16="http://schemas.microsoft.com/office/drawing/2014/main" id="{6935529A-E9BE-4784-B144-A35692B57480}"/>
+                <a16:creationId xmlns:a16="http://schemas.microsoft.com/office/drawing/2014/main" id="{359B1EBB-0EA1-42CF-8B13-A69D7EDA489C}"/>
               </a:ext>
             </a:extLst>
           </p:cNvPr>
@@ -6674,7 +6884,7 @@
           <p:cNvPr id="20" name="">
             <a:extLst xmlns:a="http://schemas.openxmlformats.org/drawingml/2006/main">
               <a:ext uri="{FF2B5EF4-FFF2-40B4-BE49-F238E27FC236}">
-                <a16:creationId xmlns:a16="http://schemas.microsoft.com/office/drawing/2014/main" id="{2F3594B1-3D3E-41B7-B827-29EB75E55E57}"/>
+                <a16:creationId xmlns:a16="http://schemas.microsoft.com/office/drawing/2014/main" id="{55EAEB98-6871-40C2-8160-F505FA7D6EAE}"/>
               </a:ext>
             </a:extLst>
           </p:cNvPr>
@@ -6730,7 +6940,7 @@
           <p:cNvPr id="21" name="">
             <a:extLst xmlns:a="http://schemas.openxmlformats.org/drawingml/2006/main">
               <a:ext uri="{FF2B5EF4-FFF2-40B4-BE49-F238E27FC236}">
-                <a16:creationId xmlns:a16="http://schemas.microsoft.com/office/drawing/2014/main" id="{8E240640-6EAA-4621-B394-AE4C7FD63EA0}"/>
+                <a16:creationId xmlns:a16="http://schemas.microsoft.com/office/drawing/2014/main" id="{3B1F79DF-C0B3-4568-AB51-36EBFC170B97}"/>
               </a:ext>
             </a:extLst>
           </p:cNvPr>
@@ -6786,7 +6996,7 @@
           <p:cNvPr id="22" name="">
             <a:extLst xmlns:a="http://schemas.openxmlformats.org/drawingml/2006/main">
               <a:ext uri="{FF2B5EF4-FFF2-40B4-BE49-F238E27FC236}">
-                <a16:creationId xmlns:a16="http://schemas.microsoft.com/office/drawing/2014/main" id="{8069CBCF-F71F-407B-B4B8-859BB82084CB}"/>
+                <a16:creationId xmlns:a16="http://schemas.microsoft.com/office/drawing/2014/main" id="{2B668C11-3E2C-45AB-9944-C436ECA1B141}"/>
               </a:ext>
             </a:extLst>
           </p:cNvPr>
@@ -6821,7 +7031,7 @@
           <p:cNvPr id="23" name="">
             <a:extLst xmlns:a="http://schemas.openxmlformats.org/drawingml/2006/main">
               <a:ext uri="{FF2B5EF4-FFF2-40B4-BE49-F238E27FC236}">
-                <a16:creationId xmlns:a16="http://schemas.microsoft.com/office/drawing/2014/main" id="{3666E7B7-F70B-4280-A922-BAB2EAF954A8}"/>
+                <a16:creationId xmlns:a16="http://schemas.microsoft.com/office/drawing/2014/main" id="{EAE23366-97BF-4DB3-8C47-651F839BF6D3}"/>
               </a:ext>
             </a:extLst>
           </p:cNvPr>
@@ -6877,7 +7087,7 @@
           <p:cNvPr id="24" name="">
             <a:extLst xmlns:a="http://schemas.openxmlformats.org/drawingml/2006/main">
               <a:ext uri="{FF2B5EF4-FFF2-40B4-BE49-F238E27FC236}">
-                <a16:creationId xmlns:a16="http://schemas.microsoft.com/office/drawing/2014/main" id="{CAEF0DF2-98B8-4854-8FC0-366BD9FC2642}"/>
+                <a16:creationId xmlns:a16="http://schemas.microsoft.com/office/drawing/2014/main" id="{BAB0BE2F-D483-463D-8FF6-85BCC49F1DB7}"/>
               </a:ext>
             </a:extLst>
           </p:cNvPr>
@@ -6912,7 +7122,7 @@
           <p:cNvPr id="25" name="">
             <a:extLst xmlns:a="http://schemas.openxmlformats.org/drawingml/2006/main">
               <a:ext uri="{FF2B5EF4-FFF2-40B4-BE49-F238E27FC236}">
-                <a16:creationId xmlns:a16="http://schemas.microsoft.com/office/drawing/2014/main" id="{66256039-3079-4EBF-B20F-FAC0FA7EE5A6}"/>
+                <a16:creationId xmlns:a16="http://schemas.microsoft.com/office/drawing/2014/main" id="{6C14833D-A8C5-4349-BAA5-EB57D4731237}"/>
               </a:ext>
             </a:extLst>
           </p:cNvPr>
@@ -6945,7 +7155,7 @@
           <p:cNvPr id="26" name="">
             <a:extLst xmlns:a="http://schemas.openxmlformats.org/drawingml/2006/main">
               <a:ext uri="{FF2B5EF4-FFF2-40B4-BE49-F238E27FC236}">
-                <a16:creationId xmlns:a16="http://schemas.microsoft.com/office/drawing/2014/main" id="{C13DFD11-8D30-41ED-A453-0B8A2B082185}"/>
+                <a16:creationId xmlns:a16="http://schemas.microsoft.com/office/drawing/2014/main" id="{A62714DA-96DE-4039-BB02-8B11C8901BFC}"/>
               </a:ext>
             </a:extLst>
           </p:cNvPr>
@@ -7001,7 +7211,7 @@
           <p:cNvPr id="27" name="">
             <a:extLst xmlns:a="http://schemas.openxmlformats.org/drawingml/2006/main">
               <a:ext uri="{FF2B5EF4-FFF2-40B4-BE49-F238E27FC236}">
-                <a16:creationId xmlns:a16="http://schemas.microsoft.com/office/drawing/2014/main" id="{CFE1F7C6-279A-4EFB-932E-695312C485DB}"/>
+                <a16:creationId xmlns:a16="http://schemas.microsoft.com/office/drawing/2014/main" id="{721D0CAB-BB77-4519-B615-996581F198F4}"/>
               </a:ext>
             </a:extLst>
           </p:cNvPr>
@@ -7057,7 +7267,7 @@
           <p:cNvPr id="28" name="">
             <a:extLst xmlns:a="http://schemas.openxmlformats.org/drawingml/2006/main">
               <a:ext uri="{FF2B5EF4-FFF2-40B4-BE49-F238E27FC236}">
-                <a16:creationId xmlns:a16="http://schemas.microsoft.com/office/drawing/2014/main" id="{3F28A029-3220-47BD-9A05-8E0E49A07BA5}"/>
+                <a16:creationId xmlns:a16="http://schemas.microsoft.com/office/drawing/2014/main" id="{1DAF8F33-534D-45B9-8D18-064259F9A81E}"/>
               </a:ext>
             </a:extLst>
           </p:cNvPr>
@@ -7113,7 +7323,7 @@
           <p:cNvPr id="29" name="">
             <a:extLst xmlns:a="http://schemas.openxmlformats.org/drawingml/2006/main">
               <a:ext uri="{FF2B5EF4-FFF2-40B4-BE49-F238E27FC236}">
-                <a16:creationId xmlns:a16="http://schemas.microsoft.com/office/drawing/2014/main" id="{D6358C74-21EE-4B59-A9B0-02D5BD55DD60}"/>
+                <a16:creationId xmlns:a16="http://schemas.microsoft.com/office/drawing/2014/main" id="{17AB881B-CB79-487A-9886-6FB45D93F085}"/>
               </a:ext>
             </a:extLst>
           </p:cNvPr>
@@ -7148,7 +7358,7 @@
           <p:cNvPr id="30" name="">
             <a:extLst xmlns:a="http://schemas.openxmlformats.org/drawingml/2006/main">
               <a:ext uri="{FF2B5EF4-FFF2-40B4-BE49-F238E27FC236}">
-                <a16:creationId xmlns:a16="http://schemas.microsoft.com/office/drawing/2014/main" id="{A0A4E145-5542-40F5-9CC5-E9861093BA39}"/>
+                <a16:creationId xmlns:a16="http://schemas.microsoft.com/office/drawing/2014/main" id="{704E196D-E9A3-4BDD-8D33-0879B08C3F1F}"/>
               </a:ext>
             </a:extLst>
           </p:cNvPr>
@@ -7181,7 +7391,7 @@
           <p:cNvPr id="31" name="">
             <a:extLst xmlns:a="http://schemas.openxmlformats.org/drawingml/2006/main">
               <a:ext uri="{FF2B5EF4-FFF2-40B4-BE49-F238E27FC236}">
-                <a16:creationId xmlns:a16="http://schemas.microsoft.com/office/drawing/2014/main" id="{0D03B755-298A-4F68-A186-8DBDF0F6DCCA}"/>
+                <a16:creationId xmlns:a16="http://schemas.microsoft.com/office/drawing/2014/main" id="{27DC9126-2099-4B9D-8753-037491F02215}"/>
               </a:ext>
             </a:extLst>
           </p:cNvPr>
@@ -7237,7 +7447,7 @@
           <p:cNvPr id="32" name="">
             <a:extLst xmlns:a="http://schemas.openxmlformats.org/drawingml/2006/main">
               <a:ext uri="{FF2B5EF4-FFF2-40B4-BE49-F238E27FC236}">
-                <a16:creationId xmlns:a16="http://schemas.microsoft.com/office/drawing/2014/main" id="{629145B6-2275-41D6-9F6F-A3542E8D2A9E}"/>
+                <a16:creationId xmlns:a16="http://schemas.microsoft.com/office/drawing/2014/main" id="{7400C1BC-A2BA-4D0B-912A-95BAC41C3C0F}"/>
               </a:ext>
             </a:extLst>
           </p:cNvPr>
@@ -7293,7 +7503,7 @@
           <p:cNvPr id="33" name="">
             <a:extLst xmlns:a="http://schemas.openxmlformats.org/drawingml/2006/main">
               <a:ext uri="{FF2B5EF4-FFF2-40B4-BE49-F238E27FC236}">
-                <a16:creationId xmlns:a16="http://schemas.microsoft.com/office/drawing/2014/main" id="{A7BA039D-3A7A-4AF6-AA9B-477EE0FDB368}"/>
+                <a16:creationId xmlns:a16="http://schemas.microsoft.com/office/drawing/2014/main" id="{8503E77A-64AF-4D01-A9EA-1AF82AE2049D}"/>
               </a:ext>
             </a:extLst>
           </p:cNvPr>
@@ -7349,7 +7559,7 @@
           <p:cNvPr id="34" name="">
             <a:extLst xmlns:a="http://schemas.openxmlformats.org/drawingml/2006/main">
               <a:ext uri="{FF2B5EF4-FFF2-40B4-BE49-F238E27FC236}">
-                <a16:creationId xmlns:a16="http://schemas.microsoft.com/office/drawing/2014/main" id="{4AB61D54-41DF-4A44-B971-D4DD6DB44227}"/>
+                <a16:creationId xmlns:a16="http://schemas.microsoft.com/office/drawing/2014/main" id="{F2FB6F32-12D1-41D0-AF80-38D44D6EBFA9}"/>
               </a:ext>
             </a:extLst>
           </p:cNvPr>
@@ -7384,7 +7594,7 @@
           <p:cNvPr id="35" name="">
             <a:extLst xmlns:a="http://schemas.openxmlformats.org/drawingml/2006/main">
               <a:ext uri="{FF2B5EF4-FFF2-40B4-BE49-F238E27FC236}">
-                <a16:creationId xmlns:a16="http://schemas.microsoft.com/office/drawing/2014/main" id="{47CB78E2-BE6C-4811-94ED-206E279DF8D6}"/>
+                <a16:creationId xmlns:a16="http://schemas.microsoft.com/office/drawing/2014/main" id="{CCA68C48-4C2E-47DD-84D8-118CD16D2206}"/>
               </a:ext>
             </a:extLst>
           </p:cNvPr>
@@ -7417,7 +7627,7 @@
           <p:cNvPr id="36" name="">
             <a:extLst xmlns:a="http://schemas.openxmlformats.org/drawingml/2006/main">
               <a:ext uri="{FF2B5EF4-FFF2-40B4-BE49-F238E27FC236}">
-                <a16:creationId xmlns:a16="http://schemas.microsoft.com/office/drawing/2014/main" id="{671071DB-2006-4B47-B89D-4B78F400B125}"/>
+                <a16:creationId xmlns:a16="http://schemas.microsoft.com/office/drawing/2014/main" id="{BEC4313A-8B4B-46B0-AB0C-26948D4A47A6}"/>
               </a:ext>
             </a:extLst>
           </p:cNvPr>
@@ -7473,7 +7683,7 @@
           <p:cNvPr id="37" name="">
             <a:extLst xmlns:a="http://schemas.openxmlformats.org/drawingml/2006/main">
               <a:ext uri="{FF2B5EF4-FFF2-40B4-BE49-F238E27FC236}">
-                <a16:creationId xmlns:a16="http://schemas.microsoft.com/office/drawing/2014/main" id="{3031122D-D9FD-495B-AB3E-6052B1030413}"/>
+                <a16:creationId xmlns:a16="http://schemas.microsoft.com/office/drawing/2014/main" id="{0D87E45F-BA14-4FCA-A717-4EBB7D2307F6}"/>
               </a:ext>
             </a:extLst>
           </p:cNvPr>
@@ -7529,7 +7739,7 @@
           <p:cNvPr id="38" name="">
             <a:extLst xmlns:a="http://schemas.openxmlformats.org/drawingml/2006/main">
               <a:ext uri="{FF2B5EF4-FFF2-40B4-BE49-F238E27FC236}">
-                <a16:creationId xmlns:a16="http://schemas.microsoft.com/office/drawing/2014/main" id="{C55EF808-0503-4027-9A2C-E401888D084F}"/>
+                <a16:creationId xmlns:a16="http://schemas.microsoft.com/office/drawing/2014/main" id="{715F2C07-039A-4DE3-BC26-870CCFD53CE2}"/>
               </a:ext>
             </a:extLst>
           </p:cNvPr>
@@ -7585,7 +7795,7 @@
           <p:cNvPr id="39" name="">
             <a:extLst xmlns:a="http://schemas.openxmlformats.org/drawingml/2006/main">
               <a:ext uri="{FF2B5EF4-FFF2-40B4-BE49-F238E27FC236}">
-                <a16:creationId xmlns:a16="http://schemas.microsoft.com/office/drawing/2014/main" id="{A385BC6D-6B22-4954-9DDC-42789ACFC4B9}"/>
+                <a16:creationId xmlns:a16="http://schemas.microsoft.com/office/drawing/2014/main" id="{0DDBF089-2D9E-4998-84CF-AD8D71A49EFB}"/>
               </a:ext>
             </a:extLst>
           </p:cNvPr>
@@ -7641,7 +7851,7 @@
           <p:cNvPr id="40" name="">
             <a:extLst xmlns:a="http://schemas.openxmlformats.org/drawingml/2006/main">
               <a:ext uri="{FF2B5EF4-FFF2-40B4-BE49-F238E27FC236}">
-                <a16:creationId xmlns:a16="http://schemas.microsoft.com/office/drawing/2014/main" id="{3E3BF5F9-8B11-4E27-8EBB-F19052724EBE}"/>
+                <a16:creationId xmlns:a16="http://schemas.microsoft.com/office/drawing/2014/main" id="{2B6F51B0-636C-4ACA-96D0-31A1925141D2}"/>
               </a:ext>
             </a:extLst>
           </p:cNvPr>
@@ -7695,7 +7905,7 @@
     </p:spTree>
     <p:extLst>
       <p:ext uri="{BB962C8B-B14F-4D97-AF65-F5344CB8AC3E}">
-        <p14:creationId xmlns:p14="http://schemas.microsoft.com/office/powerpoint/2010/main" val="1713220944"/>
+        <p14:creationId xmlns:p14="http://schemas.microsoft.com/office/powerpoint/2010/main" val="1000289002"/>
       </p:ext>
     </p:extLst>
   </p:cSld>
@@ -7726,7 +7936,7 @@
           <p:cNvPr id="1" name="">
             <a:extLst xmlns:a="http://schemas.openxmlformats.org/drawingml/2006/main">
               <a:ext uri="{FF2B5EF4-FFF2-40B4-BE49-F238E27FC236}">
-                <a16:creationId xmlns:a16="http://schemas.microsoft.com/office/drawing/2014/main" id="{153D3DA5-135E-45C8-AC92-7E3DD0DF53C3}"/>
+                <a16:creationId xmlns:a16="http://schemas.microsoft.com/office/drawing/2014/main" id="{38F85876-7A1C-40BC-868C-69665874CBFC}"/>
               </a:ext>
             </a:extLst>
           </p:cNvPr>
@@ -7759,7 +7969,7 @@
           <p:cNvPr id="2" name="">
             <a:extLst xmlns:a="http://schemas.openxmlformats.org/drawingml/2006/main">
               <a:ext uri="{FF2B5EF4-FFF2-40B4-BE49-F238E27FC236}">
-                <a16:creationId xmlns:a16="http://schemas.microsoft.com/office/drawing/2014/main" id="{C7D2F6C4-9AA0-4F4D-987C-492341DFEDAB}"/>
+                <a16:creationId xmlns:a16="http://schemas.microsoft.com/office/drawing/2014/main" id="{25DE5111-D063-4DD1-B762-ADBD8C7F404C}"/>
               </a:ext>
             </a:extLst>
           </p:cNvPr>
@@ -7815,7 +8025,7 @@
           <p:cNvPr id="3" name="">
             <a:extLst xmlns:a="http://schemas.openxmlformats.org/drawingml/2006/main">
               <a:ext uri="{FF2B5EF4-FFF2-40B4-BE49-F238E27FC236}">
-                <a16:creationId xmlns:a16="http://schemas.microsoft.com/office/drawing/2014/main" id="{AACA9221-EFC0-4E11-A326-6FF3154B29DE}"/>
+                <a16:creationId xmlns:a16="http://schemas.microsoft.com/office/drawing/2014/main" id="{FA4A0A63-E5FF-47C8-AFCA-9DE854E882CF}"/>
               </a:ext>
             </a:extLst>
           </p:cNvPr>
@@ -7871,7 +8081,7 @@
           <p:cNvPr id="4" name="">
             <a:extLst xmlns:a="http://schemas.openxmlformats.org/drawingml/2006/main">
               <a:ext uri="{FF2B5EF4-FFF2-40B4-BE49-F238E27FC236}">
-                <a16:creationId xmlns:a16="http://schemas.microsoft.com/office/drawing/2014/main" id="{F73B3248-1210-458F-8B6A-27A0FCF79EDB}"/>
+                <a16:creationId xmlns:a16="http://schemas.microsoft.com/office/drawing/2014/main" id="{4B7711BD-8529-43BA-8CA1-FE7F68DBBBBF}"/>
               </a:ext>
             </a:extLst>
           </p:cNvPr>
@@ -7927,7 +8137,7 @@
           <p:cNvPr id="5" name="">
             <a:extLst xmlns:a="http://schemas.openxmlformats.org/drawingml/2006/main">
               <a:ext uri="{FF2B5EF4-FFF2-40B4-BE49-F238E27FC236}">
-                <a16:creationId xmlns:a16="http://schemas.microsoft.com/office/drawing/2014/main" id="{7FF0D948-965E-49FD-9D45-B7C64B9E84B5}"/>
+                <a16:creationId xmlns:a16="http://schemas.microsoft.com/office/drawing/2014/main" id="{504B62DB-6F0F-4426-9F21-0FF5B98998F7}"/>
               </a:ext>
             </a:extLst>
           </p:cNvPr>
@@ -7962,7 +8172,7 @@
           <p:cNvPr id="6" name="">
             <a:extLst xmlns:a="http://schemas.openxmlformats.org/drawingml/2006/main">
               <a:ext uri="{FF2B5EF4-FFF2-40B4-BE49-F238E27FC236}">
-                <a16:creationId xmlns:a16="http://schemas.microsoft.com/office/drawing/2014/main" id="{B4B7EA89-AA15-49B7-811E-C2A403683D68}"/>
+                <a16:creationId xmlns:a16="http://schemas.microsoft.com/office/drawing/2014/main" id="{351C0599-A744-4230-B876-778961D3E7E0}"/>
               </a:ext>
             </a:extLst>
           </p:cNvPr>
@@ -8018,7 +8228,7 @@
           <p:cNvPr id="7" name="">
             <a:extLst xmlns:a="http://schemas.openxmlformats.org/drawingml/2006/main">
               <a:ext uri="{FF2B5EF4-FFF2-40B4-BE49-F238E27FC236}">
-                <a16:creationId xmlns:a16="http://schemas.microsoft.com/office/drawing/2014/main" id="{4C822267-CE72-4CD5-BDF7-1B437F68E15D}"/>
+                <a16:creationId xmlns:a16="http://schemas.microsoft.com/office/drawing/2014/main" id="{3D69C69B-2C54-43AD-8C02-21F1D21B4972}"/>
               </a:ext>
             </a:extLst>
           </p:cNvPr>
@@ -8074,7 +8284,7 @@
           <p:cNvPr id="8" name="">
             <a:extLst xmlns:a="http://schemas.openxmlformats.org/drawingml/2006/main">
               <a:ext uri="{FF2B5EF4-FFF2-40B4-BE49-F238E27FC236}">
-                <a16:creationId xmlns:a16="http://schemas.microsoft.com/office/drawing/2014/main" id="{641CD125-D6CB-4664-9DBD-1368985FEA67}"/>
+                <a16:creationId xmlns:a16="http://schemas.microsoft.com/office/drawing/2014/main" id="{75212FBF-E6FD-4780-8F72-A69ED4EC792A}"/>
               </a:ext>
             </a:extLst>
           </p:cNvPr>
@@ -8109,7 +8319,7 @@
           <p:cNvPr id="9" name="">
             <a:extLst xmlns:a="http://schemas.openxmlformats.org/drawingml/2006/main">
               <a:ext uri="{FF2B5EF4-FFF2-40B4-BE49-F238E27FC236}">
-                <a16:creationId xmlns:a16="http://schemas.microsoft.com/office/drawing/2014/main" id="{63BE0153-D353-47CF-B340-011CCAFA1849}"/>
+                <a16:creationId xmlns:a16="http://schemas.microsoft.com/office/drawing/2014/main" id="{5732CBF2-E3FA-43E2-8438-20DCEF37AFC1}"/>
               </a:ext>
             </a:extLst>
           </p:cNvPr>
@@ -8165,7 +8375,7 @@
           <p:cNvPr id="10" name="">
             <a:extLst xmlns:a="http://schemas.openxmlformats.org/drawingml/2006/main">
               <a:ext uri="{FF2B5EF4-FFF2-40B4-BE49-F238E27FC236}">
-                <a16:creationId xmlns:a16="http://schemas.microsoft.com/office/drawing/2014/main" id="{F5E54BDB-4E02-4D21-88F2-67D058BED3BC}"/>
+                <a16:creationId xmlns:a16="http://schemas.microsoft.com/office/drawing/2014/main" id="{A6B1B143-7305-4CDD-B9B1-7BD6B61D437D}"/>
               </a:ext>
             </a:extLst>
           </p:cNvPr>
@@ -8221,7 +8431,7 @@
           <p:cNvPr id="11" name="">
             <a:extLst xmlns:a="http://schemas.openxmlformats.org/drawingml/2006/main">
               <a:ext uri="{FF2B5EF4-FFF2-40B4-BE49-F238E27FC236}">
-                <a16:creationId xmlns:a16="http://schemas.microsoft.com/office/drawing/2014/main" id="{A7C8CDBC-5982-4548-9132-7ED5972FDD7B}"/>
+                <a16:creationId xmlns:a16="http://schemas.microsoft.com/office/drawing/2014/main" id="{9A55643F-FA4A-4DE8-B88F-A5B902AB9440}"/>
               </a:ext>
             </a:extLst>
           </p:cNvPr>
@@ -8256,7 +8466,7 @@
           <p:cNvPr id="12" name="">
             <a:extLst xmlns:a="http://schemas.openxmlformats.org/drawingml/2006/main">
               <a:ext uri="{FF2B5EF4-FFF2-40B4-BE49-F238E27FC236}">
-                <a16:creationId xmlns:a16="http://schemas.microsoft.com/office/drawing/2014/main" id="{7C9159DB-E244-422B-AEA8-061E4AECDEA5}"/>
+                <a16:creationId xmlns:a16="http://schemas.microsoft.com/office/drawing/2014/main" id="{304BBFA2-4777-456E-A2CE-DC674AB1808F}"/>
               </a:ext>
             </a:extLst>
           </p:cNvPr>
@@ -8312,7 +8522,7 @@
           <p:cNvPr id="13" name="">
             <a:extLst xmlns:a="http://schemas.openxmlformats.org/drawingml/2006/main">
               <a:ext uri="{FF2B5EF4-FFF2-40B4-BE49-F238E27FC236}">
-                <a16:creationId xmlns:a16="http://schemas.microsoft.com/office/drawing/2014/main" id="{46BC522A-DB04-4DA6-8C20-A30C919C268C}"/>
+                <a16:creationId xmlns:a16="http://schemas.microsoft.com/office/drawing/2014/main" id="{34E4A0A6-4354-4433-A331-2BE1544FAFE8}"/>
               </a:ext>
             </a:extLst>
           </p:cNvPr>
@@ -8368,7 +8578,7 @@
           <p:cNvPr id="14" name="">
             <a:extLst xmlns:a="http://schemas.openxmlformats.org/drawingml/2006/main">
               <a:ext uri="{FF2B5EF4-FFF2-40B4-BE49-F238E27FC236}">
-                <a16:creationId xmlns:a16="http://schemas.microsoft.com/office/drawing/2014/main" id="{6D7D3B86-3DC0-4355-A15A-DD9377601191}"/>
+                <a16:creationId xmlns:a16="http://schemas.microsoft.com/office/drawing/2014/main" id="{006F06AF-9F15-4F81-89D1-0BEB1EA423C2}"/>
               </a:ext>
             </a:extLst>
           </p:cNvPr>
@@ -8403,7 +8613,7 @@
           <p:cNvPr id="15" name="">
             <a:extLst xmlns:a="http://schemas.openxmlformats.org/drawingml/2006/main">
               <a:ext uri="{FF2B5EF4-FFF2-40B4-BE49-F238E27FC236}">
-                <a16:creationId xmlns:a16="http://schemas.microsoft.com/office/drawing/2014/main" id="{602978BB-88BB-42B9-960F-2180AC62DFB6}"/>
+                <a16:creationId xmlns:a16="http://schemas.microsoft.com/office/drawing/2014/main" id="{77EC9683-3C55-49EE-9B24-30C251007FE5}"/>
               </a:ext>
             </a:extLst>
           </p:cNvPr>
@@ -8459,7 +8669,7 @@
           <p:cNvPr id="16" name="">
             <a:extLst xmlns:a="http://schemas.openxmlformats.org/drawingml/2006/main">
               <a:ext uri="{FF2B5EF4-FFF2-40B4-BE49-F238E27FC236}">
-                <a16:creationId xmlns:a16="http://schemas.microsoft.com/office/drawing/2014/main" id="{DF521A21-76BB-40CF-836E-2E617064C2D8}"/>
+                <a16:creationId xmlns:a16="http://schemas.microsoft.com/office/drawing/2014/main" id="{5195818D-44C8-4504-8CFF-83B659BD337D}"/>
               </a:ext>
             </a:extLst>
           </p:cNvPr>
@@ -8515,7 +8725,7 @@
           <p:cNvPr id="17" name="">
             <a:extLst xmlns:a="http://schemas.openxmlformats.org/drawingml/2006/main">
               <a:ext uri="{FF2B5EF4-FFF2-40B4-BE49-F238E27FC236}">
-                <a16:creationId xmlns:a16="http://schemas.microsoft.com/office/drawing/2014/main" id="{AA97B8DB-2A07-4C76-9C25-3C185F8FB901}"/>
+                <a16:creationId xmlns:a16="http://schemas.microsoft.com/office/drawing/2014/main" id="{5F6EDF6B-CC1B-43A8-A485-A7302F660DC3}"/>
               </a:ext>
             </a:extLst>
           </p:cNvPr>
@@ -8571,7 +8781,7 @@
           <p:cNvPr id="18" name="">
             <a:extLst xmlns:a="http://schemas.openxmlformats.org/drawingml/2006/main">
               <a:ext uri="{FF2B5EF4-FFF2-40B4-BE49-F238E27FC236}">
-                <a16:creationId xmlns:a16="http://schemas.microsoft.com/office/drawing/2014/main" id="{7E75D98E-09A1-4306-9777-2AEB5960A07A}"/>
+                <a16:creationId xmlns:a16="http://schemas.microsoft.com/office/drawing/2014/main" id="{5243358A-7182-4290-B008-86C4832A5310}"/>
               </a:ext>
             </a:extLst>
           </p:cNvPr>
@@ -8625,7 +8835,7 @@
     </p:spTree>
     <p:extLst>
       <p:ext uri="{BB962C8B-B14F-4D97-AF65-F5344CB8AC3E}">
-        <p14:creationId xmlns:p14="http://schemas.microsoft.com/office/powerpoint/2010/main" val="439833923"/>
+        <p14:creationId xmlns:p14="http://schemas.microsoft.com/office/powerpoint/2010/main" val="325185337"/>
       </p:ext>
     </p:extLst>
   </p:cSld>
@@ -8656,7 +8866,7 @@
           <p:cNvPr id="1" name="">
             <a:extLst xmlns:a="http://schemas.openxmlformats.org/drawingml/2006/main">
               <a:ext uri="{FF2B5EF4-FFF2-40B4-BE49-F238E27FC236}">
-                <a16:creationId xmlns:a16="http://schemas.microsoft.com/office/drawing/2014/main" id="{87E966B6-76A8-45F3-8817-5F4414A4FB09}"/>
+                <a16:creationId xmlns:a16="http://schemas.microsoft.com/office/drawing/2014/main" id="{F89E40F1-5D22-438D-ABDA-D3B4FA5CE576}"/>
               </a:ext>
             </a:extLst>
           </p:cNvPr>
@@ -8689,7 +8899,7 @@
           <p:cNvPr id="2" name="">
             <a:extLst xmlns:a="http://schemas.openxmlformats.org/drawingml/2006/main">
               <a:ext uri="{FF2B5EF4-FFF2-40B4-BE49-F238E27FC236}">
-                <a16:creationId xmlns:a16="http://schemas.microsoft.com/office/drawing/2014/main" id="{B93E2511-605D-4A3C-A027-25B6D00AA674}"/>
+                <a16:creationId xmlns:a16="http://schemas.microsoft.com/office/drawing/2014/main" id="{1007C66B-D38D-4886-9ADA-CBBCCDB50A0B}"/>
               </a:ext>
             </a:extLst>
           </p:cNvPr>
@@ -8745,7 +8955,7 @@
           <p:cNvPr id="3" name="">
             <a:extLst xmlns:a="http://schemas.openxmlformats.org/drawingml/2006/main">
               <a:ext uri="{FF2B5EF4-FFF2-40B4-BE49-F238E27FC236}">
-                <a16:creationId xmlns:a16="http://schemas.microsoft.com/office/drawing/2014/main" id="{29CDDE60-272A-4BF6-8C86-80466E04E5D1}"/>
+                <a16:creationId xmlns:a16="http://schemas.microsoft.com/office/drawing/2014/main" id="{97F80EF1-E8BC-4A04-9DB7-27A8D386E20A}"/>
               </a:ext>
             </a:extLst>
           </p:cNvPr>
@@ -8801,7 +9011,7 @@
           <p:cNvPr id="4" name="">
             <a:extLst xmlns:a="http://schemas.openxmlformats.org/drawingml/2006/main">
               <a:ext uri="{FF2B5EF4-FFF2-40B4-BE49-F238E27FC236}">
-                <a16:creationId xmlns:a16="http://schemas.microsoft.com/office/drawing/2014/main" id="{2B171624-1F51-4F8A-BC10-04F420DF889B}"/>
+                <a16:creationId xmlns:a16="http://schemas.microsoft.com/office/drawing/2014/main" id="{8B336FE9-3195-4F09-BDAE-8410BD39AEE3}"/>
               </a:ext>
             </a:extLst>
           </p:cNvPr>
@@ -8857,7 +9067,7 @@
           <p:cNvPr id="5" name="">
             <a:extLst xmlns:a="http://schemas.openxmlformats.org/drawingml/2006/main">
               <a:ext uri="{FF2B5EF4-FFF2-40B4-BE49-F238E27FC236}">
-                <a16:creationId xmlns:a16="http://schemas.microsoft.com/office/drawing/2014/main" id="{1ABE2BCA-7406-411B-9C80-56B03D534321}"/>
+                <a16:creationId xmlns:a16="http://schemas.microsoft.com/office/drawing/2014/main" id="{0B758C45-2930-4C84-97BF-71BC01923E98}"/>
               </a:ext>
             </a:extLst>
           </p:cNvPr>
@@ -8892,7 +9102,7 @@
           <p:cNvPr id="6" name="">
             <a:extLst xmlns:a="http://schemas.openxmlformats.org/drawingml/2006/main">
               <a:ext uri="{FF2B5EF4-FFF2-40B4-BE49-F238E27FC236}">
-                <a16:creationId xmlns:a16="http://schemas.microsoft.com/office/drawing/2014/main" id="{7C2F820D-FFD8-4BE4-B71D-DAB80146A2D1}"/>
+                <a16:creationId xmlns:a16="http://schemas.microsoft.com/office/drawing/2014/main" id="{EA9CC3E6-5644-4611-8B91-852C68D2DC45}"/>
               </a:ext>
             </a:extLst>
           </p:cNvPr>
@@ -8948,7 +9158,7 @@
           <p:cNvPr id="7" name="">
             <a:extLst xmlns:a="http://schemas.openxmlformats.org/drawingml/2006/main">
               <a:ext uri="{FF2B5EF4-FFF2-40B4-BE49-F238E27FC236}">
-                <a16:creationId xmlns:a16="http://schemas.microsoft.com/office/drawing/2014/main" id="{C1B10B91-78F7-4516-B46A-6CEEF743AA43}"/>
+                <a16:creationId xmlns:a16="http://schemas.microsoft.com/office/drawing/2014/main" id="{56CF725A-C134-42AF-904F-F40AF39911E2}"/>
               </a:ext>
             </a:extLst>
           </p:cNvPr>
@@ -9004,7 +9214,7 @@
           <p:cNvPr id="8" name="">
             <a:extLst xmlns:a="http://schemas.openxmlformats.org/drawingml/2006/main">
               <a:ext uri="{FF2B5EF4-FFF2-40B4-BE49-F238E27FC236}">
-                <a16:creationId xmlns:a16="http://schemas.microsoft.com/office/drawing/2014/main" id="{CDA3E77A-3451-417B-A5A0-72782BA9209B}"/>
+                <a16:creationId xmlns:a16="http://schemas.microsoft.com/office/drawing/2014/main" id="{B7E538E0-C582-4EC5-86EB-468BAA895138}"/>
               </a:ext>
             </a:extLst>
           </p:cNvPr>
@@ -9037,7 +9247,7 @@
           <p:cNvPr id="9" name="">
             <a:extLst xmlns:a="http://schemas.openxmlformats.org/drawingml/2006/main">
               <a:ext uri="{FF2B5EF4-FFF2-40B4-BE49-F238E27FC236}">
-                <a16:creationId xmlns:a16="http://schemas.microsoft.com/office/drawing/2014/main" id="{3FB1E7EA-65F3-4F4F-9095-998E18ACEC5D}"/>
+                <a16:creationId xmlns:a16="http://schemas.microsoft.com/office/drawing/2014/main" id="{3ED6F9E3-573B-49B2-9C19-AD4A98E22B0C}"/>
               </a:ext>
             </a:extLst>
           </p:cNvPr>
@@ -9072,7 +9282,7 @@
           <p:cNvPr id="10" name="">
             <a:extLst xmlns:a="http://schemas.openxmlformats.org/drawingml/2006/main">
               <a:ext uri="{FF2B5EF4-FFF2-40B4-BE49-F238E27FC236}">
-                <a16:creationId xmlns:a16="http://schemas.microsoft.com/office/drawing/2014/main" id="{DA8B517E-E44D-4492-8E8B-7F11AA5E0AA9}"/>
+                <a16:creationId xmlns:a16="http://schemas.microsoft.com/office/drawing/2014/main" id="{43B61333-9B71-4153-ACF2-F5FBD9CA311E}"/>
               </a:ext>
             </a:extLst>
           </p:cNvPr>
@@ -9128,7 +9338,7 @@
           <p:cNvPr id="11" name="">
             <a:extLst xmlns:a="http://schemas.openxmlformats.org/drawingml/2006/main">
               <a:ext uri="{FF2B5EF4-FFF2-40B4-BE49-F238E27FC236}">
-                <a16:creationId xmlns:a16="http://schemas.microsoft.com/office/drawing/2014/main" id="{B5810763-B6A0-46D5-B455-EB5126F99373}"/>
+                <a16:creationId xmlns:a16="http://schemas.microsoft.com/office/drawing/2014/main" id="{979B27DE-0343-4180-B941-87475AAECC8B}"/>
               </a:ext>
             </a:extLst>
           </p:cNvPr>
@@ -9184,7 +9394,7 @@
           <p:cNvPr id="12" name="">
             <a:extLst xmlns:a="http://schemas.openxmlformats.org/drawingml/2006/main">
               <a:ext uri="{FF2B5EF4-FFF2-40B4-BE49-F238E27FC236}">
-                <a16:creationId xmlns:a16="http://schemas.microsoft.com/office/drawing/2014/main" id="{D51C6B03-4751-4A17-9136-FAFB40680427}"/>
+                <a16:creationId xmlns:a16="http://schemas.microsoft.com/office/drawing/2014/main" id="{5109A09B-EB3D-4E28-B9A3-A0E2886E319C}"/>
               </a:ext>
             </a:extLst>
           </p:cNvPr>
@@ -9217,7 +9427,7 @@
           <p:cNvPr id="13" name="">
             <a:extLst xmlns:a="http://schemas.openxmlformats.org/drawingml/2006/main">
               <a:ext uri="{FF2B5EF4-FFF2-40B4-BE49-F238E27FC236}">
-                <a16:creationId xmlns:a16="http://schemas.microsoft.com/office/drawing/2014/main" id="{A1C7D767-BFD4-4DBC-8033-B0A902151A16}"/>
+                <a16:creationId xmlns:a16="http://schemas.microsoft.com/office/drawing/2014/main" id="{ABF0F7B2-6990-418D-B7B2-51FA488B8964}"/>
               </a:ext>
             </a:extLst>
           </p:cNvPr>
@@ -9252,7 +9462,7 @@
           <p:cNvPr id="14" name="">
             <a:extLst xmlns:a="http://schemas.openxmlformats.org/drawingml/2006/main">
               <a:ext uri="{FF2B5EF4-FFF2-40B4-BE49-F238E27FC236}">
-                <a16:creationId xmlns:a16="http://schemas.microsoft.com/office/drawing/2014/main" id="{B7B0E2D6-40D1-4A6E-8249-B7EF550530EF}"/>
+                <a16:creationId xmlns:a16="http://schemas.microsoft.com/office/drawing/2014/main" id="{984F7C4C-71A6-4D7D-934E-34A3C73E9F12}"/>
               </a:ext>
             </a:extLst>
           </p:cNvPr>
@@ -9308,7 +9518,7 @@
           <p:cNvPr id="15" name="">
             <a:extLst xmlns:a="http://schemas.openxmlformats.org/drawingml/2006/main">
               <a:ext uri="{FF2B5EF4-FFF2-40B4-BE49-F238E27FC236}">
-                <a16:creationId xmlns:a16="http://schemas.microsoft.com/office/drawing/2014/main" id="{417E1A1E-492D-4479-A94E-27040679884F}"/>
+                <a16:creationId xmlns:a16="http://schemas.microsoft.com/office/drawing/2014/main" id="{8BC94397-1DD9-41DE-9B7C-8F593CB09ECB}"/>
               </a:ext>
             </a:extLst>
           </p:cNvPr>
@@ -9364,7 +9574,7 @@
           <p:cNvPr id="16" name="">
             <a:extLst xmlns:a="http://schemas.openxmlformats.org/drawingml/2006/main">
               <a:ext uri="{FF2B5EF4-FFF2-40B4-BE49-F238E27FC236}">
-                <a16:creationId xmlns:a16="http://schemas.microsoft.com/office/drawing/2014/main" id="{CCB919A9-ABB5-46D9-A4DA-BDC14F078A96}"/>
+                <a16:creationId xmlns:a16="http://schemas.microsoft.com/office/drawing/2014/main" id="{0A470AC0-16E5-4B54-8B41-92D2230A8983}"/>
               </a:ext>
             </a:extLst>
           </p:cNvPr>
@@ -9397,7 +9607,7 @@
           <p:cNvPr id="17" name="">
             <a:extLst xmlns:a="http://schemas.openxmlformats.org/drawingml/2006/main">
               <a:ext uri="{FF2B5EF4-FFF2-40B4-BE49-F238E27FC236}">
-                <a16:creationId xmlns:a16="http://schemas.microsoft.com/office/drawing/2014/main" id="{ED3ADC84-0A8D-40AB-BE6B-C87C48F59933}"/>
+                <a16:creationId xmlns:a16="http://schemas.microsoft.com/office/drawing/2014/main" id="{CD56C04E-9FC1-4258-B07E-C86DD0589C25}"/>
               </a:ext>
             </a:extLst>
           </p:cNvPr>
@@ -9432,7 +9642,7 @@
           <p:cNvPr id="18" name="">
             <a:extLst xmlns:a="http://schemas.openxmlformats.org/drawingml/2006/main">
               <a:ext uri="{FF2B5EF4-FFF2-40B4-BE49-F238E27FC236}">
-                <a16:creationId xmlns:a16="http://schemas.microsoft.com/office/drawing/2014/main" id="{1865D6D9-0829-4420-A72E-AD70998399C1}"/>
+                <a16:creationId xmlns:a16="http://schemas.microsoft.com/office/drawing/2014/main" id="{FC11743C-185C-433A-98EA-C30D18FB40F3}"/>
               </a:ext>
             </a:extLst>
           </p:cNvPr>
@@ -9488,7 +9698,7 @@
           <p:cNvPr id="19" name="">
             <a:extLst xmlns:a="http://schemas.openxmlformats.org/drawingml/2006/main">
               <a:ext uri="{FF2B5EF4-FFF2-40B4-BE49-F238E27FC236}">
-                <a16:creationId xmlns:a16="http://schemas.microsoft.com/office/drawing/2014/main" id="{0932B43A-1D10-4926-B555-ACFC1F28F3F5}"/>
+                <a16:creationId xmlns:a16="http://schemas.microsoft.com/office/drawing/2014/main" id="{8DEE0759-28ED-446B-8A7A-A7DA78BFD95D}"/>
               </a:ext>
             </a:extLst>
           </p:cNvPr>
@@ -9544,7 +9754,7 @@
           <p:cNvPr id="20" name="">
             <a:extLst xmlns:a="http://schemas.openxmlformats.org/drawingml/2006/main">
               <a:ext uri="{FF2B5EF4-FFF2-40B4-BE49-F238E27FC236}">
-                <a16:creationId xmlns:a16="http://schemas.microsoft.com/office/drawing/2014/main" id="{C6293505-633E-43AF-8359-633A8CF80B7E}"/>
+                <a16:creationId xmlns:a16="http://schemas.microsoft.com/office/drawing/2014/main" id="{91F639D1-58E1-4B5E-BA1F-F14DC54D8915}"/>
               </a:ext>
             </a:extLst>
           </p:cNvPr>
@@ -9577,7 +9787,7 @@
           <p:cNvPr id="21" name="">
             <a:extLst xmlns:a="http://schemas.openxmlformats.org/drawingml/2006/main">
               <a:ext uri="{FF2B5EF4-FFF2-40B4-BE49-F238E27FC236}">
-                <a16:creationId xmlns:a16="http://schemas.microsoft.com/office/drawing/2014/main" id="{3D5409C9-65F3-4DC9-9AF8-4FDFD32207C0}"/>
+                <a16:creationId xmlns:a16="http://schemas.microsoft.com/office/drawing/2014/main" id="{7E2BB6A8-AC8C-4A3E-BEB7-31620A371406}"/>
               </a:ext>
             </a:extLst>
           </p:cNvPr>
@@ -9633,7 +9843,7 @@
           <p:cNvPr id="22" name="">
             <a:extLst xmlns:a="http://schemas.openxmlformats.org/drawingml/2006/main">
               <a:ext uri="{FF2B5EF4-FFF2-40B4-BE49-F238E27FC236}">
-                <a16:creationId xmlns:a16="http://schemas.microsoft.com/office/drawing/2014/main" id="{8D845A8E-5AB4-4FC0-AA0D-80F6B65B715B}"/>
+                <a16:creationId xmlns:a16="http://schemas.microsoft.com/office/drawing/2014/main" id="{7A314081-55DA-4435-93F7-5011487193FF}"/>
               </a:ext>
             </a:extLst>
           </p:cNvPr>
@@ -9666,7 +9876,7 @@
           <p:cNvPr id="23" name="">
             <a:extLst xmlns:a="http://schemas.openxmlformats.org/drawingml/2006/main">
               <a:ext uri="{FF2B5EF4-FFF2-40B4-BE49-F238E27FC236}">
-                <a16:creationId xmlns:a16="http://schemas.microsoft.com/office/drawing/2014/main" id="{94126AD6-90BB-44C2-97A7-498E8BB0890A}"/>
+                <a16:creationId xmlns:a16="http://schemas.microsoft.com/office/drawing/2014/main" id="{22F897DE-9C62-45E2-BF77-BEE2527BBB81}"/>
               </a:ext>
             </a:extLst>
           </p:cNvPr>
@@ -9722,7 +9932,7 @@
           <p:cNvPr id="24" name="">
             <a:extLst xmlns:a="http://schemas.openxmlformats.org/drawingml/2006/main">
               <a:ext uri="{FF2B5EF4-FFF2-40B4-BE49-F238E27FC236}">
-                <a16:creationId xmlns:a16="http://schemas.microsoft.com/office/drawing/2014/main" id="{5B92CDDD-816D-489A-B6EF-82AF0B0677F7}"/>
+                <a16:creationId xmlns:a16="http://schemas.microsoft.com/office/drawing/2014/main" id="{2D152D82-368D-41FE-B0DA-D735B77457BE}"/>
               </a:ext>
             </a:extLst>
           </p:cNvPr>
@@ -9755,7 +9965,7 @@
           <p:cNvPr id="25" name="">
             <a:extLst xmlns:a="http://schemas.openxmlformats.org/drawingml/2006/main">
               <a:ext uri="{FF2B5EF4-FFF2-40B4-BE49-F238E27FC236}">
-                <a16:creationId xmlns:a16="http://schemas.microsoft.com/office/drawing/2014/main" id="{5D623CAE-7B54-473C-A4FE-B5CEB6A0C490}"/>
+                <a16:creationId xmlns:a16="http://schemas.microsoft.com/office/drawing/2014/main" id="{28D4083B-BC35-4F4C-9B9F-CDEA8948E14E}"/>
               </a:ext>
             </a:extLst>
           </p:cNvPr>
@@ -9811,7 +10021,7 @@
           <p:cNvPr id="26" name="">
             <a:extLst xmlns:a="http://schemas.openxmlformats.org/drawingml/2006/main">
               <a:ext uri="{FF2B5EF4-FFF2-40B4-BE49-F238E27FC236}">
-                <a16:creationId xmlns:a16="http://schemas.microsoft.com/office/drawing/2014/main" id="{7CFF505E-AA63-4F8C-9764-EE583DD6F342}"/>
+                <a16:creationId xmlns:a16="http://schemas.microsoft.com/office/drawing/2014/main" id="{E4BCF63C-E811-4313-AE8A-22F052B1016E}"/>
               </a:ext>
             </a:extLst>
           </p:cNvPr>
@@ -9867,7 +10077,7 @@
           <p:cNvPr id="27" name="">
             <a:extLst xmlns:a="http://schemas.openxmlformats.org/drawingml/2006/main">
               <a:ext uri="{FF2B5EF4-FFF2-40B4-BE49-F238E27FC236}">
-                <a16:creationId xmlns:a16="http://schemas.microsoft.com/office/drawing/2014/main" id="{E9F4F3C2-2C96-4F56-9D1E-1E22457D5B60}"/>
+                <a16:creationId xmlns:a16="http://schemas.microsoft.com/office/drawing/2014/main" id="{AE26A7F6-36F0-4418-900E-1BEBB15ADA5D}"/>
               </a:ext>
             </a:extLst>
           </p:cNvPr>
@@ -9921,7 +10131,7 @@
     </p:spTree>
     <p:extLst>
       <p:ext uri="{BB962C8B-B14F-4D97-AF65-F5344CB8AC3E}">
-        <p14:creationId xmlns:p14="http://schemas.microsoft.com/office/powerpoint/2010/main" val="1544024895"/>
+        <p14:creationId xmlns:p14="http://schemas.microsoft.com/office/powerpoint/2010/main" val="2011111613"/>
       </p:ext>
     </p:extLst>
   </p:cSld>
@@ -9952,7 +10162,7 @@
           <p:cNvPr id="1" name="">
             <a:extLst xmlns:a="http://schemas.openxmlformats.org/drawingml/2006/main">
               <a:ext uri="{FF2B5EF4-FFF2-40B4-BE49-F238E27FC236}">
-                <a16:creationId xmlns:a16="http://schemas.microsoft.com/office/drawing/2014/main" id="{9676FE14-F488-4756-B569-67C26C075A63}"/>
+                <a16:creationId xmlns:a16="http://schemas.microsoft.com/office/drawing/2014/main" id="{94B8074E-4146-4F9E-B1A4-59AA05FA2C60}"/>
               </a:ext>
             </a:extLst>
           </p:cNvPr>
@@ -9985,7 +10195,7 @@
           <p:cNvPr id="2" name="">
             <a:extLst xmlns:a="http://schemas.openxmlformats.org/drawingml/2006/main">
               <a:ext uri="{FF2B5EF4-FFF2-40B4-BE49-F238E27FC236}">
-                <a16:creationId xmlns:a16="http://schemas.microsoft.com/office/drawing/2014/main" id="{E34C8DD7-79F8-46AC-A033-3BA0FC69B74F}"/>
+                <a16:creationId xmlns:a16="http://schemas.microsoft.com/office/drawing/2014/main" id="{A09B8EA8-C411-4BA7-97CF-9BF605F85314}"/>
               </a:ext>
             </a:extLst>
           </p:cNvPr>
@@ -10041,7 +10251,7 @@
           <p:cNvPr id="3" name="">
             <a:extLst xmlns:a="http://schemas.openxmlformats.org/drawingml/2006/main">
               <a:ext uri="{FF2B5EF4-FFF2-40B4-BE49-F238E27FC236}">
-                <a16:creationId xmlns:a16="http://schemas.microsoft.com/office/drawing/2014/main" id="{11533AC2-F8A6-4EAC-8ECC-1C0DC8A35005}"/>
+                <a16:creationId xmlns:a16="http://schemas.microsoft.com/office/drawing/2014/main" id="{008532F5-D336-4675-BAB2-9159F6279439}"/>
               </a:ext>
             </a:extLst>
           </p:cNvPr>
@@ -10097,7 +10307,7 @@
           <p:cNvPr id="4" name="">
             <a:extLst xmlns:a="http://schemas.openxmlformats.org/drawingml/2006/main">
               <a:ext uri="{FF2B5EF4-FFF2-40B4-BE49-F238E27FC236}">
-                <a16:creationId xmlns:a16="http://schemas.microsoft.com/office/drawing/2014/main" id="{6EE8CC27-30B5-46AF-8700-9375D9B9BC90}"/>
+                <a16:creationId xmlns:a16="http://schemas.microsoft.com/office/drawing/2014/main" id="{961E1377-AAD3-4169-841C-3175182C4D70}"/>
               </a:ext>
             </a:extLst>
           </p:cNvPr>
@@ -10153,7 +10363,7 @@
           <p:cNvPr id="5" name="">
             <a:extLst xmlns:a="http://schemas.openxmlformats.org/drawingml/2006/main">
               <a:ext uri="{FF2B5EF4-FFF2-40B4-BE49-F238E27FC236}">
-                <a16:creationId xmlns:a16="http://schemas.microsoft.com/office/drawing/2014/main" id="{9E39BD71-9730-4C02-892E-1441E455863F}"/>
+                <a16:creationId xmlns:a16="http://schemas.microsoft.com/office/drawing/2014/main" id="{095CE2B2-3506-4CAE-B82E-FD11AFE82CC8}"/>
               </a:ext>
             </a:extLst>
           </p:cNvPr>
@@ -10188,7 +10398,7 @@
           <p:cNvPr id="6" name="">
             <a:extLst xmlns:a="http://schemas.openxmlformats.org/drawingml/2006/main">
               <a:ext uri="{FF2B5EF4-FFF2-40B4-BE49-F238E27FC236}">
-                <a16:creationId xmlns:a16="http://schemas.microsoft.com/office/drawing/2014/main" id="{0FC27CB3-38CD-491A-8CD3-C6593AC8B275}"/>
+                <a16:creationId xmlns:a16="http://schemas.microsoft.com/office/drawing/2014/main" id="{14787D91-C1BA-4289-962F-C82159E9F365}"/>
               </a:ext>
             </a:extLst>
           </p:cNvPr>
@@ -10244,7 +10454,7 @@
           <p:cNvPr id="7" name="">
             <a:extLst xmlns:a="http://schemas.openxmlformats.org/drawingml/2006/main">
               <a:ext uri="{FF2B5EF4-FFF2-40B4-BE49-F238E27FC236}">
-                <a16:creationId xmlns:a16="http://schemas.microsoft.com/office/drawing/2014/main" id="{425B9F34-3F37-46D2-9ECE-554879F977ED}"/>
+                <a16:creationId xmlns:a16="http://schemas.microsoft.com/office/drawing/2014/main" id="{2494B63A-34BF-464C-A2B9-24D367C4502E}"/>
               </a:ext>
             </a:extLst>
           </p:cNvPr>
@@ -10277,7 +10487,7 @@
           <p:cNvPr id="8" name="">
             <a:extLst xmlns:a="http://schemas.openxmlformats.org/drawingml/2006/main">
               <a:ext uri="{FF2B5EF4-FFF2-40B4-BE49-F238E27FC236}">
-                <a16:creationId xmlns:a16="http://schemas.microsoft.com/office/drawing/2014/main" id="{AAE9346D-5FFF-4BF9-AD7C-B17B4C58C865}"/>
+                <a16:creationId xmlns:a16="http://schemas.microsoft.com/office/drawing/2014/main" id="{5C981FD4-8414-49F1-9A14-06E8D960FAA9}"/>
               </a:ext>
             </a:extLst>
           </p:cNvPr>
@@ -10333,7 +10543,7 @@
           <p:cNvPr id="9" name="">
             <a:extLst xmlns:a="http://schemas.openxmlformats.org/drawingml/2006/main">
               <a:ext uri="{FF2B5EF4-FFF2-40B4-BE49-F238E27FC236}">
-                <a16:creationId xmlns:a16="http://schemas.microsoft.com/office/drawing/2014/main" id="{B27B9B0A-2DF5-482A-8BF1-4B306BBB1AD0}"/>
+                <a16:creationId xmlns:a16="http://schemas.microsoft.com/office/drawing/2014/main" id="{F518FECC-AAB5-4CE6-BBBB-7A0EE0560E7B}"/>
               </a:ext>
             </a:extLst>
           </p:cNvPr>
@@ -10366,7 +10576,7 @@
           <p:cNvPr id="10" name="">
             <a:extLst xmlns:a="http://schemas.openxmlformats.org/drawingml/2006/main">
               <a:ext uri="{FF2B5EF4-FFF2-40B4-BE49-F238E27FC236}">
-                <a16:creationId xmlns:a16="http://schemas.microsoft.com/office/drawing/2014/main" id="{5829F993-48FD-44E5-B199-0DF80CEF0544}"/>
+                <a16:creationId xmlns:a16="http://schemas.microsoft.com/office/drawing/2014/main" id="{30FE8D0F-E309-4D5E-AB34-AD29EE4363B7}"/>
               </a:ext>
             </a:extLst>
           </p:cNvPr>
@@ -10422,7 +10632,7 @@
           <p:cNvPr id="11" name="">
             <a:extLst xmlns:a="http://schemas.openxmlformats.org/drawingml/2006/main">
               <a:ext uri="{FF2B5EF4-FFF2-40B4-BE49-F238E27FC236}">
-                <a16:creationId xmlns:a16="http://schemas.microsoft.com/office/drawing/2014/main" id="{A3FB6EC6-8D2A-4B6B-B55E-AE0AAAC1B297}"/>
+                <a16:creationId xmlns:a16="http://schemas.microsoft.com/office/drawing/2014/main" id="{872637EF-D371-4341-BA03-2808706CBA3A}"/>
               </a:ext>
             </a:extLst>
           </p:cNvPr>
@@ -10455,7 +10665,7 @@
           <p:cNvPr id="12" name="">
             <a:extLst xmlns:a="http://schemas.openxmlformats.org/drawingml/2006/main">
               <a:ext uri="{FF2B5EF4-FFF2-40B4-BE49-F238E27FC236}">
-                <a16:creationId xmlns:a16="http://schemas.microsoft.com/office/drawing/2014/main" id="{A0E1A01E-CF8C-453A-A700-4E0438C41633}"/>
+                <a16:creationId xmlns:a16="http://schemas.microsoft.com/office/drawing/2014/main" id="{1D8881DA-233F-44A5-A0BC-57F68C350229}"/>
               </a:ext>
             </a:extLst>
           </p:cNvPr>
@@ -10511,7 +10721,7 @@
           <p:cNvPr id="13" name="">
             <a:extLst xmlns:a="http://schemas.openxmlformats.org/drawingml/2006/main">
               <a:ext uri="{FF2B5EF4-FFF2-40B4-BE49-F238E27FC236}">
-                <a16:creationId xmlns:a16="http://schemas.microsoft.com/office/drawing/2014/main" id="{203DB1AC-99B3-4168-AA30-95C750952157}"/>
+                <a16:creationId xmlns:a16="http://schemas.microsoft.com/office/drawing/2014/main" id="{573CB690-D424-4AFE-811B-EC7951620BC3}"/>
               </a:ext>
             </a:extLst>
           </p:cNvPr>
@@ -10546,7 +10756,7 @@
           <p:cNvPr id="14" name="">
             <a:extLst xmlns:a="http://schemas.openxmlformats.org/drawingml/2006/main">
               <a:ext uri="{FF2B5EF4-FFF2-40B4-BE49-F238E27FC236}">
-                <a16:creationId xmlns:a16="http://schemas.microsoft.com/office/drawing/2014/main" id="{01F28749-1DA0-475D-8E52-0588A573E1FA}"/>
+                <a16:creationId xmlns:a16="http://schemas.microsoft.com/office/drawing/2014/main" id="{107A668C-0419-4589-962A-B3A79DACF1F9}"/>
               </a:ext>
             </a:extLst>
           </p:cNvPr>
@@ -10602,7 +10812,7 @@
           <p:cNvPr id="15" name="">
             <a:extLst xmlns:a="http://schemas.openxmlformats.org/drawingml/2006/main">
               <a:ext uri="{FF2B5EF4-FFF2-40B4-BE49-F238E27FC236}">
-                <a16:creationId xmlns:a16="http://schemas.microsoft.com/office/drawing/2014/main" id="{F8B4EF18-A2DF-43B4-B249-991A19AD12D6}"/>
+                <a16:creationId xmlns:a16="http://schemas.microsoft.com/office/drawing/2014/main" id="{8080E2FF-4252-4F00-9333-638842B97CFA}"/>
               </a:ext>
             </a:extLst>
           </p:cNvPr>
@@ -10635,7 +10845,7 @@
           <p:cNvPr id="16" name="">
             <a:extLst xmlns:a="http://schemas.openxmlformats.org/drawingml/2006/main">
               <a:ext uri="{FF2B5EF4-FFF2-40B4-BE49-F238E27FC236}">
-                <a16:creationId xmlns:a16="http://schemas.microsoft.com/office/drawing/2014/main" id="{37FEBE71-6501-40B2-A3BD-6B59C99ADA7E}"/>
+                <a16:creationId xmlns:a16="http://schemas.microsoft.com/office/drawing/2014/main" id="{6E9D0A98-2AFD-464C-9131-DBD80DB51257}"/>
               </a:ext>
             </a:extLst>
           </p:cNvPr>
@@ -10691,7 +10901,7 @@
           <p:cNvPr id="17" name="">
             <a:extLst xmlns:a="http://schemas.openxmlformats.org/drawingml/2006/main">
               <a:ext uri="{FF2B5EF4-FFF2-40B4-BE49-F238E27FC236}">
-                <a16:creationId xmlns:a16="http://schemas.microsoft.com/office/drawing/2014/main" id="{C786D379-C6E4-4EBA-92D5-1396E36471CA}"/>
+                <a16:creationId xmlns:a16="http://schemas.microsoft.com/office/drawing/2014/main" id="{462C1BBD-44D3-429A-9C52-976589B6BD3C}"/>
               </a:ext>
             </a:extLst>
           </p:cNvPr>
@@ -10724,7 +10934,7 @@
           <p:cNvPr id="18" name="">
             <a:extLst xmlns:a="http://schemas.openxmlformats.org/drawingml/2006/main">
               <a:ext uri="{FF2B5EF4-FFF2-40B4-BE49-F238E27FC236}">
-                <a16:creationId xmlns:a16="http://schemas.microsoft.com/office/drawing/2014/main" id="{B66DF131-2926-4640-B11E-0AD54B3D5B02}"/>
+                <a16:creationId xmlns:a16="http://schemas.microsoft.com/office/drawing/2014/main" id="{EA820BA5-F196-44F9-9EE9-79001829AC60}"/>
               </a:ext>
             </a:extLst>
           </p:cNvPr>
@@ -10780,7 +10990,7 @@
           <p:cNvPr id="19" name="">
             <a:extLst xmlns:a="http://schemas.openxmlformats.org/drawingml/2006/main">
               <a:ext uri="{FF2B5EF4-FFF2-40B4-BE49-F238E27FC236}">
-                <a16:creationId xmlns:a16="http://schemas.microsoft.com/office/drawing/2014/main" id="{C43E9889-4431-43E7-83D2-9A4B1585E49F}"/>
+                <a16:creationId xmlns:a16="http://schemas.microsoft.com/office/drawing/2014/main" id="{865E49F7-EC5A-4BF6-922B-493A48AD4A60}"/>
               </a:ext>
             </a:extLst>
           </p:cNvPr>
@@ -10813,7 +11023,7 @@
           <p:cNvPr id="20" name="">
             <a:extLst xmlns:a="http://schemas.openxmlformats.org/drawingml/2006/main">
               <a:ext uri="{FF2B5EF4-FFF2-40B4-BE49-F238E27FC236}">
-                <a16:creationId xmlns:a16="http://schemas.microsoft.com/office/drawing/2014/main" id="{B615D039-A7F7-42A1-A0CF-B7EC52F8246F}"/>
+                <a16:creationId xmlns:a16="http://schemas.microsoft.com/office/drawing/2014/main" id="{075E1057-0270-408E-8B7E-96091B93AFF9}"/>
               </a:ext>
             </a:extLst>
           </p:cNvPr>
@@ -10869,7 +11079,7 @@
           <p:cNvPr id="21" name="">
             <a:extLst xmlns:a="http://schemas.openxmlformats.org/drawingml/2006/main">
               <a:ext uri="{FF2B5EF4-FFF2-40B4-BE49-F238E27FC236}">
-                <a16:creationId xmlns:a16="http://schemas.microsoft.com/office/drawing/2014/main" id="{EBEFB0CD-202B-4027-A159-6E267749C699}"/>
+                <a16:creationId xmlns:a16="http://schemas.microsoft.com/office/drawing/2014/main" id="{BD8AC618-3CBD-451B-95E3-B755FF7315A7}"/>
               </a:ext>
             </a:extLst>
           </p:cNvPr>
@@ -10925,7 +11135,7 @@
           <p:cNvPr id="22" name="">
             <a:extLst xmlns:a="http://schemas.openxmlformats.org/drawingml/2006/main">
               <a:ext uri="{FF2B5EF4-FFF2-40B4-BE49-F238E27FC236}">
-                <a16:creationId xmlns:a16="http://schemas.microsoft.com/office/drawing/2014/main" id="{B8454472-A97E-4BDA-B90E-5BC2FDBFE55B}"/>
+                <a16:creationId xmlns:a16="http://schemas.microsoft.com/office/drawing/2014/main" id="{0645C41C-BDFA-41C0-8EBC-939EAED6140F}"/>
               </a:ext>
             </a:extLst>
           </p:cNvPr>
@@ -10979,7 +11189,7 @@
     </p:spTree>
     <p:extLst>
       <p:ext uri="{BB962C8B-B14F-4D97-AF65-F5344CB8AC3E}">
-        <p14:creationId xmlns:p14="http://schemas.microsoft.com/office/powerpoint/2010/main" val="1408890154"/>
+        <p14:creationId xmlns:p14="http://schemas.microsoft.com/office/powerpoint/2010/main" val="1247133533"/>
       </p:ext>
     </p:extLst>
   </p:cSld>
@@ -11010,7 +11220,7 @@
           <p:cNvPr id="1" name="">
             <a:extLst xmlns:a="http://schemas.openxmlformats.org/drawingml/2006/main">
               <a:ext uri="{FF2B5EF4-FFF2-40B4-BE49-F238E27FC236}">
-                <a16:creationId xmlns:a16="http://schemas.microsoft.com/office/drawing/2014/main" id="{B89B208B-3F3D-4D6C-8806-6B3424DA6EAC}"/>
+                <a16:creationId xmlns:a16="http://schemas.microsoft.com/office/drawing/2014/main" id="{668C62C1-3650-4EA2-8360-67418CFBE6F3}"/>
               </a:ext>
             </a:extLst>
           </p:cNvPr>
@@ -11043,7 +11253,7 @@
           <p:cNvPr id="2" name="">
             <a:extLst xmlns:a="http://schemas.openxmlformats.org/drawingml/2006/main">
               <a:ext uri="{FF2B5EF4-FFF2-40B4-BE49-F238E27FC236}">
-                <a16:creationId xmlns:a16="http://schemas.microsoft.com/office/drawing/2014/main" id="{BBEACF67-AE52-4051-ADB0-A623CF10D15B}"/>
+                <a16:creationId xmlns:a16="http://schemas.microsoft.com/office/drawing/2014/main" id="{AE12BB85-11C5-467B-B443-A851F568033C}"/>
               </a:ext>
             </a:extLst>
           </p:cNvPr>
@@ -11099,7 +11309,7 @@
           <p:cNvPr id="3" name="">
             <a:extLst xmlns:a="http://schemas.openxmlformats.org/drawingml/2006/main">
               <a:ext uri="{FF2B5EF4-FFF2-40B4-BE49-F238E27FC236}">
-                <a16:creationId xmlns:a16="http://schemas.microsoft.com/office/drawing/2014/main" id="{7CA25B6C-5B1F-42AD-B837-E17006AF2687}"/>
+                <a16:creationId xmlns:a16="http://schemas.microsoft.com/office/drawing/2014/main" id="{9284EB5B-7BCF-4AB6-AC2D-082BA6C941C1}"/>
               </a:ext>
             </a:extLst>
           </p:cNvPr>
@@ -11155,7 +11365,7 @@
           <p:cNvPr id="4" name="">
             <a:extLst xmlns:a="http://schemas.openxmlformats.org/drawingml/2006/main">
               <a:ext uri="{FF2B5EF4-FFF2-40B4-BE49-F238E27FC236}">
-                <a16:creationId xmlns:a16="http://schemas.microsoft.com/office/drawing/2014/main" id="{8ED80F76-B866-4E81-A838-A9F2CF537059}"/>
+                <a16:creationId xmlns:a16="http://schemas.microsoft.com/office/drawing/2014/main" id="{ABA9F1BF-FA02-4106-A10F-302F7A0B65EC}"/>
               </a:ext>
             </a:extLst>
           </p:cNvPr>
@@ -11211,7 +11421,7 @@
           <p:cNvPr id="5" name="">
             <a:extLst xmlns:a="http://schemas.openxmlformats.org/drawingml/2006/main">
               <a:ext uri="{FF2B5EF4-FFF2-40B4-BE49-F238E27FC236}">
-                <a16:creationId xmlns:a16="http://schemas.microsoft.com/office/drawing/2014/main" id="{369E815E-FA87-4411-B148-6CAABE631B38}"/>
+                <a16:creationId xmlns:a16="http://schemas.microsoft.com/office/drawing/2014/main" id="{81335B97-31AA-4F0B-A16C-451187E9442F}"/>
               </a:ext>
             </a:extLst>
           </p:cNvPr>
@@ -11246,7 +11456,7 @@
           <p:cNvPr id="6" name="">
             <a:extLst xmlns:a="http://schemas.openxmlformats.org/drawingml/2006/main">
               <a:ext uri="{FF2B5EF4-FFF2-40B4-BE49-F238E27FC236}">
-                <a16:creationId xmlns:a16="http://schemas.microsoft.com/office/drawing/2014/main" id="{88B2F33B-C2CF-41C8-845D-C0764CE56D1C}"/>
+                <a16:creationId xmlns:a16="http://schemas.microsoft.com/office/drawing/2014/main" id="{CE4AF72D-7601-4EC2-9894-6CFE394CA17C}"/>
               </a:ext>
             </a:extLst>
           </p:cNvPr>
@@ -11279,7 +11489,7 @@
           <p:cNvPr id="7" name="">
             <a:extLst xmlns:a="http://schemas.openxmlformats.org/drawingml/2006/main">
               <a:ext uri="{FF2B5EF4-FFF2-40B4-BE49-F238E27FC236}">
-                <a16:creationId xmlns:a16="http://schemas.microsoft.com/office/drawing/2014/main" id="{5E480D71-D8F5-407D-AAA2-888397DB1B40}"/>
+                <a16:creationId xmlns:a16="http://schemas.microsoft.com/office/drawing/2014/main" id="{23CE09AA-82AD-4745-8579-201D9BAD5F92}"/>
               </a:ext>
             </a:extLst>
           </p:cNvPr>
@@ -11335,7 +11545,7 @@
           <p:cNvPr id="8" name="">
             <a:extLst xmlns:a="http://schemas.openxmlformats.org/drawingml/2006/main">
               <a:ext uri="{FF2B5EF4-FFF2-40B4-BE49-F238E27FC236}">
-                <a16:creationId xmlns:a16="http://schemas.microsoft.com/office/drawing/2014/main" id="{6F8B4781-ED0D-42BA-BC74-97C4813F1597}"/>
+                <a16:creationId xmlns:a16="http://schemas.microsoft.com/office/drawing/2014/main" id="{D9D508FC-5136-4D77-AFC5-18D9F2FC711A}"/>
               </a:ext>
             </a:extLst>
           </p:cNvPr>
@@ -11391,7 +11601,7 @@
           <p:cNvPr id="9" name="">
             <a:extLst xmlns:a="http://schemas.openxmlformats.org/drawingml/2006/main">
               <a:ext uri="{FF2B5EF4-FFF2-40B4-BE49-F238E27FC236}">
-                <a16:creationId xmlns:a16="http://schemas.microsoft.com/office/drawing/2014/main" id="{79F232B5-D32A-4AB7-A795-3FDCF24F5D4B}"/>
+                <a16:creationId xmlns:a16="http://schemas.microsoft.com/office/drawing/2014/main" id="{D00FE05F-C0AF-4AEF-A943-C6AB805D78D6}"/>
               </a:ext>
             </a:extLst>
           </p:cNvPr>
@@ -11447,7 +11657,7 @@
           <p:cNvPr id="10" name="">
             <a:extLst xmlns:a="http://schemas.openxmlformats.org/drawingml/2006/main">
               <a:ext uri="{FF2B5EF4-FFF2-40B4-BE49-F238E27FC236}">
-                <a16:creationId xmlns:a16="http://schemas.microsoft.com/office/drawing/2014/main" id="{6D635950-E412-44DA-859D-08772360C7F1}"/>
+                <a16:creationId xmlns:a16="http://schemas.microsoft.com/office/drawing/2014/main" id="{24F892AF-D254-48FB-9853-53AE8127854B}"/>
               </a:ext>
             </a:extLst>
           </p:cNvPr>
@@ -11482,7 +11692,7 @@
           <p:cNvPr id="11" name="">
             <a:extLst xmlns:a="http://schemas.openxmlformats.org/drawingml/2006/main">
               <a:ext uri="{FF2B5EF4-FFF2-40B4-BE49-F238E27FC236}">
-                <a16:creationId xmlns:a16="http://schemas.microsoft.com/office/drawing/2014/main" id="{6F139D5A-870F-47AC-A645-AF8A1B3EB9F2}"/>
+                <a16:creationId xmlns:a16="http://schemas.microsoft.com/office/drawing/2014/main" id="{E2F239A9-FAD3-4B7C-B0ED-1823680B19D0}"/>
               </a:ext>
             </a:extLst>
           </p:cNvPr>
@@ -11515,7 +11725,7 @@
           <p:cNvPr id="12" name="">
             <a:extLst xmlns:a="http://schemas.openxmlformats.org/drawingml/2006/main">
               <a:ext uri="{FF2B5EF4-FFF2-40B4-BE49-F238E27FC236}">
-                <a16:creationId xmlns:a16="http://schemas.microsoft.com/office/drawing/2014/main" id="{3175A3BD-766D-47A3-A378-0DF9386040AE}"/>
+                <a16:creationId xmlns:a16="http://schemas.microsoft.com/office/drawing/2014/main" id="{E868E9B0-3EFF-4651-8246-484430B362A4}"/>
               </a:ext>
             </a:extLst>
           </p:cNvPr>
@@ -11571,7 +11781,7 @@
           <p:cNvPr id="13" name="">
             <a:extLst xmlns:a="http://schemas.openxmlformats.org/drawingml/2006/main">
               <a:ext uri="{FF2B5EF4-FFF2-40B4-BE49-F238E27FC236}">
-                <a16:creationId xmlns:a16="http://schemas.microsoft.com/office/drawing/2014/main" id="{0779D62E-196D-499F-9767-B816E347AA4B}"/>
+                <a16:creationId xmlns:a16="http://schemas.microsoft.com/office/drawing/2014/main" id="{F5E001BD-F1FA-45C3-B27F-6A9FC39CF6A9}"/>
               </a:ext>
             </a:extLst>
           </p:cNvPr>
@@ -11627,7 +11837,7 @@
           <p:cNvPr id="14" name="">
             <a:extLst xmlns:a="http://schemas.openxmlformats.org/drawingml/2006/main">
               <a:ext uri="{FF2B5EF4-FFF2-40B4-BE49-F238E27FC236}">
-                <a16:creationId xmlns:a16="http://schemas.microsoft.com/office/drawing/2014/main" id="{D5E8A4E3-D608-4D2C-894F-6808E296FD43}"/>
+                <a16:creationId xmlns:a16="http://schemas.microsoft.com/office/drawing/2014/main" id="{4DFCCF53-3AB6-4747-B781-C515B8B23C11}"/>
               </a:ext>
             </a:extLst>
           </p:cNvPr>
@@ -11683,7 +11893,7 @@
           <p:cNvPr id="15" name="">
             <a:extLst xmlns:a="http://schemas.openxmlformats.org/drawingml/2006/main">
               <a:ext uri="{FF2B5EF4-FFF2-40B4-BE49-F238E27FC236}">
-                <a16:creationId xmlns:a16="http://schemas.microsoft.com/office/drawing/2014/main" id="{E42969C7-029E-40FB-9FB0-84762D229655}"/>
+                <a16:creationId xmlns:a16="http://schemas.microsoft.com/office/drawing/2014/main" id="{8D90CD7C-3F2B-40B2-8227-1C7FDCE9DD59}"/>
               </a:ext>
             </a:extLst>
           </p:cNvPr>
@@ -11718,7 +11928,7 @@
           <p:cNvPr id="16" name="">
             <a:extLst xmlns:a="http://schemas.openxmlformats.org/drawingml/2006/main">
               <a:ext uri="{FF2B5EF4-FFF2-40B4-BE49-F238E27FC236}">
-                <a16:creationId xmlns:a16="http://schemas.microsoft.com/office/drawing/2014/main" id="{203B8A68-D865-4228-BA0D-38AD0CFABB5A}"/>
+                <a16:creationId xmlns:a16="http://schemas.microsoft.com/office/drawing/2014/main" id="{818776F7-5BF0-4E19-973C-C601AD13E393}"/>
               </a:ext>
             </a:extLst>
           </p:cNvPr>
@@ -11751,7 +11961,7 @@
           <p:cNvPr id="17" name="">
             <a:extLst xmlns:a="http://schemas.openxmlformats.org/drawingml/2006/main">
               <a:ext uri="{FF2B5EF4-FFF2-40B4-BE49-F238E27FC236}">
-                <a16:creationId xmlns:a16="http://schemas.microsoft.com/office/drawing/2014/main" id="{E106F022-6C5D-4D66-AA04-5939963BFD58}"/>
+                <a16:creationId xmlns:a16="http://schemas.microsoft.com/office/drawing/2014/main" id="{48B3E6C9-387E-42CF-A299-3DC55BFD76EC}"/>
               </a:ext>
             </a:extLst>
           </p:cNvPr>
@@ -11807,7 +12017,7 @@
           <p:cNvPr id="18" name="">
             <a:extLst xmlns:a="http://schemas.openxmlformats.org/drawingml/2006/main">
               <a:ext uri="{FF2B5EF4-FFF2-40B4-BE49-F238E27FC236}">
-                <a16:creationId xmlns:a16="http://schemas.microsoft.com/office/drawing/2014/main" id="{D918AF64-F9C7-47D2-AAF4-961424077AEA}"/>
+                <a16:creationId xmlns:a16="http://schemas.microsoft.com/office/drawing/2014/main" id="{03BB7E25-E181-4DAB-866B-D6937ABAA202}"/>
               </a:ext>
             </a:extLst>
           </p:cNvPr>
@@ -11863,7 +12073,7 @@
           <p:cNvPr id="19" name="">
             <a:extLst xmlns:a="http://schemas.openxmlformats.org/drawingml/2006/main">
               <a:ext uri="{FF2B5EF4-FFF2-40B4-BE49-F238E27FC236}">
-                <a16:creationId xmlns:a16="http://schemas.microsoft.com/office/drawing/2014/main" id="{C7C5251C-B609-48F8-B359-A01606B031A2}"/>
+                <a16:creationId xmlns:a16="http://schemas.microsoft.com/office/drawing/2014/main" id="{7C559FC5-78D5-4251-9F97-95CD2370AE92}"/>
               </a:ext>
             </a:extLst>
           </p:cNvPr>
@@ -11919,7 +12129,7 @@
           <p:cNvPr id="20" name="">
             <a:extLst xmlns:a="http://schemas.openxmlformats.org/drawingml/2006/main">
               <a:ext uri="{FF2B5EF4-FFF2-40B4-BE49-F238E27FC236}">
-                <a16:creationId xmlns:a16="http://schemas.microsoft.com/office/drawing/2014/main" id="{4024FF26-73EF-46ED-BE40-320252583E67}"/>
+                <a16:creationId xmlns:a16="http://schemas.microsoft.com/office/drawing/2014/main" id="{8432DD24-3B6A-40C1-9DAD-B4EBF5AB5164}"/>
               </a:ext>
             </a:extLst>
           </p:cNvPr>
@@ -11954,7 +12164,7 @@
           <p:cNvPr id="21" name="">
             <a:extLst xmlns:a="http://schemas.openxmlformats.org/drawingml/2006/main">
               <a:ext uri="{FF2B5EF4-FFF2-40B4-BE49-F238E27FC236}">
-                <a16:creationId xmlns:a16="http://schemas.microsoft.com/office/drawing/2014/main" id="{611862DC-FFAC-4220-B789-E433AF064438}"/>
+                <a16:creationId xmlns:a16="http://schemas.microsoft.com/office/drawing/2014/main" id="{287AEC8E-07B7-41B7-9863-A007DC25BE80}"/>
               </a:ext>
             </a:extLst>
           </p:cNvPr>
@@ -11987,7 +12197,7 @@
           <p:cNvPr id="22" name="">
             <a:extLst xmlns:a="http://schemas.openxmlformats.org/drawingml/2006/main">
               <a:ext uri="{FF2B5EF4-FFF2-40B4-BE49-F238E27FC236}">
-                <a16:creationId xmlns:a16="http://schemas.microsoft.com/office/drawing/2014/main" id="{E7B5DFBF-A3BD-4CF4-8B82-F4262EF476CE}"/>
+                <a16:creationId xmlns:a16="http://schemas.microsoft.com/office/drawing/2014/main" id="{046C2560-A82B-4AF6-9371-1E311660525A}"/>
               </a:ext>
             </a:extLst>
           </p:cNvPr>
@@ -12043,7 +12253,7 @@
           <p:cNvPr id="23" name="">
             <a:extLst xmlns:a="http://schemas.openxmlformats.org/drawingml/2006/main">
               <a:ext uri="{FF2B5EF4-FFF2-40B4-BE49-F238E27FC236}">
-                <a16:creationId xmlns:a16="http://schemas.microsoft.com/office/drawing/2014/main" id="{835283E8-888D-4EE8-93EE-2D810EA1FE42}"/>
+                <a16:creationId xmlns:a16="http://schemas.microsoft.com/office/drawing/2014/main" id="{D62AA87C-9394-4CED-BE70-4C16E6CED412}"/>
               </a:ext>
             </a:extLst>
           </p:cNvPr>
@@ -12099,7 +12309,7 @@
           <p:cNvPr id="24" name="">
             <a:extLst xmlns:a="http://schemas.openxmlformats.org/drawingml/2006/main">
               <a:ext uri="{FF2B5EF4-FFF2-40B4-BE49-F238E27FC236}">
-                <a16:creationId xmlns:a16="http://schemas.microsoft.com/office/drawing/2014/main" id="{2F985A34-1D08-49BD-97B0-ACB70F6DB38B}"/>
+                <a16:creationId xmlns:a16="http://schemas.microsoft.com/office/drawing/2014/main" id="{76B6E898-BDF4-4AEB-93C9-BF4DD32EF111}"/>
               </a:ext>
             </a:extLst>
           </p:cNvPr>
@@ -12155,7 +12365,7 @@
           <p:cNvPr id="25" name="">
             <a:extLst xmlns:a="http://schemas.openxmlformats.org/drawingml/2006/main">
               <a:ext uri="{FF2B5EF4-FFF2-40B4-BE49-F238E27FC236}">
-                <a16:creationId xmlns:a16="http://schemas.microsoft.com/office/drawing/2014/main" id="{7EE2E55B-5D65-43F9-9DC6-412229B599F7}"/>
+                <a16:creationId xmlns:a16="http://schemas.microsoft.com/office/drawing/2014/main" id="{31887A16-4C14-4A79-8424-85E1E59A23FE}"/>
               </a:ext>
             </a:extLst>
           </p:cNvPr>
@@ -12188,7 +12398,7 @@
           <p:cNvPr id="26" name="">
             <a:extLst xmlns:a="http://schemas.openxmlformats.org/drawingml/2006/main">
               <a:ext uri="{FF2B5EF4-FFF2-40B4-BE49-F238E27FC236}">
-                <a16:creationId xmlns:a16="http://schemas.microsoft.com/office/drawing/2014/main" id="{10353308-362E-4663-9086-EBEE2B16C53B}"/>
+                <a16:creationId xmlns:a16="http://schemas.microsoft.com/office/drawing/2014/main" id="{B0574E9E-86B4-4CE5-B2A0-6C4C6A7CD16F}"/>
               </a:ext>
             </a:extLst>
           </p:cNvPr>
@@ -12244,7 +12454,7 @@
           <p:cNvPr id="27" name="">
             <a:extLst xmlns:a="http://schemas.openxmlformats.org/drawingml/2006/main">
               <a:ext uri="{FF2B5EF4-FFF2-40B4-BE49-F238E27FC236}">
-                <a16:creationId xmlns:a16="http://schemas.microsoft.com/office/drawing/2014/main" id="{B2774B8F-D056-445C-BC81-461CF2472387}"/>
+                <a16:creationId xmlns:a16="http://schemas.microsoft.com/office/drawing/2014/main" id="{958CCB72-F359-4976-A29D-8AF1F65CF67C}"/>
               </a:ext>
             </a:extLst>
           </p:cNvPr>
@@ -12277,7 +12487,7 @@
           <p:cNvPr id="28" name="">
             <a:extLst xmlns:a="http://schemas.openxmlformats.org/drawingml/2006/main">
               <a:ext uri="{FF2B5EF4-FFF2-40B4-BE49-F238E27FC236}">
-                <a16:creationId xmlns:a16="http://schemas.microsoft.com/office/drawing/2014/main" id="{572D7091-2F45-4F84-9861-2FD27EADD5C5}"/>
+                <a16:creationId xmlns:a16="http://schemas.microsoft.com/office/drawing/2014/main" id="{9A66F24F-09FB-41C4-B8F6-A5C9798AA6CC}"/>
               </a:ext>
             </a:extLst>
           </p:cNvPr>
@@ -12333,7 +12543,7 @@
           <p:cNvPr id="29" name="">
             <a:extLst xmlns:a="http://schemas.openxmlformats.org/drawingml/2006/main">
               <a:ext uri="{FF2B5EF4-FFF2-40B4-BE49-F238E27FC236}">
-                <a16:creationId xmlns:a16="http://schemas.microsoft.com/office/drawing/2014/main" id="{C866FFA7-76BD-4C1B-A4F9-AA3993CDA5D3}"/>
+                <a16:creationId xmlns:a16="http://schemas.microsoft.com/office/drawing/2014/main" id="{4C385A58-2ECD-47E7-AEA8-A2B1DA83AC23}"/>
               </a:ext>
             </a:extLst>
           </p:cNvPr>
@@ -12366,7 +12576,7 @@
           <p:cNvPr id="30" name="">
             <a:extLst xmlns:a="http://schemas.openxmlformats.org/drawingml/2006/main">
               <a:ext uri="{FF2B5EF4-FFF2-40B4-BE49-F238E27FC236}">
-                <a16:creationId xmlns:a16="http://schemas.microsoft.com/office/drawing/2014/main" id="{72A70B5A-39B2-4DBA-B536-B013B8037FD2}"/>
+                <a16:creationId xmlns:a16="http://schemas.microsoft.com/office/drawing/2014/main" id="{6EB446CF-4BB8-4229-B66C-E117C090A228}"/>
               </a:ext>
             </a:extLst>
           </p:cNvPr>
@@ -12422,7 +12632,7 @@
           <p:cNvPr id="31" name="">
             <a:extLst xmlns:a="http://schemas.openxmlformats.org/drawingml/2006/main">
               <a:ext uri="{FF2B5EF4-FFF2-40B4-BE49-F238E27FC236}">
-                <a16:creationId xmlns:a16="http://schemas.microsoft.com/office/drawing/2014/main" id="{DF4D03AC-1B71-4275-8C25-3CD6ECE7602F}"/>
+                <a16:creationId xmlns:a16="http://schemas.microsoft.com/office/drawing/2014/main" id="{D73E965C-CE4C-4EA4-B6A4-3AF1B481F5B0}"/>
               </a:ext>
             </a:extLst>
           </p:cNvPr>
@@ -12478,7 +12688,7 @@
           <p:cNvPr id="32" name="">
             <a:extLst xmlns:a="http://schemas.openxmlformats.org/drawingml/2006/main">
               <a:ext uri="{FF2B5EF4-FFF2-40B4-BE49-F238E27FC236}">
-                <a16:creationId xmlns:a16="http://schemas.microsoft.com/office/drawing/2014/main" id="{C3F63925-9F16-48C5-B950-7FC00DAC8D88}"/>
+                <a16:creationId xmlns:a16="http://schemas.microsoft.com/office/drawing/2014/main" id="{85C4BAAE-5DD2-4967-A1E0-FB20C59ED81F}"/>
               </a:ext>
             </a:extLst>
           </p:cNvPr>
@@ -12532,7 +12742,7 @@
     </p:spTree>
     <p:extLst>
       <p:ext uri="{BB962C8B-B14F-4D97-AF65-F5344CB8AC3E}">
-        <p14:creationId xmlns:p14="http://schemas.microsoft.com/office/powerpoint/2010/main" val="366605621"/>
+        <p14:creationId xmlns:p14="http://schemas.microsoft.com/office/powerpoint/2010/main" val="1270942459"/>
       </p:ext>
     </p:extLst>
   </p:cSld>
@@ -12563,7 +12773,7 @@
           <p:cNvPr id="1" name="">
             <a:extLst xmlns:a="http://schemas.openxmlformats.org/drawingml/2006/main">
               <a:ext uri="{FF2B5EF4-FFF2-40B4-BE49-F238E27FC236}">
-                <a16:creationId xmlns:a16="http://schemas.microsoft.com/office/drawing/2014/main" id="{AF049046-26FA-4466-A78D-6F30A742C4D6}"/>
+                <a16:creationId xmlns:a16="http://schemas.microsoft.com/office/drawing/2014/main" id="{C8FC0E6D-C160-4D93-A02D-B832A62D2208}"/>
               </a:ext>
             </a:extLst>
           </p:cNvPr>
@@ -12596,7 +12806,7 @@
           <p:cNvPr id="2" name="">
             <a:extLst xmlns:a="http://schemas.openxmlformats.org/drawingml/2006/main">
               <a:ext uri="{FF2B5EF4-FFF2-40B4-BE49-F238E27FC236}">
-                <a16:creationId xmlns:a16="http://schemas.microsoft.com/office/drawing/2014/main" id="{A2B85B04-41D8-4B30-B39B-CB79DE4DA1AC}"/>
+                <a16:creationId xmlns:a16="http://schemas.microsoft.com/office/drawing/2014/main" id="{23B36B99-E637-4827-997C-96A12F548E27}"/>
               </a:ext>
             </a:extLst>
           </p:cNvPr>
@@ -12652,7 +12862,7 @@
           <p:cNvPr id="3" name="">
             <a:extLst xmlns:a="http://schemas.openxmlformats.org/drawingml/2006/main">
               <a:ext uri="{FF2B5EF4-FFF2-40B4-BE49-F238E27FC236}">
-                <a16:creationId xmlns:a16="http://schemas.microsoft.com/office/drawing/2014/main" id="{05960798-E3EC-493A-B2AC-A35AE11A256C}"/>
+                <a16:creationId xmlns:a16="http://schemas.microsoft.com/office/drawing/2014/main" id="{010948B2-A07B-44F7-ACAB-8BB2EF4B046D}"/>
               </a:ext>
             </a:extLst>
           </p:cNvPr>
@@ -12708,7 +12918,7 @@
           <p:cNvPr id="4" name="">
             <a:extLst xmlns:a="http://schemas.openxmlformats.org/drawingml/2006/main">
               <a:ext uri="{FF2B5EF4-FFF2-40B4-BE49-F238E27FC236}">
-                <a16:creationId xmlns:a16="http://schemas.microsoft.com/office/drawing/2014/main" id="{56195F59-1AAF-47B3-BB11-53D7FE5EE1C7}"/>
+                <a16:creationId xmlns:a16="http://schemas.microsoft.com/office/drawing/2014/main" id="{7C17D1AB-74BD-4064-B1DA-422A956905A1}"/>
               </a:ext>
             </a:extLst>
           </p:cNvPr>
@@ -12764,7 +12974,7 @@
           <p:cNvPr id="5" name="">
             <a:extLst xmlns:a="http://schemas.openxmlformats.org/drawingml/2006/main">
               <a:ext uri="{FF2B5EF4-FFF2-40B4-BE49-F238E27FC236}">
-                <a16:creationId xmlns:a16="http://schemas.microsoft.com/office/drawing/2014/main" id="{8F5185AA-E6CA-47BB-934A-91612D2F5FEE}"/>
+                <a16:creationId xmlns:a16="http://schemas.microsoft.com/office/drawing/2014/main" id="{3E88FA83-7365-4A05-B026-AC2391F479B7}"/>
               </a:ext>
             </a:extLst>
           </p:cNvPr>
@@ -12799,7 +13009,7 @@
           <p:cNvPr id="6" name="">
             <a:extLst xmlns:a="http://schemas.openxmlformats.org/drawingml/2006/main">
               <a:ext uri="{FF2B5EF4-FFF2-40B4-BE49-F238E27FC236}">
-                <a16:creationId xmlns:a16="http://schemas.microsoft.com/office/drawing/2014/main" id="{C66BE31E-3228-42B7-A671-5557E392494F}"/>
+                <a16:creationId xmlns:a16="http://schemas.microsoft.com/office/drawing/2014/main" id="{BAB811DA-7AE7-439D-AE37-669371553336}"/>
               </a:ext>
             </a:extLst>
           </p:cNvPr>
@@ -12855,7 +13065,7 @@
           <p:cNvPr id="7" name="">
             <a:extLst xmlns:a="http://schemas.openxmlformats.org/drawingml/2006/main">
               <a:ext uri="{FF2B5EF4-FFF2-40B4-BE49-F238E27FC236}">
-                <a16:creationId xmlns:a16="http://schemas.microsoft.com/office/drawing/2014/main" id="{0B9D5F0C-495F-4D11-85CF-53A0D49F79DF}"/>
+                <a16:creationId xmlns:a16="http://schemas.microsoft.com/office/drawing/2014/main" id="{27229B9F-CF43-436E-ADBE-46DA2713D0E4}"/>
               </a:ext>
             </a:extLst>
           </p:cNvPr>
@@ -12911,7 +13121,7 @@
           <p:cNvPr id="8" name="">
             <a:extLst xmlns:a="http://schemas.openxmlformats.org/drawingml/2006/main">
               <a:ext uri="{FF2B5EF4-FFF2-40B4-BE49-F238E27FC236}">
-                <a16:creationId xmlns:a16="http://schemas.microsoft.com/office/drawing/2014/main" id="{A2FAA43F-3E58-4240-80B5-D1024E21D29F}"/>
+                <a16:creationId xmlns:a16="http://schemas.microsoft.com/office/drawing/2014/main" id="{B854C439-F3FB-425E-8C77-EC0F58708EDD}"/>
               </a:ext>
             </a:extLst>
           </p:cNvPr>
@@ -12967,7 +13177,7 @@
           <p:cNvPr id="9" name="">
             <a:extLst xmlns:a="http://schemas.openxmlformats.org/drawingml/2006/main">
               <a:ext uri="{FF2B5EF4-FFF2-40B4-BE49-F238E27FC236}">
-                <a16:creationId xmlns:a16="http://schemas.microsoft.com/office/drawing/2014/main" id="{DCF88FAB-023C-4723-A0F6-47D48BF2B7DA}"/>
+                <a16:creationId xmlns:a16="http://schemas.microsoft.com/office/drawing/2014/main" id="{3EF6BF43-892A-4CA5-868E-AB8D6A55BB5F}"/>
               </a:ext>
             </a:extLst>
           </p:cNvPr>
@@ -13002,7 +13212,7 @@
           <p:cNvPr id="10" name="">
             <a:extLst xmlns:a="http://schemas.openxmlformats.org/drawingml/2006/main">
               <a:ext uri="{FF2B5EF4-FFF2-40B4-BE49-F238E27FC236}">
-                <a16:creationId xmlns:a16="http://schemas.microsoft.com/office/drawing/2014/main" id="{309CB852-B0EB-45C9-A614-6219E1D6BD4F}"/>
+                <a16:creationId xmlns:a16="http://schemas.microsoft.com/office/drawing/2014/main" id="{EA80B0FA-A41D-4D20-9542-0AF3CF720BE3}"/>
               </a:ext>
             </a:extLst>
           </p:cNvPr>
@@ -13058,7 +13268,7 @@
           <p:cNvPr id="11" name="">
             <a:extLst xmlns:a="http://schemas.openxmlformats.org/drawingml/2006/main">
               <a:ext uri="{FF2B5EF4-FFF2-40B4-BE49-F238E27FC236}">
-                <a16:creationId xmlns:a16="http://schemas.microsoft.com/office/drawing/2014/main" id="{52804688-E646-4D0C-A6ED-0AE57F393469}"/>
+                <a16:creationId xmlns:a16="http://schemas.microsoft.com/office/drawing/2014/main" id="{B2EA0069-F348-4D0E-AADB-133EC37689A1}"/>
               </a:ext>
             </a:extLst>
           </p:cNvPr>
@@ -13114,7 +13324,7 @@
           <p:cNvPr id="12" name="">
             <a:extLst xmlns:a="http://schemas.openxmlformats.org/drawingml/2006/main">
               <a:ext uri="{FF2B5EF4-FFF2-40B4-BE49-F238E27FC236}">
-                <a16:creationId xmlns:a16="http://schemas.microsoft.com/office/drawing/2014/main" id="{B97436A7-DD39-4680-A4E3-6942D5887C4D}"/>
+                <a16:creationId xmlns:a16="http://schemas.microsoft.com/office/drawing/2014/main" id="{630D0FD5-A968-40C1-A04B-19CEE60E483B}"/>
               </a:ext>
             </a:extLst>
           </p:cNvPr>
@@ -13170,7 +13380,7 @@
           <p:cNvPr id="13" name="">
             <a:extLst xmlns:a="http://schemas.openxmlformats.org/drawingml/2006/main">
               <a:ext uri="{FF2B5EF4-FFF2-40B4-BE49-F238E27FC236}">
-                <a16:creationId xmlns:a16="http://schemas.microsoft.com/office/drawing/2014/main" id="{64646DB0-06E7-4A3F-BAE7-EFEB3D20126C}"/>
+                <a16:creationId xmlns:a16="http://schemas.microsoft.com/office/drawing/2014/main" id="{84A984B4-39B1-4245-9FF1-348883BE8B86}"/>
               </a:ext>
             </a:extLst>
           </p:cNvPr>
@@ -13203,7 +13413,7 @@
           <p:cNvPr id="14" name="">
             <a:extLst xmlns:a="http://schemas.openxmlformats.org/drawingml/2006/main">
               <a:ext uri="{FF2B5EF4-FFF2-40B4-BE49-F238E27FC236}">
-                <a16:creationId xmlns:a16="http://schemas.microsoft.com/office/drawing/2014/main" id="{0B3D73F5-0F4A-4105-9163-D84BEF62F2CE}"/>
+                <a16:creationId xmlns:a16="http://schemas.microsoft.com/office/drawing/2014/main" id="{A3080265-940E-41F1-889F-C59D75CA174B}"/>
               </a:ext>
             </a:extLst>
           </p:cNvPr>
@@ -13259,7 +13469,7 @@
           <p:cNvPr id="15" name="">
             <a:extLst xmlns:a="http://schemas.openxmlformats.org/drawingml/2006/main">
               <a:ext uri="{FF2B5EF4-FFF2-40B4-BE49-F238E27FC236}">
-                <a16:creationId xmlns:a16="http://schemas.microsoft.com/office/drawing/2014/main" id="{706A7581-8E00-4C9C-A205-34A632FB4DD3}"/>
+                <a16:creationId xmlns:a16="http://schemas.microsoft.com/office/drawing/2014/main" id="{33DD922E-9CBD-40B8-9AD7-1D1BA424A079}"/>
               </a:ext>
             </a:extLst>
           </p:cNvPr>
@@ -13313,7 +13523,7 @@
     </p:spTree>
     <p:extLst>
       <p:ext uri="{BB962C8B-B14F-4D97-AF65-F5344CB8AC3E}">
-        <p14:creationId xmlns:p14="http://schemas.microsoft.com/office/powerpoint/2010/main" val="1809638940"/>
+        <p14:creationId xmlns:p14="http://schemas.microsoft.com/office/powerpoint/2010/main" val="1453064705"/>
       </p:ext>
     </p:extLst>
   </p:cSld>
@@ -13344,7 +13554,7 @@
           <p:cNvPr id="1" name="">
             <a:extLst xmlns:a="http://schemas.openxmlformats.org/drawingml/2006/main">
               <a:ext uri="{FF2B5EF4-FFF2-40B4-BE49-F238E27FC236}">
-                <a16:creationId xmlns:a16="http://schemas.microsoft.com/office/drawing/2014/main" id="{D4541C23-CFDA-4870-A798-97C75E82EC81}"/>
+                <a16:creationId xmlns:a16="http://schemas.microsoft.com/office/drawing/2014/main" id="{4094A4CA-FCAF-4D7F-ADD3-AE25C37540F2}"/>
               </a:ext>
             </a:extLst>
           </p:cNvPr>
@@ -13377,7 +13587,7 @@
           <p:cNvPr id="2" name="">
             <a:extLst xmlns:a="http://schemas.openxmlformats.org/drawingml/2006/main">
               <a:ext uri="{FF2B5EF4-FFF2-40B4-BE49-F238E27FC236}">
-                <a16:creationId xmlns:a16="http://schemas.microsoft.com/office/drawing/2014/main" id="{144BB528-7864-40D1-A995-D0BDD37DC5A2}"/>
+                <a16:creationId xmlns:a16="http://schemas.microsoft.com/office/drawing/2014/main" id="{BF2B103D-62A0-4D09-A7FF-EDC5F1D20C99}"/>
               </a:ext>
             </a:extLst>
           </p:cNvPr>
@@ -13433,7 +13643,7 @@
           <p:cNvPr id="3" name="">
             <a:extLst xmlns:a="http://schemas.openxmlformats.org/drawingml/2006/main">
               <a:ext uri="{FF2B5EF4-FFF2-40B4-BE49-F238E27FC236}">
-                <a16:creationId xmlns:a16="http://schemas.microsoft.com/office/drawing/2014/main" id="{878F8501-7C8B-400F-AA9A-28C5D6BE6DA1}"/>
+                <a16:creationId xmlns:a16="http://schemas.microsoft.com/office/drawing/2014/main" id="{5D05701A-DC6F-4D52-8324-CF2A08E4F8FF}"/>
               </a:ext>
             </a:extLst>
           </p:cNvPr>
@@ -13489,7 +13699,7 @@
           <p:cNvPr id="4" name="">
             <a:extLst xmlns:a="http://schemas.openxmlformats.org/drawingml/2006/main">
               <a:ext uri="{FF2B5EF4-FFF2-40B4-BE49-F238E27FC236}">
-                <a16:creationId xmlns:a16="http://schemas.microsoft.com/office/drawing/2014/main" id="{2352CBDF-DC15-415D-9B1F-B981C2C06881}"/>
+                <a16:creationId xmlns:a16="http://schemas.microsoft.com/office/drawing/2014/main" id="{29BB2E21-215C-42AA-9B6A-9B35C73E8DFF}"/>
               </a:ext>
             </a:extLst>
           </p:cNvPr>
@@ -13545,7 +13755,7 @@
           <p:cNvPr id="5" name="">
             <a:extLst xmlns:a="http://schemas.openxmlformats.org/drawingml/2006/main">
               <a:ext uri="{FF2B5EF4-FFF2-40B4-BE49-F238E27FC236}">
-                <a16:creationId xmlns:a16="http://schemas.microsoft.com/office/drawing/2014/main" id="{FBCDFCC0-C0A1-4875-9C9F-C0C1D4F49D6D}"/>
+                <a16:creationId xmlns:a16="http://schemas.microsoft.com/office/drawing/2014/main" id="{8FACF23A-EF7B-4AFE-8662-ED5F7A32BB92}"/>
               </a:ext>
             </a:extLst>
           </p:cNvPr>
@@ -13580,7 +13790,7 @@
           <p:cNvPr id="6" name="">
             <a:extLst xmlns:a="http://schemas.openxmlformats.org/drawingml/2006/main">
               <a:ext uri="{FF2B5EF4-FFF2-40B4-BE49-F238E27FC236}">
-                <a16:creationId xmlns:a16="http://schemas.microsoft.com/office/drawing/2014/main" id="{76977DB7-0638-4C76-B6F5-A94B3038C7D3}"/>
+                <a16:creationId xmlns:a16="http://schemas.microsoft.com/office/drawing/2014/main" id="{68898968-4EBC-4A5D-A543-05D5D7BF0FD0}"/>
               </a:ext>
             </a:extLst>
           </p:cNvPr>
@@ -13636,7 +13846,7 @@
           <p:cNvPr id="7" name="">
             <a:extLst xmlns:a="http://schemas.openxmlformats.org/drawingml/2006/main">
               <a:ext uri="{FF2B5EF4-FFF2-40B4-BE49-F238E27FC236}">
-                <a16:creationId xmlns:a16="http://schemas.microsoft.com/office/drawing/2014/main" id="{21C94A8B-7AD7-4A45-BB57-A4EA410CAF83}"/>
+                <a16:creationId xmlns:a16="http://schemas.microsoft.com/office/drawing/2014/main" id="{4FE30C5B-F812-40EB-BC43-49E6D953B75D}"/>
               </a:ext>
             </a:extLst>
           </p:cNvPr>
@@ -13692,7 +13902,7 @@
           <p:cNvPr id="8" name="">
             <a:extLst xmlns:a="http://schemas.openxmlformats.org/drawingml/2006/main">
               <a:ext uri="{FF2B5EF4-FFF2-40B4-BE49-F238E27FC236}">
-                <a16:creationId xmlns:a16="http://schemas.microsoft.com/office/drawing/2014/main" id="{228EDA52-4C1B-4DE3-B083-7DC209B402B8}"/>
+                <a16:creationId xmlns:a16="http://schemas.microsoft.com/office/drawing/2014/main" id="{D38EB615-AAC1-413B-A5C3-5CB08E0E8DA6}"/>
               </a:ext>
             </a:extLst>
           </p:cNvPr>
@@ -13725,7 +13935,7 @@
           <p:cNvPr id="9" name="">
             <a:extLst xmlns:a="http://schemas.openxmlformats.org/drawingml/2006/main">
               <a:ext uri="{FF2B5EF4-FFF2-40B4-BE49-F238E27FC236}">
-                <a16:creationId xmlns:a16="http://schemas.microsoft.com/office/drawing/2014/main" id="{9927C92B-9BDE-4AF9-A1FC-04D4BB6D96F4}"/>
+                <a16:creationId xmlns:a16="http://schemas.microsoft.com/office/drawing/2014/main" id="{3AEBB82B-45B0-4309-A739-9031890F7F8C}"/>
               </a:ext>
             </a:extLst>
           </p:cNvPr>
@@ -13760,7 +13970,7 @@
           <p:cNvPr id="10" name="">
             <a:extLst xmlns:a="http://schemas.openxmlformats.org/drawingml/2006/main">
               <a:ext uri="{FF2B5EF4-FFF2-40B4-BE49-F238E27FC236}">
-                <a16:creationId xmlns:a16="http://schemas.microsoft.com/office/drawing/2014/main" id="{A2C1CCDD-80C8-4484-9891-B7F32E965547}"/>
+                <a16:creationId xmlns:a16="http://schemas.microsoft.com/office/drawing/2014/main" id="{F2EE9789-F9F3-4AD7-8AF1-B279E5B46974}"/>
               </a:ext>
             </a:extLst>
           </p:cNvPr>
@@ -13816,7 +14026,7 @@
           <p:cNvPr id="11" name="">
             <a:extLst xmlns:a="http://schemas.openxmlformats.org/drawingml/2006/main">
               <a:ext uri="{FF2B5EF4-FFF2-40B4-BE49-F238E27FC236}">
-                <a16:creationId xmlns:a16="http://schemas.microsoft.com/office/drawing/2014/main" id="{D697FA72-9B3B-4CBE-BD67-05279E9CF35F}"/>
+                <a16:creationId xmlns:a16="http://schemas.microsoft.com/office/drawing/2014/main" id="{5F720131-B943-4D21-B5BE-D12C020482D7}"/>
               </a:ext>
             </a:extLst>
           </p:cNvPr>
@@ -13872,7 +14082,7 @@
           <p:cNvPr id="12" name="">
             <a:extLst xmlns:a="http://schemas.openxmlformats.org/drawingml/2006/main">
               <a:ext uri="{FF2B5EF4-FFF2-40B4-BE49-F238E27FC236}">
-                <a16:creationId xmlns:a16="http://schemas.microsoft.com/office/drawing/2014/main" id="{4E35D183-9D2C-441E-A453-909465E67EE1}"/>
+                <a16:creationId xmlns:a16="http://schemas.microsoft.com/office/drawing/2014/main" id="{A7CD49B8-1E94-464E-91FA-D5EEDC1781D9}"/>
               </a:ext>
             </a:extLst>
           </p:cNvPr>
@@ -13905,7 +14115,7 @@
           <p:cNvPr id="13" name="">
             <a:extLst xmlns:a="http://schemas.openxmlformats.org/drawingml/2006/main">
               <a:ext uri="{FF2B5EF4-FFF2-40B4-BE49-F238E27FC236}">
-                <a16:creationId xmlns:a16="http://schemas.microsoft.com/office/drawing/2014/main" id="{44DF6D6B-CF66-441B-A1AD-5813C96CBF11}"/>
+                <a16:creationId xmlns:a16="http://schemas.microsoft.com/office/drawing/2014/main" id="{FE6CEC60-EBB4-428D-A9DE-9557BBE68795}"/>
               </a:ext>
             </a:extLst>
           </p:cNvPr>
@@ -13940,7 +14150,7 @@
           <p:cNvPr id="14" name="">
             <a:extLst xmlns:a="http://schemas.openxmlformats.org/drawingml/2006/main">
               <a:ext uri="{FF2B5EF4-FFF2-40B4-BE49-F238E27FC236}">
-                <a16:creationId xmlns:a16="http://schemas.microsoft.com/office/drawing/2014/main" id="{1535BF33-2A2C-4617-92BE-BC6462E64CD7}"/>
+                <a16:creationId xmlns:a16="http://schemas.microsoft.com/office/drawing/2014/main" id="{B6C0EB65-4709-4F85-8957-25E93FDCA6B3}"/>
               </a:ext>
             </a:extLst>
           </p:cNvPr>
@@ -13996,7 +14206,7 @@
           <p:cNvPr id="15" name="">
             <a:extLst xmlns:a="http://schemas.openxmlformats.org/drawingml/2006/main">
               <a:ext uri="{FF2B5EF4-FFF2-40B4-BE49-F238E27FC236}">
-                <a16:creationId xmlns:a16="http://schemas.microsoft.com/office/drawing/2014/main" id="{65A80D4C-A32C-40B0-BDB4-7B523DFE4BD0}"/>
+                <a16:creationId xmlns:a16="http://schemas.microsoft.com/office/drawing/2014/main" id="{78E90DC4-DA9E-4A02-8291-46D1B2BFE597}"/>
               </a:ext>
             </a:extLst>
           </p:cNvPr>
@@ -14052,7 +14262,7 @@
           <p:cNvPr id="16" name="">
             <a:extLst xmlns:a="http://schemas.openxmlformats.org/drawingml/2006/main">
               <a:ext uri="{FF2B5EF4-FFF2-40B4-BE49-F238E27FC236}">
-                <a16:creationId xmlns:a16="http://schemas.microsoft.com/office/drawing/2014/main" id="{16CA6B34-C356-4C70-8F23-A04CE84C26A0}"/>
+                <a16:creationId xmlns:a16="http://schemas.microsoft.com/office/drawing/2014/main" id="{FFCF54DB-B6D4-4271-A5DF-BCB68DE8B34F}"/>
               </a:ext>
             </a:extLst>
           </p:cNvPr>
@@ -14085,7 +14295,7 @@
           <p:cNvPr id="17" name="">
             <a:extLst xmlns:a="http://schemas.openxmlformats.org/drawingml/2006/main">
               <a:ext uri="{FF2B5EF4-FFF2-40B4-BE49-F238E27FC236}">
-                <a16:creationId xmlns:a16="http://schemas.microsoft.com/office/drawing/2014/main" id="{557EEB51-2B33-43C6-A1E8-274A3F747A3E}"/>
+                <a16:creationId xmlns:a16="http://schemas.microsoft.com/office/drawing/2014/main" id="{ADED88BA-04B6-4F04-87CC-767B53A9BFA7}"/>
               </a:ext>
             </a:extLst>
           </p:cNvPr>
@@ -14120,7 +14330,7 @@
           <p:cNvPr id="18" name="">
             <a:extLst xmlns:a="http://schemas.openxmlformats.org/drawingml/2006/main">
               <a:ext uri="{FF2B5EF4-FFF2-40B4-BE49-F238E27FC236}">
-                <a16:creationId xmlns:a16="http://schemas.microsoft.com/office/drawing/2014/main" id="{0A388A7C-69BA-468B-9ABD-8041BBF2982C}"/>
+                <a16:creationId xmlns:a16="http://schemas.microsoft.com/office/drawing/2014/main" id="{95E6A2F5-FE3C-4CAE-9A02-7C41776884DC}"/>
               </a:ext>
             </a:extLst>
           </p:cNvPr>
@@ -14176,7 +14386,7 @@
           <p:cNvPr id="19" name="">
             <a:extLst xmlns:a="http://schemas.openxmlformats.org/drawingml/2006/main">
               <a:ext uri="{FF2B5EF4-FFF2-40B4-BE49-F238E27FC236}">
-                <a16:creationId xmlns:a16="http://schemas.microsoft.com/office/drawing/2014/main" id="{915F4C47-2D44-4BF3-B7FC-F5ECF0508271}"/>
+                <a16:creationId xmlns:a16="http://schemas.microsoft.com/office/drawing/2014/main" id="{EF4797EF-633F-4D01-ADE7-EC6719167FAF}"/>
               </a:ext>
             </a:extLst>
           </p:cNvPr>
@@ -14232,7 +14442,7 @@
           <p:cNvPr id="20" name="">
             <a:extLst xmlns:a="http://schemas.openxmlformats.org/drawingml/2006/main">
               <a:ext uri="{FF2B5EF4-FFF2-40B4-BE49-F238E27FC236}">
-                <a16:creationId xmlns:a16="http://schemas.microsoft.com/office/drawing/2014/main" id="{38898A8D-948C-474B-A1D0-3979F4DBD06A}"/>
+                <a16:creationId xmlns:a16="http://schemas.microsoft.com/office/drawing/2014/main" id="{15833402-6E92-4E77-820C-997B223129AE}"/>
               </a:ext>
             </a:extLst>
           </p:cNvPr>
@@ -14265,7 +14475,7 @@
           <p:cNvPr id="21" name="">
             <a:extLst xmlns:a="http://schemas.openxmlformats.org/drawingml/2006/main">
               <a:ext uri="{FF2B5EF4-FFF2-40B4-BE49-F238E27FC236}">
-                <a16:creationId xmlns:a16="http://schemas.microsoft.com/office/drawing/2014/main" id="{2BA7E611-0ED5-4DEB-A7AA-DD969C34F027}"/>
+                <a16:creationId xmlns:a16="http://schemas.microsoft.com/office/drawing/2014/main" id="{D477156E-0266-4381-ADDB-53E06CC26EBB}"/>
               </a:ext>
             </a:extLst>
           </p:cNvPr>
@@ -14300,7 +14510,7 @@
           <p:cNvPr id="22" name="">
             <a:extLst xmlns:a="http://schemas.openxmlformats.org/drawingml/2006/main">
               <a:ext uri="{FF2B5EF4-FFF2-40B4-BE49-F238E27FC236}">
-                <a16:creationId xmlns:a16="http://schemas.microsoft.com/office/drawing/2014/main" id="{FE621F63-F60E-425D-B400-E9432B0BD309}"/>
+                <a16:creationId xmlns:a16="http://schemas.microsoft.com/office/drawing/2014/main" id="{19A04CA1-20D7-495E-A89C-522185D62FAF}"/>
               </a:ext>
             </a:extLst>
           </p:cNvPr>
@@ -14356,7 +14566,7 @@
           <p:cNvPr id="23" name="">
             <a:extLst xmlns:a="http://schemas.openxmlformats.org/drawingml/2006/main">
               <a:ext uri="{FF2B5EF4-FFF2-40B4-BE49-F238E27FC236}">
-                <a16:creationId xmlns:a16="http://schemas.microsoft.com/office/drawing/2014/main" id="{A60579FF-8E33-42DD-BC21-C9C47A1FDA51}"/>
+                <a16:creationId xmlns:a16="http://schemas.microsoft.com/office/drawing/2014/main" id="{F5DF54A7-FB15-4245-A22B-6B0340D7ED9C}"/>
               </a:ext>
             </a:extLst>
           </p:cNvPr>
@@ -14412,7 +14622,7 @@
           <p:cNvPr id="24" name="">
             <a:extLst xmlns:a="http://schemas.openxmlformats.org/drawingml/2006/main">
               <a:ext uri="{FF2B5EF4-FFF2-40B4-BE49-F238E27FC236}">
-                <a16:creationId xmlns:a16="http://schemas.microsoft.com/office/drawing/2014/main" id="{270943DE-925B-47C4-B801-556DFE9E028B}"/>
+                <a16:creationId xmlns:a16="http://schemas.microsoft.com/office/drawing/2014/main" id="{E8C3912E-6C1B-4277-AA54-3B0B11F576EB}"/>
               </a:ext>
             </a:extLst>
           </p:cNvPr>
@@ -14447,7 +14657,7 @@
           <p:cNvPr id="25" name="">
             <a:extLst xmlns:a="http://schemas.openxmlformats.org/drawingml/2006/main">
               <a:ext uri="{FF2B5EF4-FFF2-40B4-BE49-F238E27FC236}">
-                <a16:creationId xmlns:a16="http://schemas.microsoft.com/office/drawing/2014/main" id="{B0D1ADDC-6D63-471B-A846-F14DD35ED0CD}"/>
+                <a16:creationId xmlns:a16="http://schemas.microsoft.com/office/drawing/2014/main" id="{D0E6C1FA-D740-4FF7-846C-252E9DB42A09}"/>
               </a:ext>
             </a:extLst>
           </p:cNvPr>
@@ -14503,7 +14713,7 @@
           <p:cNvPr id="26" name="">
             <a:extLst xmlns:a="http://schemas.openxmlformats.org/drawingml/2006/main">
               <a:ext uri="{FF2B5EF4-FFF2-40B4-BE49-F238E27FC236}">
-                <a16:creationId xmlns:a16="http://schemas.microsoft.com/office/drawing/2014/main" id="{7DF78C85-B4D8-494F-B868-485C16C7CD9D}"/>
+                <a16:creationId xmlns:a16="http://schemas.microsoft.com/office/drawing/2014/main" id="{1DB17215-CBE6-4810-89EA-4A036802A76E}"/>
               </a:ext>
             </a:extLst>
           </p:cNvPr>
@@ -14559,7 +14769,7 @@
           <p:cNvPr id="27" name="">
             <a:extLst xmlns:a="http://schemas.openxmlformats.org/drawingml/2006/main">
               <a:ext uri="{FF2B5EF4-FFF2-40B4-BE49-F238E27FC236}">
-                <a16:creationId xmlns:a16="http://schemas.microsoft.com/office/drawing/2014/main" id="{05E7F255-B091-433F-B6D8-9E423B8A19C2}"/>
+                <a16:creationId xmlns:a16="http://schemas.microsoft.com/office/drawing/2014/main" id="{FAFAFBFA-8FD4-4D3A-8AF9-85159AC54C3A}"/>
               </a:ext>
             </a:extLst>
           </p:cNvPr>
@@ -14613,7 +14823,7 @@
     </p:spTree>
     <p:extLst>
       <p:ext uri="{BB962C8B-B14F-4D97-AF65-F5344CB8AC3E}">
-        <p14:creationId xmlns:p14="http://schemas.microsoft.com/office/powerpoint/2010/main" val="757121189"/>
+        <p14:creationId xmlns:p14="http://schemas.microsoft.com/office/powerpoint/2010/main" val="724370028"/>
       </p:ext>
     </p:extLst>
   </p:cSld>
@@ -14644,7 +14854,7 @@
           <p:cNvPr id="1" name="">
             <a:extLst xmlns:a="http://schemas.openxmlformats.org/drawingml/2006/main">
               <a:ext uri="{FF2B5EF4-FFF2-40B4-BE49-F238E27FC236}">
-                <a16:creationId xmlns:a16="http://schemas.microsoft.com/office/drawing/2014/main" id="{FD61718B-3591-40D9-9814-6C03A82B47A4}"/>
+                <a16:creationId xmlns:a16="http://schemas.microsoft.com/office/drawing/2014/main" id="{8B76EBE4-DF0A-4C26-9790-0477BA369C66}"/>
               </a:ext>
             </a:extLst>
           </p:cNvPr>
@@ -14677,7 +14887,7 @@
           <p:cNvPr id="2" name="">
             <a:extLst xmlns:a="http://schemas.openxmlformats.org/drawingml/2006/main">
               <a:ext uri="{FF2B5EF4-FFF2-40B4-BE49-F238E27FC236}">
-                <a16:creationId xmlns:a16="http://schemas.microsoft.com/office/drawing/2014/main" id="{A665C337-F750-4AB9-91C3-CFFF4C183433}"/>
+                <a16:creationId xmlns:a16="http://schemas.microsoft.com/office/drawing/2014/main" id="{5B73460A-61C6-4DEE-B183-54453E5776F5}"/>
               </a:ext>
             </a:extLst>
           </p:cNvPr>
@@ -14733,7 +14943,7 @@
           <p:cNvPr id="3" name="">
             <a:extLst xmlns:a="http://schemas.openxmlformats.org/drawingml/2006/main">
               <a:ext uri="{FF2B5EF4-FFF2-40B4-BE49-F238E27FC236}">
-                <a16:creationId xmlns:a16="http://schemas.microsoft.com/office/drawing/2014/main" id="{E3DABB4E-EA38-4F6B-B267-BC9EFB068CCE}"/>
+                <a16:creationId xmlns:a16="http://schemas.microsoft.com/office/drawing/2014/main" id="{D2E1ADFC-D141-46DA-A6C7-73EE99158C77}"/>
               </a:ext>
             </a:extLst>
           </p:cNvPr>
@@ -14789,7 +14999,7 @@
           <p:cNvPr id="4" name="">
             <a:extLst xmlns:a="http://schemas.openxmlformats.org/drawingml/2006/main">
               <a:ext uri="{FF2B5EF4-FFF2-40B4-BE49-F238E27FC236}">
-                <a16:creationId xmlns:a16="http://schemas.microsoft.com/office/drawing/2014/main" id="{42CE7DCD-DDD6-4ED4-BDB4-5FA6F3AAB73B}"/>
+                <a16:creationId xmlns:a16="http://schemas.microsoft.com/office/drawing/2014/main" id="{35F7E6F9-67C1-4B63-9EAD-4FE9226FB3B4}"/>
               </a:ext>
             </a:extLst>
           </p:cNvPr>
@@ -14845,7 +15055,7 @@
           <p:cNvPr id="5" name="">
             <a:extLst xmlns:a="http://schemas.openxmlformats.org/drawingml/2006/main">
               <a:ext uri="{FF2B5EF4-FFF2-40B4-BE49-F238E27FC236}">
-                <a16:creationId xmlns:a16="http://schemas.microsoft.com/office/drawing/2014/main" id="{88909EB4-2E3E-4F74-A3A1-ECBAAC3B93E6}"/>
+                <a16:creationId xmlns:a16="http://schemas.microsoft.com/office/drawing/2014/main" id="{D5A42AB7-0985-40CD-8A78-00F226736CF8}"/>
               </a:ext>
             </a:extLst>
           </p:cNvPr>
@@ -14880,7 +15090,7 @@
           <p:cNvPr id="6" name="">
             <a:extLst xmlns:a="http://schemas.openxmlformats.org/drawingml/2006/main">
               <a:ext uri="{FF2B5EF4-FFF2-40B4-BE49-F238E27FC236}">
-                <a16:creationId xmlns:a16="http://schemas.microsoft.com/office/drawing/2014/main" id="{ADA664C6-7C80-481E-8319-135BD0B04479}"/>
+                <a16:creationId xmlns:a16="http://schemas.microsoft.com/office/drawing/2014/main" id="{BB7525DA-2F08-4117-889D-B1D5CD3DF2D2}"/>
               </a:ext>
             </a:extLst>
           </p:cNvPr>
@@ -14936,7 +15146,7 @@
           <p:cNvPr id="7" name="">
             <a:extLst xmlns:a="http://schemas.openxmlformats.org/drawingml/2006/main">
               <a:ext uri="{FF2B5EF4-FFF2-40B4-BE49-F238E27FC236}">
-                <a16:creationId xmlns:a16="http://schemas.microsoft.com/office/drawing/2014/main" id="{EA1C4243-BE76-42B7-BFBD-321D7EE2AE2B}"/>
+                <a16:creationId xmlns:a16="http://schemas.microsoft.com/office/drawing/2014/main" id="{DC86F248-4275-4893-9F76-7FC413387030}"/>
               </a:ext>
             </a:extLst>
           </p:cNvPr>
@@ -14992,7 +15202,7 @@
           <p:cNvPr id="8" name="">
             <a:extLst xmlns:a="http://schemas.openxmlformats.org/drawingml/2006/main">
               <a:ext uri="{FF2B5EF4-FFF2-40B4-BE49-F238E27FC236}">
-                <a16:creationId xmlns:a16="http://schemas.microsoft.com/office/drawing/2014/main" id="{B2C3BB85-6106-4533-9E3D-A41E57792C40}"/>
+                <a16:creationId xmlns:a16="http://schemas.microsoft.com/office/drawing/2014/main" id="{F6CAF29A-E266-49BD-82E2-8F6A17B79F99}"/>
               </a:ext>
             </a:extLst>
           </p:cNvPr>
@@ -15048,7 +15258,7 @@
           <p:cNvPr id="9" name="">
             <a:extLst xmlns:a="http://schemas.openxmlformats.org/drawingml/2006/main">
               <a:ext uri="{FF2B5EF4-FFF2-40B4-BE49-F238E27FC236}">
-                <a16:creationId xmlns:a16="http://schemas.microsoft.com/office/drawing/2014/main" id="{B5A1B18B-9E1E-4211-ABC8-3A71443975E0}"/>
+                <a16:creationId xmlns:a16="http://schemas.microsoft.com/office/drawing/2014/main" id="{9F8B2E6F-974F-422E-9649-94DF8333F67F}"/>
               </a:ext>
             </a:extLst>
           </p:cNvPr>
@@ -15083,7 +15293,7 @@
           <p:cNvPr id="10" name="">
             <a:extLst xmlns:a="http://schemas.openxmlformats.org/drawingml/2006/main">
               <a:ext uri="{FF2B5EF4-FFF2-40B4-BE49-F238E27FC236}">
-                <a16:creationId xmlns:a16="http://schemas.microsoft.com/office/drawing/2014/main" id="{2EAB3F29-100A-4569-A5FE-DF5A0409EB3C}"/>
+                <a16:creationId xmlns:a16="http://schemas.microsoft.com/office/drawing/2014/main" id="{44A1AF8E-DED3-4282-9638-78CA802CB404}"/>
               </a:ext>
             </a:extLst>
           </p:cNvPr>
@@ -15139,7 +15349,7 @@
           <p:cNvPr id="11" name="">
             <a:extLst xmlns:a="http://schemas.openxmlformats.org/drawingml/2006/main">
               <a:ext uri="{FF2B5EF4-FFF2-40B4-BE49-F238E27FC236}">
-                <a16:creationId xmlns:a16="http://schemas.microsoft.com/office/drawing/2014/main" id="{D48CBF36-E7F6-46E6-BC15-0329FCF1DCE9}"/>
+                <a16:creationId xmlns:a16="http://schemas.microsoft.com/office/drawing/2014/main" id="{5FF1C21B-91D1-48A9-9C39-DB2924CCCD97}"/>
               </a:ext>
             </a:extLst>
           </p:cNvPr>
@@ -15195,7 +15405,7 @@
           <p:cNvPr id="12" name="">
             <a:extLst xmlns:a="http://schemas.openxmlformats.org/drawingml/2006/main">
               <a:ext uri="{FF2B5EF4-FFF2-40B4-BE49-F238E27FC236}">
-                <a16:creationId xmlns:a16="http://schemas.microsoft.com/office/drawing/2014/main" id="{0C4BB794-99D8-43FE-8D82-A3DA07F9FB6A}"/>
+                <a16:creationId xmlns:a16="http://schemas.microsoft.com/office/drawing/2014/main" id="{110F4A01-AE0E-4D51-8028-9C4CEE684D5E}"/>
               </a:ext>
             </a:extLst>
           </p:cNvPr>
@@ -15251,7 +15461,7 @@
           <p:cNvPr id="13" name="">
             <a:extLst xmlns:a="http://schemas.openxmlformats.org/drawingml/2006/main">
               <a:ext uri="{FF2B5EF4-FFF2-40B4-BE49-F238E27FC236}">
-                <a16:creationId xmlns:a16="http://schemas.microsoft.com/office/drawing/2014/main" id="{9718BD4F-28B0-4ADC-8C81-54501A556A2D}"/>
+                <a16:creationId xmlns:a16="http://schemas.microsoft.com/office/drawing/2014/main" id="{D4DC5AB8-C545-411F-A45F-74058FCCBE31}"/>
               </a:ext>
             </a:extLst>
           </p:cNvPr>
@@ -15286,7 +15496,7 @@
           <p:cNvPr id="14" name="">
             <a:extLst xmlns:a="http://schemas.openxmlformats.org/drawingml/2006/main">
               <a:ext uri="{FF2B5EF4-FFF2-40B4-BE49-F238E27FC236}">
-                <a16:creationId xmlns:a16="http://schemas.microsoft.com/office/drawing/2014/main" id="{F954AABC-0134-4388-884E-6B21CF5CCC7D}"/>
+                <a16:creationId xmlns:a16="http://schemas.microsoft.com/office/drawing/2014/main" id="{C2179392-1745-40AC-A2A2-452A38A6B4A2}"/>
               </a:ext>
             </a:extLst>
           </p:cNvPr>
@@ -15342,7 +15552,7 @@
           <p:cNvPr id="15" name="">
             <a:extLst xmlns:a="http://schemas.openxmlformats.org/drawingml/2006/main">
               <a:ext uri="{FF2B5EF4-FFF2-40B4-BE49-F238E27FC236}">
-                <a16:creationId xmlns:a16="http://schemas.microsoft.com/office/drawing/2014/main" id="{17099625-2D8E-4186-9C91-77B4DA164E4C}"/>
+                <a16:creationId xmlns:a16="http://schemas.microsoft.com/office/drawing/2014/main" id="{A61A91EA-E1AE-4143-8D27-165003C0C7EA}"/>
               </a:ext>
             </a:extLst>
           </p:cNvPr>
@@ -15398,7 +15608,7 @@
           <p:cNvPr id="16" name="">
             <a:extLst xmlns:a="http://schemas.openxmlformats.org/drawingml/2006/main">
               <a:ext uri="{FF2B5EF4-FFF2-40B4-BE49-F238E27FC236}">
-                <a16:creationId xmlns:a16="http://schemas.microsoft.com/office/drawing/2014/main" id="{72DF7556-FF16-46D3-8344-47EFC1C68F0D}"/>
+                <a16:creationId xmlns:a16="http://schemas.microsoft.com/office/drawing/2014/main" id="{20080E1D-9587-48B0-8334-BA3B2FB0E5F4}"/>
               </a:ext>
             </a:extLst>
           </p:cNvPr>
@@ -15454,7 +15664,7 @@
           <p:cNvPr id="17" name="">
             <a:extLst xmlns:a="http://schemas.openxmlformats.org/drawingml/2006/main">
               <a:ext uri="{FF2B5EF4-FFF2-40B4-BE49-F238E27FC236}">
-                <a16:creationId xmlns:a16="http://schemas.microsoft.com/office/drawing/2014/main" id="{DC7C290F-4D6C-495C-944C-1177ED5AC0C2}"/>
+                <a16:creationId xmlns:a16="http://schemas.microsoft.com/office/drawing/2014/main" id="{01659C47-8B5F-4014-8196-6602B30928CC}"/>
               </a:ext>
             </a:extLst>
           </p:cNvPr>
@@ -15510,7 +15720,7 @@
           <p:cNvPr id="18" name="">
             <a:extLst xmlns:a="http://schemas.openxmlformats.org/drawingml/2006/main">
               <a:ext uri="{FF2B5EF4-FFF2-40B4-BE49-F238E27FC236}">
-                <a16:creationId xmlns:a16="http://schemas.microsoft.com/office/drawing/2014/main" id="{A9F112F2-7140-44CE-B059-228BABBD8CAC}"/>
+                <a16:creationId xmlns:a16="http://schemas.microsoft.com/office/drawing/2014/main" id="{50810000-329D-4715-B7B0-F8FE720BC163}"/>
               </a:ext>
             </a:extLst>
           </p:cNvPr>
@@ -15564,7 +15774,7 @@
     </p:spTree>
     <p:extLst>
       <p:ext uri="{BB962C8B-B14F-4D97-AF65-F5344CB8AC3E}">
-        <p14:creationId xmlns:p14="http://schemas.microsoft.com/office/powerpoint/2010/main" val="2024307579"/>
+        <p14:creationId xmlns:p14="http://schemas.microsoft.com/office/powerpoint/2010/main" val="1997466900"/>
       </p:ext>
     </p:extLst>
   </p:cSld>
@@ -15595,7 +15805,7 @@
           <p:cNvPr id="1" name="">
             <a:extLst xmlns:a="http://schemas.openxmlformats.org/drawingml/2006/main">
               <a:ext uri="{FF2B5EF4-FFF2-40B4-BE49-F238E27FC236}">
-                <a16:creationId xmlns:a16="http://schemas.microsoft.com/office/drawing/2014/main" id="{A47037A1-83BC-41A4-BDA0-480E4F4C024D}"/>
+                <a16:creationId xmlns:a16="http://schemas.microsoft.com/office/drawing/2014/main" id="{8032F002-7133-4BEF-989C-F6A0688732EB}"/>
               </a:ext>
             </a:extLst>
           </p:cNvPr>
@@ -15628,7 +15838,7 @@
           <p:cNvPr id="2" name="">
             <a:extLst xmlns:a="http://schemas.openxmlformats.org/drawingml/2006/main">
               <a:ext uri="{FF2B5EF4-FFF2-40B4-BE49-F238E27FC236}">
-                <a16:creationId xmlns:a16="http://schemas.microsoft.com/office/drawing/2014/main" id="{AFB4C144-5D2B-46BE-B43A-029AE712B762}"/>
+                <a16:creationId xmlns:a16="http://schemas.microsoft.com/office/drawing/2014/main" id="{9E40E48E-AB28-4D62-B646-5E489EB8BE3A}"/>
               </a:ext>
             </a:extLst>
           </p:cNvPr>
@@ -15684,7 +15894,7 @@
           <p:cNvPr id="3" name="">
             <a:extLst xmlns:a="http://schemas.openxmlformats.org/drawingml/2006/main">
               <a:ext uri="{FF2B5EF4-FFF2-40B4-BE49-F238E27FC236}">
-                <a16:creationId xmlns:a16="http://schemas.microsoft.com/office/drawing/2014/main" id="{0CBA20C8-63A5-4711-8968-A4A6CC517C94}"/>
+                <a16:creationId xmlns:a16="http://schemas.microsoft.com/office/drawing/2014/main" id="{D47554CB-333D-419A-9E2F-3F22D7989049}"/>
               </a:ext>
             </a:extLst>
           </p:cNvPr>
@@ -15740,7 +15950,7 @@
           <p:cNvPr id="4" name="">
             <a:extLst xmlns:a="http://schemas.openxmlformats.org/drawingml/2006/main">
               <a:ext uri="{FF2B5EF4-FFF2-40B4-BE49-F238E27FC236}">
-                <a16:creationId xmlns:a16="http://schemas.microsoft.com/office/drawing/2014/main" id="{074BAADD-FFFC-48F8-8F77-E6215B99ED34}"/>
+                <a16:creationId xmlns:a16="http://schemas.microsoft.com/office/drawing/2014/main" id="{148BEEC5-4210-436C-86D8-F71B692B1DAA}"/>
               </a:ext>
             </a:extLst>
           </p:cNvPr>
@@ -15796,7 +16006,7 @@
           <p:cNvPr id="5" name="">
             <a:extLst xmlns:a="http://schemas.openxmlformats.org/drawingml/2006/main">
               <a:ext uri="{FF2B5EF4-FFF2-40B4-BE49-F238E27FC236}">
-                <a16:creationId xmlns:a16="http://schemas.microsoft.com/office/drawing/2014/main" id="{843CDB60-DD38-45EC-8817-980583BEEF23}"/>
+                <a16:creationId xmlns:a16="http://schemas.microsoft.com/office/drawing/2014/main" id="{F6DB90D0-8589-484F-AB3C-D4B90AB37D1C}"/>
               </a:ext>
             </a:extLst>
           </p:cNvPr>
@@ -15831,7 +16041,7 @@
           <p:cNvPr id="6" name="">
             <a:extLst xmlns:a="http://schemas.openxmlformats.org/drawingml/2006/main">
               <a:ext uri="{FF2B5EF4-FFF2-40B4-BE49-F238E27FC236}">
-                <a16:creationId xmlns:a16="http://schemas.microsoft.com/office/drawing/2014/main" id="{FDB67E1F-12A6-49AD-AAB0-E1C68B30AF4D}"/>
+                <a16:creationId xmlns:a16="http://schemas.microsoft.com/office/drawing/2014/main" id="{A0D5B79D-68BE-48DD-8516-58FF13F1C32B}"/>
               </a:ext>
             </a:extLst>
           </p:cNvPr>
@@ -15887,7 +16097,7 @@
           <p:cNvPr id="7" name="">
             <a:extLst xmlns:a="http://schemas.openxmlformats.org/drawingml/2006/main">
               <a:ext uri="{FF2B5EF4-FFF2-40B4-BE49-F238E27FC236}">
-                <a16:creationId xmlns:a16="http://schemas.microsoft.com/office/drawing/2014/main" id="{369BD914-C779-4B57-861B-66B434406B65}"/>
+                <a16:creationId xmlns:a16="http://schemas.microsoft.com/office/drawing/2014/main" id="{50F41D44-3B21-4A8A-ABB3-7A9738B54201}"/>
               </a:ext>
             </a:extLst>
           </p:cNvPr>
@@ -15943,7 +16153,7 @@
           <p:cNvPr id="8" name="">
             <a:extLst xmlns:a="http://schemas.openxmlformats.org/drawingml/2006/main">
               <a:ext uri="{FF2B5EF4-FFF2-40B4-BE49-F238E27FC236}">
-                <a16:creationId xmlns:a16="http://schemas.microsoft.com/office/drawing/2014/main" id="{F39B605B-395F-4B76-B6A4-631AE2A898E5}"/>
+                <a16:creationId xmlns:a16="http://schemas.microsoft.com/office/drawing/2014/main" id="{42F10DDF-DD4E-4F26-9F23-73812F674464}"/>
               </a:ext>
             </a:extLst>
           </p:cNvPr>
@@ -15978,7 +16188,7 @@
           <p:cNvPr id="9" name="">
             <a:extLst xmlns:a="http://schemas.openxmlformats.org/drawingml/2006/main">
               <a:ext uri="{FF2B5EF4-FFF2-40B4-BE49-F238E27FC236}">
-                <a16:creationId xmlns:a16="http://schemas.microsoft.com/office/drawing/2014/main" id="{B83DE123-3C45-4858-899E-1AC7A757D14A}"/>
+                <a16:creationId xmlns:a16="http://schemas.microsoft.com/office/drawing/2014/main" id="{81EDF26C-25D9-44CF-B38B-E3401D62CEAD}"/>
               </a:ext>
             </a:extLst>
           </p:cNvPr>
@@ -16011,7 +16221,7 @@
           <p:cNvPr id="10" name="">
             <a:extLst xmlns:a="http://schemas.openxmlformats.org/drawingml/2006/main">
               <a:ext uri="{FF2B5EF4-FFF2-40B4-BE49-F238E27FC236}">
-                <a16:creationId xmlns:a16="http://schemas.microsoft.com/office/drawing/2014/main" id="{8049EDF7-9159-4505-A2CF-4FC8EE7C7E39}"/>
+                <a16:creationId xmlns:a16="http://schemas.microsoft.com/office/drawing/2014/main" id="{E3460C28-56F9-4A83-B499-3F587F8FF386}"/>
               </a:ext>
             </a:extLst>
           </p:cNvPr>
@@ -16067,7 +16277,7 @@
           <p:cNvPr id="11" name="">
             <a:extLst xmlns:a="http://schemas.openxmlformats.org/drawingml/2006/main">
               <a:ext uri="{FF2B5EF4-FFF2-40B4-BE49-F238E27FC236}">
-                <a16:creationId xmlns:a16="http://schemas.microsoft.com/office/drawing/2014/main" id="{66524819-5CB8-403B-B47E-29E0490FD305}"/>
+                <a16:creationId xmlns:a16="http://schemas.microsoft.com/office/drawing/2014/main" id="{E6633384-CFEE-48CC-AAEF-27D714BEA878}"/>
               </a:ext>
             </a:extLst>
           </p:cNvPr>
@@ -16123,7 +16333,7 @@
           <p:cNvPr id="12" name="">
             <a:extLst xmlns:a="http://schemas.openxmlformats.org/drawingml/2006/main">
               <a:ext uri="{FF2B5EF4-FFF2-40B4-BE49-F238E27FC236}">
-                <a16:creationId xmlns:a16="http://schemas.microsoft.com/office/drawing/2014/main" id="{700BEA6E-FAD0-4D90-B206-E9C146D48C1A}"/>
+                <a16:creationId xmlns:a16="http://schemas.microsoft.com/office/drawing/2014/main" id="{1318A255-7637-4EA2-A538-5F261858BE43}"/>
               </a:ext>
             </a:extLst>
           </p:cNvPr>
@@ -16158,7 +16368,7 @@
           <p:cNvPr id="13" name="">
             <a:extLst xmlns:a="http://schemas.openxmlformats.org/drawingml/2006/main">
               <a:ext uri="{FF2B5EF4-FFF2-40B4-BE49-F238E27FC236}">
-                <a16:creationId xmlns:a16="http://schemas.microsoft.com/office/drawing/2014/main" id="{88E676B8-9550-48F2-AC23-DF1D4C52384A}"/>
+                <a16:creationId xmlns:a16="http://schemas.microsoft.com/office/drawing/2014/main" id="{8A76BF03-6505-467C-A240-FDA759FE0C3D}"/>
               </a:ext>
             </a:extLst>
           </p:cNvPr>
@@ -16191,7 +16401,7 @@
           <p:cNvPr id="14" name="">
             <a:extLst xmlns:a="http://schemas.openxmlformats.org/drawingml/2006/main">
               <a:ext uri="{FF2B5EF4-FFF2-40B4-BE49-F238E27FC236}">
-                <a16:creationId xmlns:a16="http://schemas.microsoft.com/office/drawing/2014/main" id="{B4538E0F-DD65-4C1D-9361-510999DCDDD7}"/>
+                <a16:creationId xmlns:a16="http://schemas.microsoft.com/office/drawing/2014/main" id="{449E68D3-826C-4DD5-8D2C-D16BBD8ECC45}"/>
               </a:ext>
             </a:extLst>
           </p:cNvPr>
@@ -16247,7 +16457,7 @@
           <p:cNvPr id="15" name="">
             <a:extLst xmlns:a="http://schemas.openxmlformats.org/drawingml/2006/main">
               <a:ext uri="{FF2B5EF4-FFF2-40B4-BE49-F238E27FC236}">
-                <a16:creationId xmlns:a16="http://schemas.microsoft.com/office/drawing/2014/main" id="{1F7C23CD-8F55-4305-A79C-0CF86AEBE1CC}"/>
+                <a16:creationId xmlns:a16="http://schemas.microsoft.com/office/drawing/2014/main" id="{AC6568A9-C2C9-49C9-99D2-5B414AB0C02C}"/>
               </a:ext>
             </a:extLst>
           </p:cNvPr>
@@ -16303,7 +16513,7 @@
           <p:cNvPr id="16" name="">
             <a:extLst xmlns:a="http://schemas.openxmlformats.org/drawingml/2006/main">
               <a:ext uri="{FF2B5EF4-FFF2-40B4-BE49-F238E27FC236}">
-                <a16:creationId xmlns:a16="http://schemas.microsoft.com/office/drawing/2014/main" id="{80995CB8-08E6-4726-A520-580B2F992FEA}"/>
+                <a16:creationId xmlns:a16="http://schemas.microsoft.com/office/drawing/2014/main" id="{098C3FCB-2201-4505-B657-11D2A38EAEC5}"/>
               </a:ext>
             </a:extLst>
           </p:cNvPr>
@@ -16338,7 +16548,7 @@
           <p:cNvPr id="17" name="">
             <a:extLst xmlns:a="http://schemas.openxmlformats.org/drawingml/2006/main">
               <a:ext uri="{FF2B5EF4-FFF2-40B4-BE49-F238E27FC236}">
-                <a16:creationId xmlns:a16="http://schemas.microsoft.com/office/drawing/2014/main" id="{08242C7A-0F3B-48D2-AD1D-D6451E97E812}"/>
+                <a16:creationId xmlns:a16="http://schemas.microsoft.com/office/drawing/2014/main" id="{1DB0651B-E954-4A41-8507-31F3687C89CC}"/>
               </a:ext>
             </a:extLst>
           </p:cNvPr>
@@ -16371,7 +16581,7 @@
           <p:cNvPr id="18" name="">
             <a:extLst xmlns:a="http://schemas.openxmlformats.org/drawingml/2006/main">
               <a:ext uri="{FF2B5EF4-FFF2-40B4-BE49-F238E27FC236}">
-                <a16:creationId xmlns:a16="http://schemas.microsoft.com/office/drawing/2014/main" id="{D0C87AB2-3309-4E20-91AF-A7138022F775}"/>
+                <a16:creationId xmlns:a16="http://schemas.microsoft.com/office/drawing/2014/main" id="{D5128A64-3B3E-4B36-9233-CF07D59C9394}"/>
               </a:ext>
             </a:extLst>
           </p:cNvPr>
@@ -16427,7 +16637,7 @@
           <p:cNvPr id="19" name="">
             <a:extLst xmlns:a="http://schemas.openxmlformats.org/drawingml/2006/main">
               <a:ext uri="{FF2B5EF4-FFF2-40B4-BE49-F238E27FC236}">
-                <a16:creationId xmlns:a16="http://schemas.microsoft.com/office/drawing/2014/main" id="{4A80976C-55F5-4E30-A367-80F4B0499752}"/>
+                <a16:creationId xmlns:a16="http://schemas.microsoft.com/office/drawing/2014/main" id="{5B4B295D-4D54-4C55-ABEE-7CA5490855E8}"/>
               </a:ext>
             </a:extLst>
           </p:cNvPr>
@@ -16483,7 +16693,7 @@
           <p:cNvPr id="20" name="">
             <a:extLst xmlns:a="http://schemas.openxmlformats.org/drawingml/2006/main">
               <a:ext uri="{FF2B5EF4-FFF2-40B4-BE49-F238E27FC236}">
-                <a16:creationId xmlns:a16="http://schemas.microsoft.com/office/drawing/2014/main" id="{5A8AA431-90B9-4F99-8162-34AC169D8CD5}"/>
+                <a16:creationId xmlns:a16="http://schemas.microsoft.com/office/drawing/2014/main" id="{C8A0AF35-C400-4582-8A0D-1F89E20F8EDF}"/>
               </a:ext>
             </a:extLst>
           </p:cNvPr>
@@ -16518,7 +16728,7 @@
           <p:cNvPr id="21" name="">
             <a:extLst xmlns:a="http://schemas.openxmlformats.org/drawingml/2006/main">
               <a:ext uri="{FF2B5EF4-FFF2-40B4-BE49-F238E27FC236}">
-                <a16:creationId xmlns:a16="http://schemas.microsoft.com/office/drawing/2014/main" id="{6C8BAF98-821B-41E4-A978-D99F290F0CD6}"/>
+                <a16:creationId xmlns:a16="http://schemas.microsoft.com/office/drawing/2014/main" id="{3384D4CF-CE00-4FB5-B938-06CE3C9D3304}"/>
               </a:ext>
             </a:extLst>
           </p:cNvPr>
@@ -16551,7 +16761,7 @@
           <p:cNvPr id="22" name="">
             <a:extLst xmlns:a="http://schemas.openxmlformats.org/drawingml/2006/main">
               <a:ext uri="{FF2B5EF4-FFF2-40B4-BE49-F238E27FC236}">
-                <a16:creationId xmlns:a16="http://schemas.microsoft.com/office/drawing/2014/main" id="{EEE27B5D-72E0-47ED-93F1-B5E0CC252320}"/>
+                <a16:creationId xmlns:a16="http://schemas.microsoft.com/office/drawing/2014/main" id="{2B0133E5-B7DD-43F6-8563-1DBAA19F5686}"/>
               </a:ext>
             </a:extLst>
           </p:cNvPr>
@@ -16607,7 +16817,7 @@
           <p:cNvPr id="23" name="">
             <a:extLst xmlns:a="http://schemas.openxmlformats.org/drawingml/2006/main">
               <a:ext uri="{FF2B5EF4-FFF2-40B4-BE49-F238E27FC236}">
-                <a16:creationId xmlns:a16="http://schemas.microsoft.com/office/drawing/2014/main" id="{65DC8D87-52E4-4B6C-8438-5E7B75F4B547}"/>
+                <a16:creationId xmlns:a16="http://schemas.microsoft.com/office/drawing/2014/main" id="{7122973E-7C4E-4F1C-BF28-7A0CD1A2F119}"/>
               </a:ext>
             </a:extLst>
           </p:cNvPr>
@@ -16642,7 +16852,7 @@
           <p:cNvPr id="24" name="">
             <a:extLst xmlns:a="http://schemas.openxmlformats.org/drawingml/2006/main">
               <a:ext uri="{FF2B5EF4-FFF2-40B4-BE49-F238E27FC236}">
-                <a16:creationId xmlns:a16="http://schemas.microsoft.com/office/drawing/2014/main" id="{8B157C4B-7DBD-4B61-8F82-59ECFF323229}"/>
+                <a16:creationId xmlns:a16="http://schemas.microsoft.com/office/drawing/2014/main" id="{E73B146C-BC3F-4F8C-8BFB-1348D068A98F}"/>
               </a:ext>
             </a:extLst>
           </p:cNvPr>
@@ -16677,7 +16887,7 @@
           <p:cNvPr id="25" name="">
             <a:extLst xmlns:a="http://schemas.openxmlformats.org/drawingml/2006/main">
               <a:ext uri="{FF2B5EF4-FFF2-40B4-BE49-F238E27FC236}">
-                <a16:creationId xmlns:a16="http://schemas.microsoft.com/office/drawing/2014/main" id="{30B45631-BA0B-483D-AC74-9EA06C9A804A}"/>
+                <a16:creationId xmlns:a16="http://schemas.microsoft.com/office/drawing/2014/main" id="{0EBE7BAC-83B1-41A6-A810-FAE1F2363A43}"/>
               </a:ext>
             </a:extLst>
           </p:cNvPr>
@@ -16710,7 +16920,7 @@
           <p:cNvPr id="26" name="">
             <a:extLst xmlns:a="http://schemas.openxmlformats.org/drawingml/2006/main">
               <a:ext uri="{FF2B5EF4-FFF2-40B4-BE49-F238E27FC236}">
-                <a16:creationId xmlns:a16="http://schemas.microsoft.com/office/drawing/2014/main" id="{4AE04BF2-1559-4229-BEE8-54E83EB8F6D5}"/>
+                <a16:creationId xmlns:a16="http://schemas.microsoft.com/office/drawing/2014/main" id="{FD6EEF10-5667-4397-9A1C-813FA33035FD}"/>
               </a:ext>
             </a:extLst>
           </p:cNvPr>
@@ -16766,7 +16976,7 @@
           <p:cNvPr id="27" name="">
             <a:extLst xmlns:a="http://schemas.openxmlformats.org/drawingml/2006/main">
               <a:ext uri="{FF2B5EF4-FFF2-40B4-BE49-F238E27FC236}">
-                <a16:creationId xmlns:a16="http://schemas.microsoft.com/office/drawing/2014/main" id="{CE4CE1D0-B98E-47F9-910C-8BEADD26B92D}"/>
+                <a16:creationId xmlns:a16="http://schemas.microsoft.com/office/drawing/2014/main" id="{384B9940-EF5F-4757-B197-4ACAC2CA9F37}"/>
               </a:ext>
             </a:extLst>
           </p:cNvPr>
@@ -16822,7 +17032,7 @@
           <p:cNvPr id="28" name="">
             <a:extLst xmlns:a="http://schemas.openxmlformats.org/drawingml/2006/main">
               <a:ext uri="{FF2B5EF4-FFF2-40B4-BE49-F238E27FC236}">
-                <a16:creationId xmlns:a16="http://schemas.microsoft.com/office/drawing/2014/main" id="{F41A0AC4-3BDD-473D-A7B0-9BF5B842A973}"/>
+                <a16:creationId xmlns:a16="http://schemas.microsoft.com/office/drawing/2014/main" id="{1EC0AE04-A59F-4FB9-BBAC-7491303B6D60}"/>
               </a:ext>
             </a:extLst>
           </p:cNvPr>
@@ -16878,7 +17088,7 @@
           <p:cNvPr id="29" name="">
             <a:extLst xmlns:a="http://schemas.openxmlformats.org/drawingml/2006/main">
               <a:ext uri="{FF2B5EF4-FFF2-40B4-BE49-F238E27FC236}">
-                <a16:creationId xmlns:a16="http://schemas.microsoft.com/office/drawing/2014/main" id="{52EBFBA0-5C03-49F7-B6E8-0FB3E3BBCBE6}"/>
+                <a16:creationId xmlns:a16="http://schemas.microsoft.com/office/drawing/2014/main" id="{3E901481-DC42-4A1A-81D5-DE6AC3B46091}"/>
               </a:ext>
             </a:extLst>
           </p:cNvPr>
@@ -16913,7 +17123,7 @@
           <p:cNvPr id="30" name="">
             <a:extLst xmlns:a="http://schemas.openxmlformats.org/drawingml/2006/main">
               <a:ext uri="{FF2B5EF4-FFF2-40B4-BE49-F238E27FC236}">
-                <a16:creationId xmlns:a16="http://schemas.microsoft.com/office/drawing/2014/main" id="{DD94BA05-BEDC-4D82-A829-F7BC9326992D}"/>
+                <a16:creationId xmlns:a16="http://schemas.microsoft.com/office/drawing/2014/main" id="{01333F07-4B52-4A1B-9EF3-54F44B56220E}"/>
               </a:ext>
             </a:extLst>
           </p:cNvPr>
@@ -16946,7 +17156,7 @@
           <p:cNvPr id="31" name="">
             <a:extLst xmlns:a="http://schemas.openxmlformats.org/drawingml/2006/main">
               <a:ext uri="{FF2B5EF4-FFF2-40B4-BE49-F238E27FC236}">
-                <a16:creationId xmlns:a16="http://schemas.microsoft.com/office/drawing/2014/main" id="{FD328866-BED0-44B2-A9E1-9C66738CDE49}"/>
+                <a16:creationId xmlns:a16="http://schemas.microsoft.com/office/drawing/2014/main" id="{D0C53B3A-B348-4D1F-ABFE-42366F83E540}"/>
               </a:ext>
             </a:extLst>
           </p:cNvPr>
@@ -17002,7 +17212,7 @@
           <p:cNvPr id="32" name="">
             <a:extLst xmlns:a="http://schemas.openxmlformats.org/drawingml/2006/main">
               <a:ext uri="{FF2B5EF4-FFF2-40B4-BE49-F238E27FC236}">
-                <a16:creationId xmlns:a16="http://schemas.microsoft.com/office/drawing/2014/main" id="{E4055533-5C39-4334-A0FC-EB8E7F1F00BD}"/>
+                <a16:creationId xmlns:a16="http://schemas.microsoft.com/office/drawing/2014/main" id="{D0B74C25-53FF-45FC-A60D-E810C2F4AD79}"/>
               </a:ext>
             </a:extLst>
           </p:cNvPr>
@@ -17058,7 +17268,7 @@
           <p:cNvPr id="33" name="">
             <a:extLst xmlns:a="http://schemas.openxmlformats.org/drawingml/2006/main">
               <a:ext uri="{FF2B5EF4-FFF2-40B4-BE49-F238E27FC236}">
-                <a16:creationId xmlns:a16="http://schemas.microsoft.com/office/drawing/2014/main" id="{92955C20-D3B0-41B6-BDB2-BC0C5EBA718E}"/>
+                <a16:creationId xmlns:a16="http://schemas.microsoft.com/office/drawing/2014/main" id="{FBA03F86-865E-48AA-B1E7-676FFA4CBBDF}"/>
               </a:ext>
             </a:extLst>
           </p:cNvPr>
@@ -17114,7 +17324,7 @@
           <p:cNvPr id="34" name="">
             <a:extLst xmlns:a="http://schemas.openxmlformats.org/drawingml/2006/main">
               <a:ext uri="{FF2B5EF4-FFF2-40B4-BE49-F238E27FC236}">
-                <a16:creationId xmlns:a16="http://schemas.microsoft.com/office/drawing/2014/main" id="{CEEA660C-9479-4079-BB02-EB993364978E}"/>
+                <a16:creationId xmlns:a16="http://schemas.microsoft.com/office/drawing/2014/main" id="{6C2104FD-14FB-469E-A08D-001C4A2EC8AE}"/>
               </a:ext>
             </a:extLst>
           </p:cNvPr>
@@ -17170,7 +17380,7 @@
           <p:cNvPr id="35" name="">
             <a:extLst xmlns:a="http://schemas.openxmlformats.org/drawingml/2006/main">
               <a:ext uri="{FF2B5EF4-FFF2-40B4-BE49-F238E27FC236}">
-                <a16:creationId xmlns:a16="http://schemas.microsoft.com/office/drawing/2014/main" id="{3A3C93A9-AB6E-4347-8C4F-1F6718D631AB}"/>
+                <a16:creationId xmlns:a16="http://schemas.microsoft.com/office/drawing/2014/main" id="{2AFD393C-22D4-43E7-B8B2-8EF3B1E972D1}"/>
               </a:ext>
             </a:extLst>
           </p:cNvPr>
@@ -17224,7 +17434,7 @@
     </p:spTree>
     <p:extLst>
       <p:ext uri="{BB962C8B-B14F-4D97-AF65-F5344CB8AC3E}">
-        <p14:creationId xmlns:p14="http://schemas.microsoft.com/office/powerpoint/2010/main" val="1613778026"/>
+        <p14:creationId xmlns:p14="http://schemas.microsoft.com/office/powerpoint/2010/main" val="1136801343"/>
       </p:ext>
     </p:extLst>
   </p:cSld>
@@ -17255,7 +17465,7 @@
           <p:cNvPr id="1" name="">
             <a:extLst xmlns:a="http://schemas.openxmlformats.org/drawingml/2006/main">
               <a:ext uri="{FF2B5EF4-FFF2-40B4-BE49-F238E27FC236}">
-                <a16:creationId xmlns:a16="http://schemas.microsoft.com/office/drawing/2014/main" id="{7A83841A-BBDD-4F70-80E6-58A108761220}"/>
+                <a16:creationId xmlns:a16="http://schemas.microsoft.com/office/drawing/2014/main" id="{6F5CB282-2B22-4385-9247-72505447E4E1}"/>
               </a:ext>
             </a:extLst>
           </p:cNvPr>
@@ -17288,7 +17498,7 @@
           <p:cNvPr id="2" name="">
             <a:extLst xmlns:a="http://schemas.openxmlformats.org/drawingml/2006/main">
               <a:ext uri="{FF2B5EF4-FFF2-40B4-BE49-F238E27FC236}">
-                <a16:creationId xmlns:a16="http://schemas.microsoft.com/office/drawing/2014/main" id="{3F6D1145-4673-47FB-BA8E-64EE036D077A}"/>
+                <a16:creationId xmlns:a16="http://schemas.microsoft.com/office/drawing/2014/main" id="{8FF6F390-2AC4-4268-9A43-BDE3625855FC}"/>
               </a:ext>
             </a:extLst>
           </p:cNvPr>
@@ -17344,7 +17554,7 @@
           <p:cNvPr id="3" name="">
             <a:extLst xmlns:a="http://schemas.openxmlformats.org/drawingml/2006/main">
               <a:ext uri="{FF2B5EF4-FFF2-40B4-BE49-F238E27FC236}">
-                <a16:creationId xmlns:a16="http://schemas.microsoft.com/office/drawing/2014/main" id="{040E846A-CB7A-47F4-AF82-A123D5956198}"/>
+                <a16:creationId xmlns:a16="http://schemas.microsoft.com/office/drawing/2014/main" id="{0F2C7AE3-A15C-47F8-82DC-7B18C10BC9EA}"/>
               </a:ext>
             </a:extLst>
           </p:cNvPr>
@@ -17400,7 +17610,7 @@
           <p:cNvPr id="4" name="">
             <a:extLst xmlns:a="http://schemas.openxmlformats.org/drawingml/2006/main">
               <a:ext uri="{FF2B5EF4-FFF2-40B4-BE49-F238E27FC236}">
-                <a16:creationId xmlns:a16="http://schemas.microsoft.com/office/drawing/2014/main" id="{30909605-BCF0-4EFA-B941-08A50A53A4AF}"/>
+                <a16:creationId xmlns:a16="http://schemas.microsoft.com/office/drawing/2014/main" id="{969031CA-2579-4EC5-A03F-E259FEA13F81}"/>
               </a:ext>
             </a:extLst>
           </p:cNvPr>
@@ -17456,7 +17666,7 @@
           <p:cNvPr id="5" name="">
             <a:extLst xmlns:a="http://schemas.openxmlformats.org/drawingml/2006/main">
               <a:ext uri="{FF2B5EF4-FFF2-40B4-BE49-F238E27FC236}">
-                <a16:creationId xmlns:a16="http://schemas.microsoft.com/office/drawing/2014/main" id="{89BBD228-7BED-4EEF-8F86-152E1A194142}"/>
+                <a16:creationId xmlns:a16="http://schemas.microsoft.com/office/drawing/2014/main" id="{9E26436C-EB3A-402D-93EA-4B16736FEEF8}"/>
               </a:ext>
             </a:extLst>
           </p:cNvPr>
@@ -17491,7 +17701,7 @@
           <p:cNvPr id="6" name="">
             <a:extLst xmlns:a="http://schemas.openxmlformats.org/drawingml/2006/main">
               <a:ext uri="{FF2B5EF4-FFF2-40B4-BE49-F238E27FC236}">
-                <a16:creationId xmlns:a16="http://schemas.microsoft.com/office/drawing/2014/main" id="{0FDFD517-853D-4A05-9ABC-9644E1DB81A1}"/>
+                <a16:creationId xmlns:a16="http://schemas.microsoft.com/office/drawing/2014/main" id="{DA980E29-A202-4C30-B6F3-B8C85052B5A1}"/>
               </a:ext>
             </a:extLst>
           </p:cNvPr>
@@ -17547,7 +17757,7 @@
           <p:cNvPr id="7" name="">
             <a:extLst xmlns:a="http://schemas.openxmlformats.org/drawingml/2006/main">
               <a:ext uri="{FF2B5EF4-FFF2-40B4-BE49-F238E27FC236}">
-                <a16:creationId xmlns:a16="http://schemas.microsoft.com/office/drawing/2014/main" id="{5BEE85B3-5862-4F1F-9A4D-AD1E52450F01}"/>
+                <a16:creationId xmlns:a16="http://schemas.microsoft.com/office/drawing/2014/main" id="{44C43CC1-DB54-46BE-9372-F47E60DA031A}"/>
               </a:ext>
             </a:extLst>
           </p:cNvPr>
@@ -17626,7 +17836,7 @@
           <p:cNvPr id="8" name="">
             <a:extLst xmlns:a="http://schemas.openxmlformats.org/drawingml/2006/main">
               <a:ext uri="{FF2B5EF4-FFF2-40B4-BE49-F238E27FC236}">
-                <a16:creationId xmlns:a16="http://schemas.microsoft.com/office/drawing/2014/main" id="{7CF2D88E-E11F-44E8-860D-73C29F62D74E}"/>
+                <a16:creationId xmlns:a16="http://schemas.microsoft.com/office/drawing/2014/main" id="{D5CDA1D3-572D-41A0-B43D-9DFEC6CF6429}"/>
               </a:ext>
             </a:extLst>
           </p:cNvPr>
@@ -17682,7 +17892,7 @@
           <p:cNvPr id="9" name="">
             <a:extLst xmlns:a="http://schemas.openxmlformats.org/drawingml/2006/main">
               <a:ext uri="{FF2B5EF4-FFF2-40B4-BE49-F238E27FC236}">
-                <a16:creationId xmlns:a16="http://schemas.microsoft.com/office/drawing/2014/main" id="{975B7C00-EBC7-4659-926E-FAC1AD930144}"/>
+                <a16:creationId xmlns:a16="http://schemas.microsoft.com/office/drawing/2014/main" id="{53B861A4-9423-4DC5-A4F9-D6972AB2F8C0}"/>
               </a:ext>
             </a:extLst>
           </p:cNvPr>
@@ -17717,7 +17927,7 @@
           <p:cNvPr id="10" name="">
             <a:extLst xmlns:a="http://schemas.openxmlformats.org/drawingml/2006/main">
               <a:ext uri="{FF2B5EF4-FFF2-40B4-BE49-F238E27FC236}">
-                <a16:creationId xmlns:a16="http://schemas.microsoft.com/office/drawing/2014/main" id="{13EB8AB1-FCF8-4523-8A84-9818189D4175}"/>
+                <a16:creationId xmlns:a16="http://schemas.microsoft.com/office/drawing/2014/main" id="{8F719C03-39C0-4A6D-8A22-A9BAAF72C301}"/>
               </a:ext>
             </a:extLst>
           </p:cNvPr>
@@ -17773,7 +17983,7 @@
           <p:cNvPr id="11" name="">
             <a:extLst xmlns:a="http://schemas.openxmlformats.org/drawingml/2006/main">
               <a:ext uri="{FF2B5EF4-FFF2-40B4-BE49-F238E27FC236}">
-                <a16:creationId xmlns:a16="http://schemas.microsoft.com/office/drawing/2014/main" id="{0276FB56-250E-400A-882D-38782B401A47}"/>
+                <a16:creationId xmlns:a16="http://schemas.microsoft.com/office/drawing/2014/main" id="{A3C595AA-1CE0-4E2F-A1F9-7B8392155A86}"/>
               </a:ext>
             </a:extLst>
           </p:cNvPr>
@@ -17852,7 +18062,7 @@
           <p:cNvPr id="12" name="">
             <a:extLst xmlns:a="http://schemas.openxmlformats.org/drawingml/2006/main">
               <a:ext uri="{FF2B5EF4-FFF2-40B4-BE49-F238E27FC236}">
-                <a16:creationId xmlns:a16="http://schemas.microsoft.com/office/drawing/2014/main" id="{4F04E9C4-84F0-4D0E-8A88-0964836A48F5}"/>
+                <a16:creationId xmlns:a16="http://schemas.microsoft.com/office/drawing/2014/main" id="{49ECFFAF-39EE-4608-97F7-F4C096705ACC}"/>
               </a:ext>
             </a:extLst>
           </p:cNvPr>
@@ -17908,7 +18118,7 @@
           <p:cNvPr id="13" name="">
             <a:extLst xmlns:a="http://schemas.openxmlformats.org/drawingml/2006/main">
               <a:ext uri="{FF2B5EF4-FFF2-40B4-BE49-F238E27FC236}">
-                <a16:creationId xmlns:a16="http://schemas.microsoft.com/office/drawing/2014/main" id="{D9E3F221-65A8-4482-81C3-F09C7FA66B45}"/>
+                <a16:creationId xmlns:a16="http://schemas.microsoft.com/office/drawing/2014/main" id="{625079E1-EC41-4CA5-81B7-74CE384CE1FC}"/>
               </a:ext>
             </a:extLst>
           </p:cNvPr>
@@ -17964,7 +18174,7 @@
           <p:cNvPr id="14" name="">
             <a:extLst xmlns:a="http://schemas.openxmlformats.org/drawingml/2006/main">
               <a:ext uri="{FF2B5EF4-FFF2-40B4-BE49-F238E27FC236}">
-                <a16:creationId xmlns:a16="http://schemas.microsoft.com/office/drawing/2014/main" id="{B4BB751B-BA1D-47D4-BF53-C53481CB076B}"/>
+                <a16:creationId xmlns:a16="http://schemas.microsoft.com/office/drawing/2014/main" id="{9B925452-E680-4A44-95E8-34325E16A842}"/>
               </a:ext>
             </a:extLst>
           </p:cNvPr>
@@ -18018,7 +18228,7 @@
     </p:spTree>
     <p:extLst>
       <p:ext uri="{BB962C8B-B14F-4D97-AF65-F5344CB8AC3E}">
-        <p14:creationId xmlns:p14="http://schemas.microsoft.com/office/powerpoint/2010/main" val="1783882212"/>
+        <p14:creationId xmlns:p14="http://schemas.microsoft.com/office/powerpoint/2010/main" val="221336691"/>
       </p:ext>
     </p:extLst>
   </p:cSld>
@@ -18049,7 +18259,7 @@
           <p:cNvPr id="1" name="">
             <a:extLst xmlns:a="http://schemas.openxmlformats.org/drawingml/2006/main">
               <a:ext uri="{FF2B5EF4-FFF2-40B4-BE49-F238E27FC236}">
-                <a16:creationId xmlns:a16="http://schemas.microsoft.com/office/drawing/2014/main" id="{4A1C7696-7557-4209-AC1C-74471584EC79}"/>
+                <a16:creationId xmlns:a16="http://schemas.microsoft.com/office/drawing/2014/main" id="{2E09B628-B244-4FA7-8501-B86A0CD34120}"/>
               </a:ext>
             </a:extLst>
           </p:cNvPr>
@@ -18082,7 +18292,7 @@
           <p:cNvPr id="2" name="">
             <a:extLst xmlns:a="http://schemas.openxmlformats.org/drawingml/2006/main">
               <a:ext uri="{FF2B5EF4-FFF2-40B4-BE49-F238E27FC236}">
-                <a16:creationId xmlns:a16="http://schemas.microsoft.com/office/drawing/2014/main" id="{14EA45A0-6C7D-4052-8F09-23F76FFD6E47}"/>
+                <a16:creationId xmlns:a16="http://schemas.microsoft.com/office/drawing/2014/main" id="{F9413980-0ACD-4028-AD8E-F31893CBBA15}"/>
               </a:ext>
             </a:extLst>
           </p:cNvPr>
@@ -18138,7 +18348,7 @@
           <p:cNvPr id="3" name="">
             <a:extLst xmlns:a="http://schemas.openxmlformats.org/drawingml/2006/main">
               <a:ext uri="{FF2B5EF4-FFF2-40B4-BE49-F238E27FC236}">
-                <a16:creationId xmlns:a16="http://schemas.microsoft.com/office/drawing/2014/main" id="{777066CE-9B49-49D8-BE8B-63A5DFD2C4DD}"/>
+                <a16:creationId xmlns:a16="http://schemas.microsoft.com/office/drawing/2014/main" id="{85ADDB6E-090A-49BF-9505-9EF82EDB2E46}"/>
               </a:ext>
             </a:extLst>
           </p:cNvPr>
@@ -18194,7 +18404,7 @@
           <p:cNvPr id="4" name="">
             <a:extLst xmlns:a="http://schemas.openxmlformats.org/drawingml/2006/main">
               <a:ext uri="{FF2B5EF4-FFF2-40B4-BE49-F238E27FC236}">
-                <a16:creationId xmlns:a16="http://schemas.microsoft.com/office/drawing/2014/main" id="{10D828A3-16FE-4626-86CF-6685678614CB}"/>
+                <a16:creationId xmlns:a16="http://schemas.microsoft.com/office/drawing/2014/main" id="{2D6D4891-4E45-4AE8-8855-38E5D5EAB973}"/>
               </a:ext>
             </a:extLst>
           </p:cNvPr>
@@ -18250,7 +18460,7 @@
           <p:cNvPr id="5" name="">
             <a:extLst xmlns:a="http://schemas.openxmlformats.org/drawingml/2006/main">
               <a:ext uri="{FF2B5EF4-FFF2-40B4-BE49-F238E27FC236}">
-                <a16:creationId xmlns:a16="http://schemas.microsoft.com/office/drawing/2014/main" id="{21C2CAB8-43F5-4ED5-BDAA-11E00F7C1A4B}"/>
+                <a16:creationId xmlns:a16="http://schemas.microsoft.com/office/drawing/2014/main" id="{5692D28B-CCFA-4D89-A90E-B8406F1012AB}"/>
               </a:ext>
             </a:extLst>
           </p:cNvPr>
@@ -18306,7 +18516,7 @@
           <p:cNvPr id="6" name="">
             <a:extLst xmlns:a="http://schemas.openxmlformats.org/drawingml/2006/main">
               <a:ext uri="{FF2B5EF4-FFF2-40B4-BE49-F238E27FC236}">
-                <a16:creationId xmlns:a16="http://schemas.microsoft.com/office/drawing/2014/main" id="{96654298-9972-4494-BA06-6495A2D03A9A}"/>
+                <a16:creationId xmlns:a16="http://schemas.microsoft.com/office/drawing/2014/main" id="{7E6FA65D-15DF-4348-8B5C-D23362E41113}"/>
               </a:ext>
             </a:extLst>
           </p:cNvPr>
@@ -18341,7 +18551,7 @@
           <p:cNvPr id="7" name="">
             <a:extLst xmlns:a="http://schemas.openxmlformats.org/drawingml/2006/main">
               <a:ext uri="{FF2B5EF4-FFF2-40B4-BE49-F238E27FC236}">
-                <a16:creationId xmlns:a16="http://schemas.microsoft.com/office/drawing/2014/main" id="{86C7DCAC-F73A-4859-8F5F-65824664E83C}"/>
+                <a16:creationId xmlns:a16="http://schemas.microsoft.com/office/drawing/2014/main" id="{D9BC0C7B-AC74-4AD4-8271-E4CC6337B5D2}"/>
               </a:ext>
             </a:extLst>
           </p:cNvPr>
@@ -18397,7 +18607,7 @@
           <p:cNvPr id="8" name="">
             <a:extLst xmlns:a="http://schemas.openxmlformats.org/drawingml/2006/main">
               <a:ext uri="{FF2B5EF4-FFF2-40B4-BE49-F238E27FC236}">
-                <a16:creationId xmlns:a16="http://schemas.microsoft.com/office/drawing/2014/main" id="{BA5174DA-2D35-4907-9D02-33BA9A511557}"/>
+                <a16:creationId xmlns:a16="http://schemas.microsoft.com/office/drawing/2014/main" id="{07599D94-6E5D-4996-B9D0-788655F19684}"/>
               </a:ext>
             </a:extLst>
           </p:cNvPr>
@@ -18435,7 +18645,7 @@
           <p:cNvPr id="9" name="">
             <a:extLst xmlns:a="http://schemas.openxmlformats.org/drawingml/2006/main">
               <a:ext uri="{FF2B5EF4-FFF2-40B4-BE49-F238E27FC236}">
-                <a16:creationId xmlns:a16="http://schemas.microsoft.com/office/drawing/2014/main" id="{9B447B3D-9042-4D6B-9BB6-EA563A765D61}"/>
+                <a16:creationId xmlns:a16="http://schemas.microsoft.com/office/drawing/2014/main" id="{F90DF323-8D2C-4EA3-9D1E-44C766CEA4C2}"/>
               </a:ext>
             </a:extLst>
           </p:cNvPr>
@@ -18468,7 +18678,7 @@
           <p:cNvPr id="10" name="">
             <a:extLst xmlns:a="http://schemas.openxmlformats.org/drawingml/2006/main">
               <a:ext uri="{FF2B5EF4-FFF2-40B4-BE49-F238E27FC236}">
-                <a16:creationId xmlns:a16="http://schemas.microsoft.com/office/drawing/2014/main" id="{C8AB3395-6CA7-4F84-9E66-D6F0BE3BCD78}"/>
+                <a16:creationId xmlns:a16="http://schemas.microsoft.com/office/drawing/2014/main" id="{A7EC7026-428E-4956-9DF0-ACE4C7651D69}"/>
               </a:ext>
             </a:extLst>
           </p:cNvPr>
@@ -18503,7 +18713,7 @@
           <p:cNvPr id="11" name="">
             <a:extLst xmlns:a="http://schemas.openxmlformats.org/drawingml/2006/main">
               <a:ext uri="{FF2B5EF4-FFF2-40B4-BE49-F238E27FC236}">
-                <a16:creationId xmlns:a16="http://schemas.microsoft.com/office/drawing/2014/main" id="{91BD80C4-2E5A-4BDE-9B91-69A7086B7902}"/>
+                <a16:creationId xmlns:a16="http://schemas.microsoft.com/office/drawing/2014/main" id="{8869586A-F0F7-486C-A412-26F03AEF3E6E}"/>
               </a:ext>
             </a:extLst>
           </p:cNvPr>
@@ -18559,7 +18769,7 @@
           <p:cNvPr id="12" name="">
             <a:extLst xmlns:a="http://schemas.openxmlformats.org/drawingml/2006/main">
               <a:ext uri="{FF2B5EF4-FFF2-40B4-BE49-F238E27FC236}">
-                <a16:creationId xmlns:a16="http://schemas.microsoft.com/office/drawing/2014/main" id="{7E70E59C-0A5C-44A0-8771-DFC3CCC6DFA7}"/>
+                <a16:creationId xmlns:a16="http://schemas.microsoft.com/office/drawing/2014/main" id="{464977AC-0F2E-4CC5-9170-BA593B006EF9}"/>
               </a:ext>
             </a:extLst>
           </p:cNvPr>
@@ -18615,7 +18825,7 @@
           <p:cNvPr id="13" name="">
             <a:extLst xmlns:a="http://schemas.openxmlformats.org/drawingml/2006/main">
               <a:ext uri="{FF2B5EF4-FFF2-40B4-BE49-F238E27FC236}">
-                <a16:creationId xmlns:a16="http://schemas.microsoft.com/office/drawing/2014/main" id="{0712AA33-9848-4EAD-922F-F4751123C529}"/>
+                <a16:creationId xmlns:a16="http://schemas.microsoft.com/office/drawing/2014/main" id="{BCD8D2C3-B8EF-4D41-925E-A900580211FB}"/>
               </a:ext>
             </a:extLst>
           </p:cNvPr>
@@ -18671,7 +18881,7 @@
           <p:cNvPr id="14" name="">
             <a:extLst xmlns:a="http://schemas.openxmlformats.org/drawingml/2006/main">
               <a:ext uri="{FF2B5EF4-FFF2-40B4-BE49-F238E27FC236}">
-                <a16:creationId xmlns:a16="http://schemas.microsoft.com/office/drawing/2014/main" id="{4DB5B239-DED6-421C-A562-CB839009D898}"/>
+                <a16:creationId xmlns:a16="http://schemas.microsoft.com/office/drawing/2014/main" id="{736F433C-F35B-4B49-B2A2-C10E25331348}"/>
               </a:ext>
             </a:extLst>
           </p:cNvPr>
@@ -18706,7 +18916,7 @@
           <p:cNvPr id="15" name="">
             <a:extLst xmlns:a="http://schemas.openxmlformats.org/drawingml/2006/main">
               <a:ext uri="{FF2B5EF4-FFF2-40B4-BE49-F238E27FC236}">
-                <a16:creationId xmlns:a16="http://schemas.microsoft.com/office/drawing/2014/main" id="{7E88799D-1B5D-48D4-9519-49DAFEF6EDA3}"/>
+                <a16:creationId xmlns:a16="http://schemas.microsoft.com/office/drawing/2014/main" id="{3BFB143F-CFFF-4557-AE6C-237AD8A774AA}"/>
               </a:ext>
             </a:extLst>
           </p:cNvPr>
@@ -18762,7 +18972,7 @@
           <p:cNvPr id="16" name="">
             <a:extLst xmlns:a="http://schemas.openxmlformats.org/drawingml/2006/main">
               <a:ext uri="{FF2B5EF4-FFF2-40B4-BE49-F238E27FC236}">
-                <a16:creationId xmlns:a16="http://schemas.microsoft.com/office/drawing/2014/main" id="{CD02F07C-5F04-4A44-8C0F-838EE2873DC6}"/>
+                <a16:creationId xmlns:a16="http://schemas.microsoft.com/office/drawing/2014/main" id="{C9FF3EB6-6857-4669-97FA-537B0E6E32ED}"/>
               </a:ext>
             </a:extLst>
           </p:cNvPr>
@@ -18800,7 +19010,7 @@
           <p:cNvPr id="17" name="">
             <a:extLst xmlns:a="http://schemas.openxmlformats.org/drawingml/2006/main">
               <a:ext uri="{FF2B5EF4-FFF2-40B4-BE49-F238E27FC236}">
-                <a16:creationId xmlns:a16="http://schemas.microsoft.com/office/drawing/2014/main" id="{7DEA8E49-8E7F-4936-8308-A469F2903EFC}"/>
+                <a16:creationId xmlns:a16="http://schemas.microsoft.com/office/drawing/2014/main" id="{4E80935B-1A9D-44A5-ABE7-EC7ECA8C534E}"/>
               </a:ext>
             </a:extLst>
           </p:cNvPr>
@@ -18833,7 +19043,7 @@
           <p:cNvPr id="18" name="">
             <a:extLst xmlns:a="http://schemas.openxmlformats.org/drawingml/2006/main">
               <a:ext uri="{FF2B5EF4-FFF2-40B4-BE49-F238E27FC236}">
-                <a16:creationId xmlns:a16="http://schemas.microsoft.com/office/drawing/2014/main" id="{2C2BF8C7-DB3E-4851-A169-D23A7B9AFD2F}"/>
+                <a16:creationId xmlns:a16="http://schemas.microsoft.com/office/drawing/2014/main" id="{CA7A28DC-A1F3-4670-A0CE-C5DC7904ED4D}"/>
               </a:ext>
             </a:extLst>
           </p:cNvPr>
@@ -18868,7 +19078,7 @@
           <p:cNvPr id="19" name="">
             <a:extLst xmlns:a="http://schemas.openxmlformats.org/drawingml/2006/main">
               <a:ext uri="{FF2B5EF4-FFF2-40B4-BE49-F238E27FC236}">
-                <a16:creationId xmlns:a16="http://schemas.microsoft.com/office/drawing/2014/main" id="{5C7A44A4-239E-4B05-B43C-23FD5EC9BD9C}"/>
+                <a16:creationId xmlns:a16="http://schemas.microsoft.com/office/drawing/2014/main" id="{373F18BE-5755-41BB-AF0F-8A5D7F14EDAC}"/>
               </a:ext>
             </a:extLst>
           </p:cNvPr>
@@ -18924,7 +19134,7 @@
           <p:cNvPr id="20" name="">
             <a:extLst xmlns:a="http://schemas.openxmlformats.org/drawingml/2006/main">
               <a:ext uri="{FF2B5EF4-FFF2-40B4-BE49-F238E27FC236}">
-                <a16:creationId xmlns:a16="http://schemas.microsoft.com/office/drawing/2014/main" id="{403E58ED-5368-402C-83B4-D04EEE9A0BE0}"/>
+                <a16:creationId xmlns:a16="http://schemas.microsoft.com/office/drawing/2014/main" id="{A3973ECD-4CEB-4252-A6FA-865CC99F4F10}"/>
               </a:ext>
             </a:extLst>
           </p:cNvPr>
@@ -18980,7 +19190,7 @@
           <p:cNvPr id="21" name="">
             <a:extLst xmlns:a="http://schemas.openxmlformats.org/drawingml/2006/main">
               <a:ext uri="{FF2B5EF4-FFF2-40B4-BE49-F238E27FC236}">
-                <a16:creationId xmlns:a16="http://schemas.microsoft.com/office/drawing/2014/main" id="{FFEF2BD2-9A29-40B2-A8EA-AE4665D50689}"/>
+                <a16:creationId xmlns:a16="http://schemas.microsoft.com/office/drawing/2014/main" id="{9F956923-1890-4953-BE91-0303FA853D07}"/>
               </a:ext>
             </a:extLst>
           </p:cNvPr>
@@ -19013,7 +19223,7 @@
           <p:cNvPr id="22" name="">
             <a:extLst xmlns:a="http://schemas.openxmlformats.org/drawingml/2006/main">
               <a:ext uri="{FF2B5EF4-FFF2-40B4-BE49-F238E27FC236}">
-                <a16:creationId xmlns:a16="http://schemas.microsoft.com/office/drawing/2014/main" id="{A5EA523A-C5B8-42FE-AA0C-A5C9D4ABA345}"/>
+                <a16:creationId xmlns:a16="http://schemas.microsoft.com/office/drawing/2014/main" id="{7B8ECB55-D0D4-4F12-BB48-3D914AE3BD60}"/>
               </a:ext>
             </a:extLst>
           </p:cNvPr>
@@ -19048,7 +19258,7 @@
           <p:cNvPr id="23" name="">
             <a:extLst xmlns:a="http://schemas.openxmlformats.org/drawingml/2006/main">
               <a:ext uri="{FF2B5EF4-FFF2-40B4-BE49-F238E27FC236}">
-                <a16:creationId xmlns:a16="http://schemas.microsoft.com/office/drawing/2014/main" id="{B0D94EBC-98D3-4942-B96D-340DBE051CB7}"/>
+                <a16:creationId xmlns:a16="http://schemas.microsoft.com/office/drawing/2014/main" id="{C509D738-1706-4D56-8D92-224F12FC5126}"/>
               </a:ext>
             </a:extLst>
           </p:cNvPr>
@@ -19104,7 +19314,7 @@
           <p:cNvPr id="24" name="">
             <a:extLst xmlns:a="http://schemas.openxmlformats.org/drawingml/2006/main">
               <a:ext uri="{FF2B5EF4-FFF2-40B4-BE49-F238E27FC236}">
-                <a16:creationId xmlns:a16="http://schemas.microsoft.com/office/drawing/2014/main" id="{B1601267-3BD0-422E-923E-8F05E6637371}"/>
+                <a16:creationId xmlns:a16="http://schemas.microsoft.com/office/drawing/2014/main" id="{20DE9198-7190-48BB-82B4-47F96B6E4E9B}"/>
               </a:ext>
             </a:extLst>
           </p:cNvPr>
@@ -19160,7 +19370,7 @@
           <p:cNvPr id="25" name="">
             <a:extLst xmlns:a="http://schemas.openxmlformats.org/drawingml/2006/main">
               <a:ext uri="{FF2B5EF4-FFF2-40B4-BE49-F238E27FC236}">
-                <a16:creationId xmlns:a16="http://schemas.microsoft.com/office/drawing/2014/main" id="{020F42D7-D086-43E4-967C-6879FE15044B}"/>
+                <a16:creationId xmlns:a16="http://schemas.microsoft.com/office/drawing/2014/main" id="{31C0A4D6-4F9E-48B2-BCD7-82CAF8F1FE55}"/>
               </a:ext>
             </a:extLst>
           </p:cNvPr>
@@ -19193,7 +19403,7 @@
           <p:cNvPr id="26" name="">
             <a:extLst xmlns:a="http://schemas.openxmlformats.org/drawingml/2006/main">
               <a:ext uri="{FF2B5EF4-FFF2-40B4-BE49-F238E27FC236}">
-                <a16:creationId xmlns:a16="http://schemas.microsoft.com/office/drawing/2014/main" id="{2FF46813-6360-4EBA-A6D5-78BC50425E21}"/>
+                <a16:creationId xmlns:a16="http://schemas.microsoft.com/office/drawing/2014/main" id="{FD4CA92A-E8C2-405C-A806-A0944444BE37}"/>
               </a:ext>
             </a:extLst>
           </p:cNvPr>
@@ -19228,7 +19438,7 @@
           <p:cNvPr id="27" name="">
             <a:extLst xmlns:a="http://schemas.openxmlformats.org/drawingml/2006/main">
               <a:ext uri="{FF2B5EF4-FFF2-40B4-BE49-F238E27FC236}">
-                <a16:creationId xmlns:a16="http://schemas.microsoft.com/office/drawing/2014/main" id="{B496C88D-C0A6-4781-9FCF-AA1F9F518B21}"/>
+                <a16:creationId xmlns:a16="http://schemas.microsoft.com/office/drawing/2014/main" id="{FC25C9C3-1303-41DF-8D99-3E8FE7961400}"/>
               </a:ext>
             </a:extLst>
           </p:cNvPr>
@@ -19284,7 +19494,7 @@
           <p:cNvPr id="28" name="">
             <a:extLst xmlns:a="http://schemas.openxmlformats.org/drawingml/2006/main">
               <a:ext uri="{FF2B5EF4-FFF2-40B4-BE49-F238E27FC236}">
-                <a16:creationId xmlns:a16="http://schemas.microsoft.com/office/drawing/2014/main" id="{C27CAD72-441B-4058-8525-6EEA8DEAFFF0}"/>
+                <a16:creationId xmlns:a16="http://schemas.microsoft.com/office/drawing/2014/main" id="{6E793B34-638A-4AF1-B50C-416C63629A2F}"/>
               </a:ext>
             </a:extLst>
           </p:cNvPr>
@@ -19340,7 +19550,7 @@
           <p:cNvPr id="29" name="">
             <a:extLst xmlns:a="http://schemas.openxmlformats.org/drawingml/2006/main">
               <a:ext uri="{FF2B5EF4-FFF2-40B4-BE49-F238E27FC236}">
-                <a16:creationId xmlns:a16="http://schemas.microsoft.com/office/drawing/2014/main" id="{B25232D2-9982-4A1D-AAE9-1292EC76B30D}"/>
+                <a16:creationId xmlns:a16="http://schemas.microsoft.com/office/drawing/2014/main" id="{567545C8-4786-459F-B6E4-7A5C62EE77F1}"/>
               </a:ext>
             </a:extLst>
           </p:cNvPr>
@@ -19373,7 +19583,7 @@
           <p:cNvPr id="30" name="">
             <a:extLst xmlns:a="http://schemas.openxmlformats.org/drawingml/2006/main">
               <a:ext uri="{FF2B5EF4-FFF2-40B4-BE49-F238E27FC236}">
-                <a16:creationId xmlns:a16="http://schemas.microsoft.com/office/drawing/2014/main" id="{0402F05E-1FDE-46B9-8CDE-6A681CE1C349}"/>
+                <a16:creationId xmlns:a16="http://schemas.microsoft.com/office/drawing/2014/main" id="{556735D6-EC71-4FB6-B016-324579FB94AA}"/>
               </a:ext>
             </a:extLst>
           </p:cNvPr>
@@ -19408,7 +19618,7 @@
           <p:cNvPr id="31" name="">
             <a:extLst xmlns:a="http://schemas.openxmlformats.org/drawingml/2006/main">
               <a:ext uri="{FF2B5EF4-FFF2-40B4-BE49-F238E27FC236}">
-                <a16:creationId xmlns:a16="http://schemas.microsoft.com/office/drawing/2014/main" id="{F2726AF0-EFCF-409B-9EEB-43A55B260B89}"/>
+                <a16:creationId xmlns:a16="http://schemas.microsoft.com/office/drawing/2014/main" id="{FFA9BD0F-C871-42D2-AC1D-9901D99818AA}"/>
               </a:ext>
             </a:extLst>
           </p:cNvPr>
@@ -19464,7 +19674,7 @@
           <p:cNvPr id="32" name="">
             <a:extLst xmlns:a="http://schemas.openxmlformats.org/drawingml/2006/main">
               <a:ext uri="{FF2B5EF4-FFF2-40B4-BE49-F238E27FC236}">
-                <a16:creationId xmlns:a16="http://schemas.microsoft.com/office/drawing/2014/main" id="{AAE9E576-F55E-4776-8107-9B3B6A4A1A40}"/>
+                <a16:creationId xmlns:a16="http://schemas.microsoft.com/office/drawing/2014/main" id="{6A9191FB-A111-417A-94E3-6AE5CD4B8969}"/>
               </a:ext>
             </a:extLst>
           </p:cNvPr>
@@ -19520,7 +19730,7 @@
           <p:cNvPr id="33" name="">
             <a:extLst xmlns:a="http://schemas.openxmlformats.org/drawingml/2006/main">
               <a:ext uri="{FF2B5EF4-FFF2-40B4-BE49-F238E27FC236}">
-                <a16:creationId xmlns:a16="http://schemas.microsoft.com/office/drawing/2014/main" id="{E186A6C6-C507-42D2-895F-9E2299CDB355}"/>
+                <a16:creationId xmlns:a16="http://schemas.microsoft.com/office/drawing/2014/main" id="{24AF18FF-828A-4AFD-8334-3FF7AEB4E3C7}"/>
               </a:ext>
             </a:extLst>
           </p:cNvPr>
@@ -19555,7 +19765,7 @@
           <p:cNvPr id="34" name="">
             <a:extLst xmlns:a="http://schemas.openxmlformats.org/drawingml/2006/main">
               <a:ext uri="{FF2B5EF4-FFF2-40B4-BE49-F238E27FC236}">
-                <a16:creationId xmlns:a16="http://schemas.microsoft.com/office/drawing/2014/main" id="{4605245A-E900-4508-8201-A82E27E453FF}"/>
+                <a16:creationId xmlns:a16="http://schemas.microsoft.com/office/drawing/2014/main" id="{B1DB0CE4-861B-4180-8AD4-B1EE078B780B}"/>
               </a:ext>
             </a:extLst>
           </p:cNvPr>
@@ -19611,7 +19821,7 @@
           <p:cNvPr id="35" name="">
             <a:extLst xmlns:a="http://schemas.openxmlformats.org/drawingml/2006/main">
               <a:ext uri="{FF2B5EF4-FFF2-40B4-BE49-F238E27FC236}">
-                <a16:creationId xmlns:a16="http://schemas.microsoft.com/office/drawing/2014/main" id="{01A92E78-D037-4713-B0D9-EC6A6F24F95A}"/>
+                <a16:creationId xmlns:a16="http://schemas.microsoft.com/office/drawing/2014/main" id="{72083CA8-67BC-465B-8C36-A6CEF76DC1C3}"/>
               </a:ext>
             </a:extLst>
           </p:cNvPr>
@@ -19667,7 +19877,7 @@
           <p:cNvPr id="36" name="">
             <a:extLst xmlns:a="http://schemas.openxmlformats.org/drawingml/2006/main">
               <a:ext uri="{FF2B5EF4-FFF2-40B4-BE49-F238E27FC236}">
-                <a16:creationId xmlns:a16="http://schemas.microsoft.com/office/drawing/2014/main" id="{38E911BB-C42C-4516-8C8F-3866A07E0E0D}"/>
+                <a16:creationId xmlns:a16="http://schemas.microsoft.com/office/drawing/2014/main" id="{E148C30A-11F4-47BD-BDF7-2FAE2F156C02}"/>
               </a:ext>
             </a:extLst>
           </p:cNvPr>
@@ -19721,7 +19931,7 @@
     </p:spTree>
     <p:extLst>
       <p:ext uri="{BB962C8B-B14F-4D97-AF65-F5344CB8AC3E}">
-        <p14:creationId xmlns:p14="http://schemas.microsoft.com/office/powerpoint/2010/main" val="350919228"/>
+        <p14:creationId xmlns:p14="http://schemas.microsoft.com/office/powerpoint/2010/main" val="2058526823"/>
       </p:ext>
     </p:extLst>
   </p:cSld>
@@ -19752,7 +19962,7 @@
           <p:cNvPr id="1" name="">
             <a:extLst xmlns:a="http://schemas.openxmlformats.org/drawingml/2006/main">
               <a:ext uri="{FF2B5EF4-FFF2-40B4-BE49-F238E27FC236}">
-                <a16:creationId xmlns:a16="http://schemas.microsoft.com/office/drawing/2014/main" id="{3B5592D5-839F-4D49-A228-9E1884091881}"/>
+                <a16:creationId xmlns:a16="http://schemas.microsoft.com/office/drawing/2014/main" id="{FFFE2385-2D96-438F-BE46-18E9AC95E9E4}"/>
               </a:ext>
             </a:extLst>
           </p:cNvPr>
@@ -19785,7 +19995,7 @@
           <p:cNvPr id="2" name="">
             <a:extLst xmlns:a="http://schemas.openxmlformats.org/drawingml/2006/main">
               <a:ext uri="{FF2B5EF4-FFF2-40B4-BE49-F238E27FC236}">
-                <a16:creationId xmlns:a16="http://schemas.microsoft.com/office/drawing/2014/main" id="{D0F21A60-C54D-4B36-9C56-86F487467B3F}"/>
+                <a16:creationId xmlns:a16="http://schemas.microsoft.com/office/drawing/2014/main" id="{62ECE4C3-B301-4967-8101-DB903154836A}"/>
               </a:ext>
             </a:extLst>
           </p:cNvPr>
@@ -19841,7 +20051,7 @@
           <p:cNvPr id="3" name="">
             <a:extLst xmlns:a="http://schemas.openxmlformats.org/drawingml/2006/main">
               <a:ext uri="{FF2B5EF4-FFF2-40B4-BE49-F238E27FC236}">
-                <a16:creationId xmlns:a16="http://schemas.microsoft.com/office/drawing/2014/main" id="{2E52B922-9987-4195-99D1-34FD8C51CD17}"/>
+                <a16:creationId xmlns:a16="http://schemas.microsoft.com/office/drawing/2014/main" id="{CBA37C21-A012-48A4-9B33-736B0709619E}"/>
               </a:ext>
             </a:extLst>
           </p:cNvPr>
@@ -19897,7 +20107,7 @@
           <p:cNvPr id="4" name="">
             <a:extLst xmlns:a="http://schemas.openxmlformats.org/drawingml/2006/main">
               <a:ext uri="{FF2B5EF4-FFF2-40B4-BE49-F238E27FC236}">
-                <a16:creationId xmlns:a16="http://schemas.microsoft.com/office/drawing/2014/main" id="{8183C93E-B838-43AD-8345-EE461DEC4FF0}"/>
+                <a16:creationId xmlns:a16="http://schemas.microsoft.com/office/drawing/2014/main" id="{B1C28784-270A-4B3D-8850-90C5ABEB7764}"/>
               </a:ext>
             </a:extLst>
           </p:cNvPr>
@@ -19953,7 +20163,7 @@
           <p:cNvPr id="5" name="">
             <a:extLst xmlns:a="http://schemas.openxmlformats.org/drawingml/2006/main">
               <a:ext uri="{FF2B5EF4-FFF2-40B4-BE49-F238E27FC236}">
-                <a16:creationId xmlns:a16="http://schemas.microsoft.com/office/drawing/2014/main" id="{0EEC3F69-8465-490F-99DE-16C7E202A014}"/>
+                <a16:creationId xmlns:a16="http://schemas.microsoft.com/office/drawing/2014/main" id="{C2D45C64-2666-461F-AE1E-6FEE0229563A}"/>
               </a:ext>
             </a:extLst>
           </p:cNvPr>
@@ -19988,7 +20198,7 @@
           <p:cNvPr id="6" name="">
             <a:extLst xmlns:a="http://schemas.openxmlformats.org/drawingml/2006/main">
               <a:ext uri="{FF2B5EF4-FFF2-40B4-BE49-F238E27FC236}">
-                <a16:creationId xmlns:a16="http://schemas.microsoft.com/office/drawing/2014/main" id="{CC31D48D-8008-4FE9-85A8-9055889EF69B}"/>
+                <a16:creationId xmlns:a16="http://schemas.microsoft.com/office/drawing/2014/main" id="{F83896B9-88DD-49EF-87A2-456DEC52491C}"/>
               </a:ext>
             </a:extLst>
           </p:cNvPr>
@@ -20021,7 +20231,7 @@
           <p:cNvPr id="7" name="">
             <a:extLst xmlns:a="http://schemas.openxmlformats.org/drawingml/2006/main">
               <a:ext uri="{FF2B5EF4-FFF2-40B4-BE49-F238E27FC236}">
-                <a16:creationId xmlns:a16="http://schemas.microsoft.com/office/drawing/2014/main" id="{BDDE589B-6BC4-4046-8EF9-9C85EF711D43}"/>
+                <a16:creationId xmlns:a16="http://schemas.microsoft.com/office/drawing/2014/main" id="{BD273ABD-F01E-485A-B3EF-B5FF06CA368C}"/>
               </a:ext>
             </a:extLst>
           </p:cNvPr>
@@ -20077,7 +20287,7 @@
           <p:cNvPr id="8" name="">
             <a:extLst xmlns:a="http://schemas.openxmlformats.org/drawingml/2006/main">
               <a:ext uri="{FF2B5EF4-FFF2-40B4-BE49-F238E27FC236}">
-                <a16:creationId xmlns:a16="http://schemas.microsoft.com/office/drawing/2014/main" id="{D444F95E-3B02-4C97-8DA9-F1284BA43DC4}"/>
+                <a16:creationId xmlns:a16="http://schemas.microsoft.com/office/drawing/2014/main" id="{5447CB2E-BA02-4289-BE16-804A29D7CE93}"/>
               </a:ext>
             </a:extLst>
           </p:cNvPr>
@@ -20133,7 +20343,7 @@
           <p:cNvPr id="9" name="">
             <a:extLst xmlns:a="http://schemas.openxmlformats.org/drawingml/2006/main">
               <a:ext uri="{FF2B5EF4-FFF2-40B4-BE49-F238E27FC236}">
-                <a16:creationId xmlns:a16="http://schemas.microsoft.com/office/drawing/2014/main" id="{12AD50CA-3326-4737-81DC-A41DDFDF94C1}"/>
+                <a16:creationId xmlns:a16="http://schemas.microsoft.com/office/drawing/2014/main" id="{3F449887-F106-4EBA-860A-1E820201A33E}"/>
               </a:ext>
             </a:extLst>
           </p:cNvPr>
@@ -20189,7 +20399,7 @@
           <p:cNvPr id="10" name="">
             <a:extLst xmlns:a="http://schemas.openxmlformats.org/drawingml/2006/main">
               <a:ext uri="{FF2B5EF4-FFF2-40B4-BE49-F238E27FC236}">
-                <a16:creationId xmlns:a16="http://schemas.microsoft.com/office/drawing/2014/main" id="{C73496EA-B8BC-47B4-B18A-B23A18C56E38}"/>
+                <a16:creationId xmlns:a16="http://schemas.microsoft.com/office/drawing/2014/main" id="{B19933B8-1105-42DB-9128-1694213148B6}"/>
               </a:ext>
             </a:extLst>
           </p:cNvPr>
@@ -20224,7 +20434,7 @@
           <p:cNvPr id="11" name="">
             <a:extLst xmlns:a="http://schemas.openxmlformats.org/drawingml/2006/main">
               <a:ext uri="{FF2B5EF4-FFF2-40B4-BE49-F238E27FC236}">
-                <a16:creationId xmlns:a16="http://schemas.microsoft.com/office/drawing/2014/main" id="{1774EB3B-845D-4E10-AE1D-73830A3D2CE5}"/>
+                <a16:creationId xmlns:a16="http://schemas.microsoft.com/office/drawing/2014/main" id="{BFEEAD04-8570-4513-B8FB-6114AF8187BE}"/>
               </a:ext>
             </a:extLst>
           </p:cNvPr>
@@ -20257,7 +20467,7 @@
           <p:cNvPr id="12" name="">
             <a:extLst xmlns:a="http://schemas.openxmlformats.org/drawingml/2006/main">
               <a:ext uri="{FF2B5EF4-FFF2-40B4-BE49-F238E27FC236}">
-                <a16:creationId xmlns:a16="http://schemas.microsoft.com/office/drawing/2014/main" id="{2FCD42D1-1860-4D79-817B-4A8CF1A6F340}"/>
+                <a16:creationId xmlns:a16="http://schemas.microsoft.com/office/drawing/2014/main" id="{4CA46FC2-4970-44FC-8244-FD3B677EF819}"/>
               </a:ext>
             </a:extLst>
           </p:cNvPr>
@@ -20313,7 +20523,7 @@
           <p:cNvPr id="13" name="">
             <a:extLst xmlns:a="http://schemas.openxmlformats.org/drawingml/2006/main">
               <a:ext uri="{FF2B5EF4-FFF2-40B4-BE49-F238E27FC236}">
-                <a16:creationId xmlns:a16="http://schemas.microsoft.com/office/drawing/2014/main" id="{3129A16A-04C0-4148-BF6D-A075CD0546B2}"/>
+                <a16:creationId xmlns:a16="http://schemas.microsoft.com/office/drawing/2014/main" id="{ACA1A5B9-5BC7-4B27-87C2-45BB6F159F73}"/>
               </a:ext>
             </a:extLst>
           </p:cNvPr>
@@ -20369,7 +20579,7 @@
           <p:cNvPr id="14" name="">
             <a:extLst xmlns:a="http://schemas.openxmlformats.org/drawingml/2006/main">
               <a:ext uri="{FF2B5EF4-FFF2-40B4-BE49-F238E27FC236}">
-                <a16:creationId xmlns:a16="http://schemas.microsoft.com/office/drawing/2014/main" id="{C8EAB172-F350-45B4-8129-3A0EC70E9418}"/>
+                <a16:creationId xmlns:a16="http://schemas.microsoft.com/office/drawing/2014/main" id="{FC754ECD-4BD0-4660-AD64-5DDBD4EB5FD9}"/>
               </a:ext>
             </a:extLst>
           </p:cNvPr>
@@ -20425,7 +20635,7 @@
           <p:cNvPr id="15" name="">
             <a:extLst xmlns:a="http://schemas.openxmlformats.org/drawingml/2006/main">
               <a:ext uri="{FF2B5EF4-FFF2-40B4-BE49-F238E27FC236}">
-                <a16:creationId xmlns:a16="http://schemas.microsoft.com/office/drawing/2014/main" id="{583EBB78-DE93-4214-9B0D-A343F065E64F}"/>
+                <a16:creationId xmlns:a16="http://schemas.microsoft.com/office/drawing/2014/main" id="{5A6B5FDC-A992-4CB8-997F-C2CD417667B3}"/>
               </a:ext>
             </a:extLst>
           </p:cNvPr>
@@ -20460,7 +20670,7 @@
           <p:cNvPr id="16" name="">
             <a:extLst xmlns:a="http://schemas.openxmlformats.org/drawingml/2006/main">
               <a:ext uri="{FF2B5EF4-FFF2-40B4-BE49-F238E27FC236}">
-                <a16:creationId xmlns:a16="http://schemas.microsoft.com/office/drawing/2014/main" id="{E2595EA8-69F8-4E29-B8BB-896A2865AA2F}"/>
+                <a16:creationId xmlns:a16="http://schemas.microsoft.com/office/drawing/2014/main" id="{1C6C2212-4B5C-4772-86F5-99B6C11A103D}"/>
               </a:ext>
             </a:extLst>
           </p:cNvPr>
@@ -20493,7 +20703,7 @@
           <p:cNvPr id="17" name="">
             <a:extLst xmlns:a="http://schemas.openxmlformats.org/drawingml/2006/main">
               <a:ext uri="{FF2B5EF4-FFF2-40B4-BE49-F238E27FC236}">
-                <a16:creationId xmlns:a16="http://schemas.microsoft.com/office/drawing/2014/main" id="{600291A9-0ADB-4819-BB46-ACE9DE4AD3EE}"/>
+                <a16:creationId xmlns:a16="http://schemas.microsoft.com/office/drawing/2014/main" id="{4F2B37F9-B363-48F7-84E9-4AB49211C2FF}"/>
               </a:ext>
             </a:extLst>
           </p:cNvPr>
@@ -20549,7 +20759,7 @@
           <p:cNvPr id="18" name="">
             <a:extLst xmlns:a="http://schemas.openxmlformats.org/drawingml/2006/main">
               <a:ext uri="{FF2B5EF4-FFF2-40B4-BE49-F238E27FC236}">
-                <a16:creationId xmlns:a16="http://schemas.microsoft.com/office/drawing/2014/main" id="{1053FC20-C1D6-4CB7-BA45-07D75F7CE724}"/>
+                <a16:creationId xmlns:a16="http://schemas.microsoft.com/office/drawing/2014/main" id="{A141B073-1DC1-4364-8CE9-CD44FC1B84AB}"/>
               </a:ext>
             </a:extLst>
           </p:cNvPr>
@@ -20605,7 +20815,7 @@
           <p:cNvPr id="19" name="">
             <a:extLst xmlns:a="http://schemas.openxmlformats.org/drawingml/2006/main">
               <a:ext uri="{FF2B5EF4-FFF2-40B4-BE49-F238E27FC236}">
-                <a16:creationId xmlns:a16="http://schemas.microsoft.com/office/drawing/2014/main" id="{73CE81D5-C287-4B4E-A17E-B63181FA8948}"/>
+                <a16:creationId xmlns:a16="http://schemas.microsoft.com/office/drawing/2014/main" id="{A4DE186D-05E2-4C0F-82C6-658E8CE1EF10}"/>
               </a:ext>
             </a:extLst>
           </p:cNvPr>
@@ -20661,7 +20871,7 @@
           <p:cNvPr id="20" name="">
             <a:extLst xmlns:a="http://schemas.openxmlformats.org/drawingml/2006/main">
               <a:ext uri="{FF2B5EF4-FFF2-40B4-BE49-F238E27FC236}">
-                <a16:creationId xmlns:a16="http://schemas.microsoft.com/office/drawing/2014/main" id="{B3131779-B764-4385-BF26-829CEAD0787B}"/>
+                <a16:creationId xmlns:a16="http://schemas.microsoft.com/office/drawing/2014/main" id="{4D3EB657-8AED-44A3-A8C3-324528C94242}"/>
               </a:ext>
             </a:extLst>
           </p:cNvPr>
@@ -20696,7 +20906,7 @@
           <p:cNvPr id="21" name="">
             <a:extLst xmlns:a="http://schemas.openxmlformats.org/drawingml/2006/main">
               <a:ext uri="{FF2B5EF4-FFF2-40B4-BE49-F238E27FC236}">
-                <a16:creationId xmlns:a16="http://schemas.microsoft.com/office/drawing/2014/main" id="{36431215-3C3F-40F9-9426-4D621B232190}"/>
+                <a16:creationId xmlns:a16="http://schemas.microsoft.com/office/drawing/2014/main" id="{E501ECAF-5FE7-470F-93ED-F7105454B246}"/>
               </a:ext>
             </a:extLst>
           </p:cNvPr>
@@ -20752,7 +20962,7 @@
           <p:cNvPr id="22" name="">
             <a:extLst xmlns:a="http://schemas.openxmlformats.org/drawingml/2006/main">
               <a:ext uri="{FF2B5EF4-FFF2-40B4-BE49-F238E27FC236}">
-                <a16:creationId xmlns:a16="http://schemas.microsoft.com/office/drawing/2014/main" id="{906A5671-EAAD-491E-8423-2E8A52678EFC}"/>
+                <a16:creationId xmlns:a16="http://schemas.microsoft.com/office/drawing/2014/main" id="{7C334AD2-2254-40A8-A16D-BF4DB569CA46}"/>
               </a:ext>
             </a:extLst>
           </p:cNvPr>
@@ -20808,7 +21018,7 @@
           <p:cNvPr id="23" name="">
             <a:extLst xmlns:a="http://schemas.openxmlformats.org/drawingml/2006/main">
               <a:ext uri="{FF2B5EF4-FFF2-40B4-BE49-F238E27FC236}">
-                <a16:creationId xmlns:a16="http://schemas.microsoft.com/office/drawing/2014/main" id="{B74EF39C-ECD6-443C-BA23-5B0AA922A820}"/>
+                <a16:creationId xmlns:a16="http://schemas.microsoft.com/office/drawing/2014/main" id="{607CDD6A-AC1B-4ECC-897A-13014DE9ED7D}"/>
               </a:ext>
             </a:extLst>
           </p:cNvPr>
@@ -20862,7 +21072,7 @@
     </p:spTree>
     <p:extLst>
       <p:ext uri="{BB962C8B-B14F-4D97-AF65-F5344CB8AC3E}">
-        <p14:creationId xmlns:p14="http://schemas.microsoft.com/office/powerpoint/2010/main" val="557187006"/>
+        <p14:creationId xmlns:p14="http://schemas.microsoft.com/office/powerpoint/2010/main" val="765868723"/>
       </p:ext>
     </p:extLst>
   </p:cSld>

</xml_diff>